<commit_message>
Add business value and quality asset flywheel
</commit_message>
<xml_diff>
--- a/submission/ChronosFix_初赛方案.pptx
+++ b/submission/ChronosFix_初赛方案.pptx
@@ -2,25 +2,26 @@
 <file path=ppt/presentation.xml><?xml version="1.0" encoding="utf-8"?>
 <p:presentation xmlns:p="http://schemas.openxmlformats.org/presentationml/2006/main">
   <p:sldMasterIdLst>
-    <p:sldMasterId xmlns:r="http://schemas.openxmlformats.org/officeDocument/2006/relationships" id="2147483648" r:id="Rd660c99f11b749ec"/>
+    <p:sldMasterId xmlns:r="http://schemas.openxmlformats.org/officeDocument/2006/relationships" id="2147483648" r:id="R85bebd38c72c4018"/>
   </p:sldMasterIdLst>
   <p:notesMasterIdLst>
-    <p:notesMasterId xmlns:r="http://schemas.openxmlformats.org/officeDocument/2006/relationships" r:id="Rd08eac36097b4a7e"/>
+    <p:notesMasterId xmlns:r="http://schemas.openxmlformats.org/officeDocument/2006/relationships" r:id="R23d1637a1dbb4bb1"/>
   </p:notesMasterIdLst>
   <p:sldIdLst>
-    <p:sldId xmlns:r="http://schemas.openxmlformats.org/officeDocument/2006/relationships" id="256" r:id="R819bcb6f78854bf5"/>
-    <p:sldId xmlns:r="http://schemas.openxmlformats.org/officeDocument/2006/relationships" id="257" r:id="R80a93fb60c4c413c"/>
-    <p:sldId xmlns:r="http://schemas.openxmlformats.org/officeDocument/2006/relationships" id="258" r:id="R4a30d6407f3c40f0"/>
-    <p:sldId xmlns:r="http://schemas.openxmlformats.org/officeDocument/2006/relationships" id="259" r:id="R68dde4f980b04b37"/>
-    <p:sldId xmlns:r="http://schemas.openxmlformats.org/officeDocument/2006/relationships" id="260" r:id="R458d016aec394dfa"/>
-    <p:sldId xmlns:r="http://schemas.openxmlformats.org/officeDocument/2006/relationships" id="261" r:id="R142b988fbdea41ab"/>
-    <p:sldId xmlns:r="http://schemas.openxmlformats.org/officeDocument/2006/relationships" id="262" r:id="Red261158872540ff"/>
-    <p:sldId xmlns:r="http://schemas.openxmlformats.org/officeDocument/2006/relationships" id="263" r:id="R6fe229fdcce245d7"/>
-    <p:sldId xmlns:r="http://schemas.openxmlformats.org/officeDocument/2006/relationships" id="264" r:id="Ra6ab0c72193b46c7"/>
-    <p:sldId xmlns:r="http://schemas.openxmlformats.org/officeDocument/2006/relationships" id="265" r:id="R3ea7e9edbd224f66"/>
-    <p:sldId xmlns:r="http://schemas.openxmlformats.org/officeDocument/2006/relationships" id="266" r:id="Rd9265183baab405e"/>
-    <p:sldId xmlns:r="http://schemas.openxmlformats.org/officeDocument/2006/relationships" id="267" r:id="R956891da53514a16"/>
-    <p:sldId xmlns:r="http://schemas.openxmlformats.org/officeDocument/2006/relationships" id="268" r:id="Rc7dfeb1bb81d4d6f"/>
+    <p:sldId xmlns:r="http://schemas.openxmlformats.org/officeDocument/2006/relationships" id="256" r:id="R14e58e3558a04178"/>
+    <p:sldId xmlns:r="http://schemas.openxmlformats.org/officeDocument/2006/relationships" id="257" r:id="R738df538193d4812"/>
+    <p:sldId xmlns:r="http://schemas.openxmlformats.org/officeDocument/2006/relationships" id="258" r:id="R2c67afc25d8b430c"/>
+    <p:sldId xmlns:r="http://schemas.openxmlformats.org/officeDocument/2006/relationships" id="259" r:id="Rc432b64ff05b43fe"/>
+    <p:sldId xmlns:r="http://schemas.openxmlformats.org/officeDocument/2006/relationships" id="260" r:id="Rae77327654064de8"/>
+    <p:sldId xmlns:r="http://schemas.openxmlformats.org/officeDocument/2006/relationships" id="261" r:id="R73d3182446af4793"/>
+    <p:sldId xmlns:r="http://schemas.openxmlformats.org/officeDocument/2006/relationships" id="262" r:id="Re766f9d399ed405e"/>
+    <p:sldId xmlns:r="http://schemas.openxmlformats.org/officeDocument/2006/relationships" id="263" r:id="Re88d362191d24261"/>
+    <p:sldId xmlns:r="http://schemas.openxmlformats.org/officeDocument/2006/relationships" id="264" r:id="Rbe4ff42b1f964175"/>
+    <p:sldId xmlns:r="http://schemas.openxmlformats.org/officeDocument/2006/relationships" id="265" r:id="R347bdd5faceb4840"/>
+    <p:sldId xmlns:r="http://schemas.openxmlformats.org/officeDocument/2006/relationships" id="266" r:id="Rdef12b4c72fe4b8b"/>
+    <p:sldId xmlns:r="http://schemas.openxmlformats.org/officeDocument/2006/relationships" id="267" r:id="R4c5500fe5fd746f6"/>
+    <p:sldId xmlns:r="http://schemas.openxmlformats.org/officeDocument/2006/relationships" id="268" r:id="R4a377b5c9e474bfe"/>
+    <p:sldId xmlns:r="http://schemas.openxmlformats.org/officeDocument/2006/relationships" id="269" r:id="R0f0b9f9476de4fe9"/>
   </p:sldIdLst>
   <p:sldSz cx="12192000" cy="6858000"/>
   <p:notesSz cx="6858000" cy="9144000"/>
@@ -779,6 +780,86 @@
           </a:p>
           <a:p xmlns:a="http://schemas.openxmlformats.org/drawingml/2006/main">
             <a:r>
+              <a:t>docs/business-value.md</a:t>
+            </a:r>
+          </a:p>
+          <a:p xmlns:a="http://schemas.openxmlformats.org/drawingml/2006/main">
+            <a:r>
+              <a:t>README.md</a:t>
+            </a:r>
+          </a:p>
+        </p:txBody>
+      </p:sp>
+      <p:sp>
+        <p:nvSpPr>
+          <p:cNvPr id="4" name="Slide Number Placeholder 3"/>
+          <p:cNvSpPr>
+            <a:spLocks xmlns:a="http://schemas.openxmlformats.org/drawingml/2006/main" noGrp="1"/>
+          </p:cNvSpPr>
+          <p:nvPr>
+            <p:ph type="sldNum" idx="5"/>
+          </p:nvPr>
+        </p:nvSpPr>
+        <p:spPr/>
+        <p:txBody>
+          <a:bodyPr xmlns:a="http://schemas.openxmlformats.org/drawingml/2006/main"/>
+          <a:lstStyle xmlns:a="http://schemas.openxmlformats.org/drawingml/2006/main"/>
+          <a:p xmlns:a="http://schemas.openxmlformats.org/drawingml/2006/main"/>
+        </p:txBody>
+      </p:sp>
+    </p:spTree>
+  </p:cSld>
+  <p:clrMapOvr>
+    <a:masterClrMapping xmlns:a="http://schemas.openxmlformats.org/drawingml/2006/main"/>
+  </p:clrMapOvr>
+</p:notes>
+</file>
+
+<file path=ppt/notesSlides/notesSlide14.xml><?xml version="1.0" encoding="utf-8"?>
+<p:notes xmlns:p="http://schemas.openxmlformats.org/presentationml/2006/main">
+  <p:cSld>
+    <p:spTree>
+      <p:nvGrpSpPr>
+        <p:cNvPr id="1" name=""/>
+        <p:cNvGrpSpPr/>
+        <p:nvPr/>
+      </p:nvGrpSpPr>
+      <p:grpSpPr>
+        <a:xfrm xmlns:a="http://schemas.openxmlformats.org/drawingml/2006/main"/>
+      </p:grpSpPr>
+      <p:sp>
+        <p:nvSpPr>
+          <p:cNvPr id="2" name="Slide Image Placeholder 1"/>
+          <p:cNvSpPr>
+            <a:spLocks xmlns:a="http://schemas.openxmlformats.org/drawingml/2006/main" noGrp="1"/>
+          </p:cNvSpPr>
+          <p:nvPr>
+            <p:ph type="sldImg" idx="0"/>
+          </p:nvPr>
+        </p:nvSpPr>
+        <p:spPr/>
+      </p:sp>
+      <p:sp>
+        <p:nvSpPr>
+          <p:cNvPr id="3" name="Notes Placeholder 2"/>
+          <p:cNvSpPr>
+            <a:spLocks xmlns:a="http://schemas.openxmlformats.org/drawingml/2006/main" noGrp="1"/>
+          </p:cNvSpPr>
+          <p:nvPr>
+            <p:ph type="body" idx="1"/>
+          </p:nvPr>
+        </p:nvSpPr>
+        <p:spPr/>
+        <p:txBody>
+          <a:bodyPr xmlns:a="http://schemas.openxmlformats.org/drawingml/2006/main"/>
+          <a:lstStyle xmlns:a="http://schemas.openxmlformats.org/drawingml/2006/main"/>
+          <a:p xmlns:a="http://schemas.openxmlformats.org/drawingml/2006/main">
+            <a:r>
+              <a:t>[Sources]</a:t>
+            </a:r>
+          </a:p>
+          <a:p xmlns:a="http://schemas.openxmlformats.org/drawingml/2006/main">
+            <a:r>
               <a:t>README.md</a:t>
             </a:r>
           </a:p>
@@ -1487,7 +1568,7 @@
   </p:cSld>
   <p:clrMap bg1="lt1" tx1="dk1" bg2="lt2" tx2="dk2" accent1="accent1" accent2="accent2" accent3="accent3" accent4="accent4" accent5="accent5" accent6="accent6" hlink="hlink" folHlink="folHlink"/>
   <p:sldLayoutIdLst>
-    <p:sldLayoutId xmlns:r="http://schemas.openxmlformats.org/officeDocument/2006/relationships" id="2147483649" r:id="R15c5e0636af4468a"/>
+    <p:sldLayoutId xmlns:r="http://schemas.openxmlformats.org/officeDocument/2006/relationships" id="2147483649" r:id="R9357c24393774605"/>
   </p:sldLayoutIdLst>
   <p:txStyles>
     <p:titleStyle>
@@ -2035,10 +2116,10 @@
       </p:grpSpPr>
       <p:sp>
         <p:nvSpPr>
-          <p:cNvPr id="19" name="">
-            <a:extLst xmlns:a="http://schemas.openxmlformats.org/drawingml/2006/main">
-              <a:ext uri="{FF2B5EF4-FFF2-40B4-BE49-F238E27FC236}">
-                <a16:creationId xmlns:a16="http://schemas.microsoft.com/office/drawing/2014/main" id="{E4D058E4-83FB-46F4-ACC0-2A7BCBCD9B69}"/>
+          <p:cNvPr id="20" name="">
+            <a:extLst xmlns:a="http://schemas.openxmlformats.org/drawingml/2006/main">
+              <a:ext uri="{FF2B5EF4-FFF2-40B4-BE49-F238E27FC236}">
+                <a16:creationId xmlns:a16="http://schemas.microsoft.com/office/drawing/2014/main" id="{A1E90E46-F12C-44B0-A39B-C8491022D221}"/>
               </a:ext>
             </a:extLst>
           </p:cNvPr>
@@ -2088,7 +2169,7 @@
           <p:cNvPr id="2" name="">
             <a:extLst xmlns:a="http://schemas.openxmlformats.org/drawingml/2006/main">
               <a:ext uri="{FF2B5EF4-FFF2-40B4-BE49-F238E27FC236}">
-                <a16:creationId xmlns:a16="http://schemas.microsoft.com/office/drawing/2014/main" id="{FF822979-C072-4993-8A47-25D2CC226929}"/>
+                <a16:creationId xmlns:a16="http://schemas.microsoft.com/office/drawing/2014/main" id="{D9729217-5F6B-4546-8951-CD788D5F91D1}"/>
               </a:ext>
             </a:extLst>
           </p:cNvPr>
@@ -2138,7 +2219,7 @@
           <p:cNvPr id="3" name="">
             <a:extLst xmlns:a="http://schemas.openxmlformats.org/drawingml/2006/main">
               <a:ext uri="{FF2B5EF4-FFF2-40B4-BE49-F238E27FC236}">
-                <a16:creationId xmlns:a16="http://schemas.microsoft.com/office/drawing/2014/main" id="{0BDDC0E0-2A57-4624-8794-C4DC3AB9FF6D}"/>
+                <a16:creationId xmlns:a16="http://schemas.microsoft.com/office/drawing/2014/main" id="{869F7CF6-F340-476F-8BDD-7012B1D1C715}"/>
               </a:ext>
             </a:extLst>
           </p:cNvPr>
@@ -2188,19 +2269,19 @@
           <p:cNvPr id="4" name="">
             <a:extLst xmlns:a="http://schemas.openxmlformats.org/drawingml/2006/main">
               <a:ext uri="{FF2B5EF4-FFF2-40B4-BE49-F238E27FC236}">
-                <a16:creationId xmlns:a16="http://schemas.microsoft.com/office/drawing/2014/main" id="{F0D5AD53-FD59-43FF-B845-B60290F0B5FC}"/>
-              </a:ext>
-            </a:extLst>
-          </p:cNvPr>
-          <p:cNvSpPr>
-            <a:spLocks xmlns:a="http://schemas.openxmlformats.org/drawingml/2006/main" noGrp="1"/>
-          </p:cNvSpPr>
-          <p:nvPr/>
-        </p:nvSpPr>
-        <p:spPr>
-          <a:xfrm xmlns:a="http://schemas.openxmlformats.org/drawingml/2006/main">
-            <a:off x="609600" y="3581400"/>
-            <a:ext cx="7810500" cy="400050"/>
+                <a16:creationId xmlns:a16="http://schemas.microsoft.com/office/drawing/2014/main" id="{2DA763BE-7A9B-4A19-9697-6A4D77CC4172}"/>
+              </a:ext>
+            </a:extLst>
+          </p:cNvPr>
+          <p:cNvSpPr>
+            <a:spLocks xmlns:a="http://schemas.openxmlformats.org/drawingml/2006/main" noGrp="1"/>
+          </p:cNvSpPr>
+          <p:nvPr/>
+        </p:nvSpPr>
+        <p:spPr>
+          <a:xfrm xmlns:a="http://schemas.openxmlformats.org/drawingml/2006/main">
+            <a:off x="609600" y="3219450"/>
+            <a:ext cx="6858000" cy="419100"/>
           </a:xfrm>
           <a:prstGeom xmlns:a="http://schemas.openxmlformats.org/drawingml/2006/main" prst="rect">
             <a:avLst/>
@@ -2216,29 +2297,79 @@
           <a:lstStyle xmlns:a="http://schemas.openxmlformats.org/drawingml/2006/main"/>
           <a:p xmlns:a="http://schemas.openxmlformats.org/drawingml/2006/main">
             <a:pPr algn="l">
-              <a:defRPr sz="1800" b="0">
+              <a:defRPr sz="2250" b="1">
+                <a:solidFill>
+                  <a:srgbClr val="14B8A6"/>
+                </a:solidFill>
+              </a:defRPr>
+            </a:pPr>
+            <a:r>
+              <a:rPr sz="2250" b="1">
+                <a:solidFill>
+                  <a:srgbClr val="14B8A6"/>
+                </a:solidFill>
+              </a:rPr>
+              <a:t>研发质量资产平台</a:t>
+            </a:r>
+          </a:p>
+        </p:txBody>
+      </p:sp>
+      <p:sp>
+        <p:nvSpPr>
+          <p:cNvPr id="5" name="">
+            <a:extLst xmlns:a="http://schemas.openxmlformats.org/drawingml/2006/main">
+              <a:ext uri="{FF2B5EF4-FFF2-40B4-BE49-F238E27FC236}">
+                <a16:creationId xmlns:a16="http://schemas.microsoft.com/office/drawing/2014/main" id="{0771E8D6-7283-4B60-953A-62EDC1BB82F8}"/>
+              </a:ext>
+            </a:extLst>
+          </p:cNvPr>
+          <p:cNvSpPr>
+            <a:spLocks xmlns:a="http://schemas.openxmlformats.org/drawingml/2006/main" noGrp="1"/>
+          </p:cNvSpPr>
+          <p:nvPr/>
+        </p:nvSpPr>
+        <p:spPr>
+          <a:xfrm xmlns:a="http://schemas.openxmlformats.org/drawingml/2006/main">
+            <a:off x="609600" y="3810000"/>
+            <a:ext cx="8191500" cy="400050"/>
+          </a:xfrm>
+          <a:prstGeom xmlns:a="http://schemas.openxmlformats.org/drawingml/2006/main" prst="rect">
+            <a:avLst/>
+          </a:prstGeom>
+          <a:noFill xmlns:a="http://schemas.openxmlformats.org/drawingml/2006/main"/>
+          <a:ln xmlns:a="http://schemas.openxmlformats.org/drawingml/2006/main" w="0">
+            <a:noFill/>
+            <a:prstDash val="solid"/>
+          </a:ln>
+        </p:spPr>
+        <p:txBody>
+          <a:bodyPr xmlns:a="http://schemas.openxmlformats.org/drawingml/2006/main"/>
+          <a:lstStyle xmlns:a="http://schemas.openxmlformats.org/drawingml/2006/main"/>
+          <a:p xmlns:a="http://schemas.openxmlformats.org/drawingml/2006/main">
+            <a:pPr algn="l">
+              <a:defRPr sz="1725" b="0">
                 <a:solidFill>
                   <a:srgbClr val="D7E3F5"/>
                 </a:solidFill>
               </a:defRPr>
             </a:pPr>
             <a:r>
-              <a:rPr sz="1800" b="0">
+              <a:rPr sz="1725" b="0">
                 <a:solidFill>
                   <a:srgbClr val="D7E3F5"/>
                 </a:solidFill>
               </a:rPr>
-              <a:t>让补丁带着因果证明、故障基因验证和证据护照进入发布</a:t>
-            </a:r>
-          </a:p>
-        </p:txBody>
-      </p:sp>
-      <p:sp>
-        <p:nvSpPr>
-          <p:cNvPr id="5" name="">
-            <a:extLst xmlns:a="http://schemas.openxmlformats.org/drawingml/2006/main">
-              <a:ext uri="{FF2B5EF4-FFF2-40B4-BE49-F238E27FC236}">
-                <a16:creationId xmlns:a16="http://schemas.microsoft.com/office/drawing/2014/main" id="{B052DFAD-05B7-435D-84DA-A683E5824614}"/>
+              <a:t>让每次事故沉淀为可复用 Skill、故障基因包和可审计证据护照</a:t>
+            </a:r>
+          </a:p>
+        </p:txBody>
+      </p:sp>
+      <p:sp>
+        <p:nvSpPr>
+          <p:cNvPr id="6" name="">
+            <a:extLst xmlns:a="http://schemas.openxmlformats.org/drawingml/2006/main">
+              <a:ext uri="{FF2B5EF4-FFF2-40B4-BE49-F238E27FC236}">
+                <a16:creationId xmlns:a16="http://schemas.microsoft.com/office/drawing/2014/main" id="{FEC864C0-AF24-4FEA-ADCC-DF2476A9DE90}"/>
               </a:ext>
             </a:extLst>
           </p:cNvPr>
@@ -2285,10 +2416,10 @@
       </p:sp>
       <p:sp>
         <p:nvSpPr>
-          <p:cNvPr id="6" name="">
-            <a:extLst xmlns:a="http://schemas.openxmlformats.org/drawingml/2006/main">
-              <a:ext uri="{FF2B5EF4-FFF2-40B4-BE49-F238E27FC236}">
-                <a16:creationId xmlns:a16="http://schemas.microsoft.com/office/drawing/2014/main" id="{EE7D629F-46CB-4A9F-ACE9-831597E7B2D0}"/>
+          <p:cNvPr id="7" name="">
+            <a:extLst xmlns:a="http://schemas.openxmlformats.org/drawingml/2006/main">
+              <a:ext uri="{FF2B5EF4-FFF2-40B4-BE49-F238E27FC236}">
+                <a16:creationId xmlns:a16="http://schemas.microsoft.com/office/drawing/2014/main" id="{00C2A654-8AA4-4D7A-A432-BCF64BA20E64}"/>
               </a:ext>
             </a:extLst>
           </p:cNvPr>
@@ -2320,10 +2451,10 @@
       </p:sp>
       <p:sp>
         <p:nvSpPr>
-          <p:cNvPr id="7" name="">
-            <a:extLst xmlns:a="http://schemas.openxmlformats.org/drawingml/2006/main">
-              <a:ext uri="{FF2B5EF4-FFF2-40B4-BE49-F238E27FC236}">
-                <a16:creationId xmlns:a16="http://schemas.microsoft.com/office/drawing/2014/main" id="{394C9A54-DB01-4688-8C4C-0FD2812B198C}"/>
+          <p:cNvPr id="8" name="">
+            <a:extLst xmlns:a="http://schemas.openxmlformats.org/drawingml/2006/main">
+              <a:ext uri="{FF2B5EF4-FFF2-40B4-BE49-F238E27FC236}">
+                <a16:creationId xmlns:a16="http://schemas.microsoft.com/office/drawing/2014/main" id="{6F9B7F4B-8E0E-4FE4-B25A-CAC3B5D4E4E9}"/>
               </a:ext>
             </a:extLst>
           </p:cNvPr>
@@ -2370,10 +2501,10 @@
       </p:sp>
       <p:sp>
         <p:nvSpPr>
-          <p:cNvPr id="8" name="">
-            <a:extLst xmlns:a="http://schemas.openxmlformats.org/drawingml/2006/main">
-              <a:ext uri="{FF2B5EF4-FFF2-40B4-BE49-F238E27FC236}">
-                <a16:creationId xmlns:a16="http://schemas.microsoft.com/office/drawing/2014/main" id="{233D638B-9E73-4A2C-869A-CA7933937260}"/>
+          <p:cNvPr id="9" name="">
+            <a:extLst xmlns:a="http://schemas.openxmlformats.org/drawingml/2006/main">
+              <a:ext uri="{FF2B5EF4-FFF2-40B4-BE49-F238E27FC236}">
+                <a16:creationId xmlns:a16="http://schemas.microsoft.com/office/drawing/2014/main" id="{5D76BC99-04C0-4C20-B3BA-E0189CA12659}"/>
               </a:ext>
             </a:extLst>
           </p:cNvPr>
@@ -2405,10 +2536,10 @@
       </p:sp>
       <p:sp>
         <p:nvSpPr>
-          <p:cNvPr id="9" name="">
-            <a:extLst xmlns:a="http://schemas.openxmlformats.org/drawingml/2006/main">
-              <a:ext uri="{FF2B5EF4-FFF2-40B4-BE49-F238E27FC236}">
-                <a16:creationId xmlns:a16="http://schemas.microsoft.com/office/drawing/2014/main" id="{1592FC9C-215A-4236-BF9F-822FC2B7B548}"/>
+          <p:cNvPr id="10" name="">
+            <a:extLst xmlns:a="http://schemas.openxmlformats.org/drawingml/2006/main">
+              <a:ext uri="{FF2B5EF4-FFF2-40B4-BE49-F238E27FC236}">
+                <a16:creationId xmlns:a16="http://schemas.microsoft.com/office/drawing/2014/main" id="{B0C00352-2F63-4498-B395-0E5E8E21248C}"/>
               </a:ext>
             </a:extLst>
           </p:cNvPr>
@@ -2455,10 +2586,10 @@
       </p:sp>
       <p:sp>
         <p:nvSpPr>
-          <p:cNvPr id="10" name="">
-            <a:extLst xmlns:a="http://schemas.openxmlformats.org/drawingml/2006/main">
-              <a:ext uri="{FF2B5EF4-FFF2-40B4-BE49-F238E27FC236}">
-                <a16:creationId xmlns:a16="http://schemas.microsoft.com/office/drawing/2014/main" id="{06453ED3-45E9-47EC-A164-110CEACF44E7}"/>
+          <p:cNvPr id="11" name="">
+            <a:extLst xmlns:a="http://schemas.openxmlformats.org/drawingml/2006/main">
+              <a:ext uri="{FF2B5EF4-FFF2-40B4-BE49-F238E27FC236}">
+                <a16:creationId xmlns:a16="http://schemas.microsoft.com/office/drawing/2014/main" id="{5AAD87A3-1847-4247-A14F-1A6F7CB127C3}"/>
               </a:ext>
             </a:extLst>
           </p:cNvPr>
@@ -2490,10 +2621,10 @@
       </p:sp>
       <p:sp>
         <p:nvSpPr>
-          <p:cNvPr id="11" name="">
-            <a:extLst xmlns:a="http://schemas.openxmlformats.org/drawingml/2006/main">
-              <a:ext uri="{FF2B5EF4-FFF2-40B4-BE49-F238E27FC236}">
-                <a16:creationId xmlns:a16="http://schemas.microsoft.com/office/drawing/2014/main" id="{01C76B7E-C683-4BFC-900E-75EC50FE2C4C}"/>
+          <p:cNvPr id="12" name="">
+            <a:extLst xmlns:a="http://schemas.openxmlformats.org/drawingml/2006/main">
+              <a:ext uri="{FF2B5EF4-FFF2-40B4-BE49-F238E27FC236}">
+                <a16:creationId xmlns:a16="http://schemas.microsoft.com/office/drawing/2014/main" id="{067D71EF-1127-47D7-A6E0-C01FC8832A45}"/>
               </a:ext>
             </a:extLst>
           </p:cNvPr>
@@ -2540,10 +2671,10 @@
       </p:sp>
       <p:sp>
         <p:nvSpPr>
-          <p:cNvPr id="12" name="">
-            <a:extLst xmlns:a="http://schemas.openxmlformats.org/drawingml/2006/main">
-              <a:ext uri="{FF2B5EF4-FFF2-40B4-BE49-F238E27FC236}">
-                <a16:creationId xmlns:a16="http://schemas.microsoft.com/office/drawing/2014/main" id="{E127F3E1-6AEC-42DA-865F-D79203FED7C6}"/>
+          <p:cNvPr id="13" name="">
+            <a:extLst xmlns:a="http://schemas.openxmlformats.org/drawingml/2006/main">
+              <a:ext uri="{FF2B5EF4-FFF2-40B4-BE49-F238E27FC236}">
+                <a16:creationId xmlns:a16="http://schemas.microsoft.com/office/drawing/2014/main" id="{31068AE3-EE4F-4633-AAF9-08892DC2E052}"/>
               </a:ext>
             </a:extLst>
           </p:cNvPr>
@@ -2575,10 +2706,10 @@
       </p:sp>
       <p:sp>
         <p:nvSpPr>
-          <p:cNvPr id="13" name="">
-            <a:extLst xmlns:a="http://schemas.openxmlformats.org/drawingml/2006/main">
-              <a:ext uri="{FF2B5EF4-FFF2-40B4-BE49-F238E27FC236}">
-                <a16:creationId xmlns:a16="http://schemas.microsoft.com/office/drawing/2014/main" id="{99ADC092-7E41-4629-95E9-CC45D5506F09}"/>
+          <p:cNvPr id="14" name="">
+            <a:extLst xmlns:a="http://schemas.openxmlformats.org/drawingml/2006/main">
+              <a:ext uri="{FF2B5EF4-FFF2-40B4-BE49-F238E27FC236}">
+                <a16:creationId xmlns:a16="http://schemas.microsoft.com/office/drawing/2014/main" id="{2E5FDF02-4077-4B20-B265-AD75718B99E1}"/>
               </a:ext>
             </a:extLst>
           </p:cNvPr>
@@ -2625,10 +2756,10 @@
       </p:sp>
       <p:sp>
         <p:nvSpPr>
-          <p:cNvPr id="14" name="">
-            <a:extLst xmlns:a="http://schemas.openxmlformats.org/drawingml/2006/main">
-              <a:ext uri="{FF2B5EF4-FFF2-40B4-BE49-F238E27FC236}">
-                <a16:creationId xmlns:a16="http://schemas.microsoft.com/office/drawing/2014/main" id="{DE167803-85E2-4C4F-B0F2-6E33928E0217}"/>
+          <p:cNvPr id="15" name="">
+            <a:extLst xmlns:a="http://schemas.openxmlformats.org/drawingml/2006/main">
+              <a:ext uri="{FF2B5EF4-FFF2-40B4-BE49-F238E27FC236}">
+                <a16:creationId xmlns:a16="http://schemas.microsoft.com/office/drawing/2014/main" id="{9C10621E-B161-4697-9F52-6FAB490F93C6}"/>
               </a:ext>
             </a:extLst>
           </p:cNvPr>
@@ -2660,10 +2791,10 @@
       </p:sp>
       <p:sp>
         <p:nvSpPr>
-          <p:cNvPr id="15" name="">
-            <a:extLst xmlns:a="http://schemas.openxmlformats.org/drawingml/2006/main">
-              <a:ext uri="{FF2B5EF4-FFF2-40B4-BE49-F238E27FC236}">
-                <a16:creationId xmlns:a16="http://schemas.microsoft.com/office/drawing/2014/main" id="{C1F0FE9B-FC99-4B20-A9FB-74CBFB49FDA4}"/>
+          <p:cNvPr id="16" name="">
+            <a:extLst xmlns:a="http://schemas.openxmlformats.org/drawingml/2006/main">
+              <a:ext uri="{FF2B5EF4-FFF2-40B4-BE49-F238E27FC236}">
+                <a16:creationId xmlns:a16="http://schemas.microsoft.com/office/drawing/2014/main" id="{53AA6741-7A9B-4BC4-A319-788424D0A172}"/>
               </a:ext>
             </a:extLst>
           </p:cNvPr>
@@ -2710,10 +2841,10 @@
       </p:sp>
       <p:sp>
         <p:nvSpPr>
-          <p:cNvPr id="16" name="">
-            <a:extLst xmlns:a="http://schemas.openxmlformats.org/drawingml/2006/main">
-              <a:ext uri="{FF2B5EF4-FFF2-40B4-BE49-F238E27FC236}">
-                <a16:creationId xmlns:a16="http://schemas.microsoft.com/office/drawing/2014/main" id="{2EC3770D-BB2F-4596-8F25-68A816D8B134}"/>
+          <p:cNvPr id="17" name="">
+            <a:extLst xmlns:a="http://schemas.openxmlformats.org/drawingml/2006/main">
+              <a:ext uri="{FF2B5EF4-FFF2-40B4-BE49-F238E27FC236}">
+                <a16:creationId xmlns:a16="http://schemas.microsoft.com/office/drawing/2014/main" id="{41DACD76-4D61-47E0-8CF1-06AAE0B701F9}"/>
               </a:ext>
             </a:extLst>
           </p:cNvPr>
@@ -2741,10 +2872,10 @@
       </p:sp>
       <p:sp>
         <p:nvSpPr>
-          <p:cNvPr id="17" name="">
-            <a:extLst xmlns:a="http://schemas.openxmlformats.org/drawingml/2006/main">
-              <a:ext uri="{FF2B5EF4-FFF2-40B4-BE49-F238E27FC236}">
-                <a16:creationId xmlns:a16="http://schemas.microsoft.com/office/drawing/2014/main" id="{4F2854F7-2A0B-440F-B99C-E8247465B4E9}"/>
+          <p:cNvPr id="18" name="">
+            <a:extLst xmlns:a="http://schemas.openxmlformats.org/drawingml/2006/main">
+              <a:ext uri="{FF2B5EF4-FFF2-40B4-BE49-F238E27FC236}">
+                <a16:creationId xmlns:a16="http://schemas.microsoft.com/office/drawing/2014/main" id="{C798C0DD-65AC-4B6E-8E20-BB2E535B3DD5}"/>
               </a:ext>
             </a:extLst>
           </p:cNvPr>
@@ -2772,10 +2903,10 @@
       </p:sp>
       <p:sp>
         <p:nvSpPr>
-          <p:cNvPr id="18" name="">
-            <a:extLst xmlns:a="http://schemas.openxmlformats.org/drawingml/2006/main">
-              <a:ext uri="{FF2B5EF4-FFF2-40B4-BE49-F238E27FC236}">
-                <a16:creationId xmlns:a16="http://schemas.microsoft.com/office/drawing/2014/main" id="{626E3C4C-2AA9-47CC-A699-F860D00FC28F}"/>
+          <p:cNvPr id="19" name="">
+            <a:extLst xmlns:a="http://schemas.openxmlformats.org/drawingml/2006/main">
+              <a:ext uri="{FF2B5EF4-FFF2-40B4-BE49-F238E27FC236}">
+                <a16:creationId xmlns:a16="http://schemas.microsoft.com/office/drawing/2014/main" id="{67EAE3E7-2D1C-4038-ABB4-60ED7D4CB06F}"/>
               </a:ext>
             </a:extLst>
           </p:cNvPr>
@@ -2815,7 +2946,7 @@
                   <a:srgbClr val="FFFFFF"/>
                 </a:solidFill>
               </a:rPr>
-              <a:t>反事实</a:t>
+              <a:t>质量资产</a:t>
             </a:r>
           </a:p>
           <a:p xmlns:a="http://schemas.openxmlformats.org/drawingml/2006/main">
@@ -2832,7 +2963,7 @@
                   <a:srgbClr val="FFFFFF"/>
                 </a:solidFill>
               </a:rPr>
-              <a:t>重放</a:t>
+              <a:t>飞轮</a:t>
             </a:r>
           </a:p>
         </p:txBody>
@@ -2840,7 +2971,7 @@
     </p:spTree>
     <p:extLst>
       <p:ext uri="{BB962C8B-B14F-4D97-AF65-F5344CB8AC3E}">
-        <p14:creationId xmlns:p14="http://schemas.microsoft.com/office/powerpoint/2010/main" val="2085685799"/>
+        <p14:creationId xmlns:p14="http://schemas.microsoft.com/office/powerpoint/2010/main" val="2081090274"/>
       </p:ext>
     </p:extLst>
   </p:cSld>
@@ -2871,7 +3002,7 @@
           <p:cNvPr id="31" name="">
             <a:extLst xmlns:a="http://schemas.openxmlformats.org/drawingml/2006/main">
               <a:ext uri="{FF2B5EF4-FFF2-40B4-BE49-F238E27FC236}">
-                <a16:creationId xmlns:a16="http://schemas.microsoft.com/office/drawing/2014/main" id="{CA8BB874-3174-44E6-A2A1-0EDD40C06BBD}"/>
+                <a16:creationId xmlns:a16="http://schemas.microsoft.com/office/drawing/2014/main" id="{F30EF71B-4CE8-43D4-A8DE-A390722779D0}"/>
               </a:ext>
             </a:extLst>
           </p:cNvPr>
@@ -2921,7 +3052,7 @@
           <p:cNvPr id="2" name="">
             <a:extLst xmlns:a="http://schemas.openxmlformats.org/drawingml/2006/main">
               <a:ext uri="{FF2B5EF4-FFF2-40B4-BE49-F238E27FC236}">
-                <a16:creationId xmlns:a16="http://schemas.microsoft.com/office/drawing/2014/main" id="{67D06D6C-B6FA-458D-BF90-D5BC3A273DC7}"/>
+                <a16:creationId xmlns:a16="http://schemas.microsoft.com/office/drawing/2014/main" id="{3A141F7F-B149-4FF1-98F2-95AE9F65D7EC}"/>
               </a:ext>
             </a:extLst>
           </p:cNvPr>
@@ -2971,7 +3102,7 @@
           <p:cNvPr id="3" name="">
             <a:extLst xmlns:a="http://schemas.openxmlformats.org/drawingml/2006/main">
               <a:ext uri="{FF2B5EF4-FFF2-40B4-BE49-F238E27FC236}">
-                <a16:creationId xmlns:a16="http://schemas.microsoft.com/office/drawing/2014/main" id="{9D8E5BB0-6BF3-443B-9441-797C2D8E5DD9}"/>
+                <a16:creationId xmlns:a16="http://schemas.microsoft.com/office/drawing/2014/main" id="{C61B2AFC-AF99-4095-B62B-8109533AEC30}"/>
               </a:ext>
             </a:extLst>
           </p:cNvPr>
@@ -3021,7 +3152,7 @@
           <p:cNvPr id="4" name="">
             <a:extLst xmlns:a="http://schemas.openxmlformats.org/drawingml/2006/main">
               <a:ext uri="{FF2B5EF4-FFF2-40B4-BE49-F238E27FC236}">
-                <a16:creationId xmlns:a16="http://schemas.microsoft.com/office/drawing/2014/main" id="{6A1136B8-3781-424A-ABEA-477656F6576D}"/>
+                <a16:creationId xmlns:a16="http://schemas.microsoft.com/office/drawing/2014/main" id="{795833E8-AC85-4240-B412-8C5749C65C36}"/>
               </a:ext>
             </a:extLst>
           </p:cNvPr>
@@ -3071,7 +3202,7 @@
           <p:cNvPr id="5" name="">
             <a:extLst xmlns:a="http://schemas.openxmlformats.org/drawingml/2006/main">
               <a:ext uri="{FF2B5EF4-FFF2-40B4-BE49-F238E27FC236}">
-                <a16:creationId xmlns:a16="http://schemas.microsoft.com/office/drawing/2014/main" id="{D23B3516-491F-4E14-86B7-7DD12D38F0EB}"/>
+                <a16:creationId xmlns:a16="http://schemas.microsoft.com/office/drawing/2014/main" id="{3D503410-A9E5-488E-930B-72B59A06B0A2}"/>
               </a:ext>
             </a:extLst>
           </p:cNvPr>
@@ -3102,7 +3233,7 @@
           <p:cNvPr id="6" name="">
             <a:extLst xmlns:a="http://schemas.openxmlformats.org/drawingml/2006/main">
               <a:ext uri="{FF2B5EF4-FFF2-40B4-BE49-F238E27FC236}">
-                <a16:creationId xmlns:a16="http://schemas.microsoft.com/office/drawing/2014/main" id="{86823419-2C25-4FBB-8A89-446FCC49F98C}"/>
+                <a16:creationId xmlns:a16="http://schemas.microsoft.com/office/drawing/2014/main" id="{BBF30F3F-3EE8-42B6-8F2D-7C4AA718BB0B}"/>
               </a:ext>
             </a:extLst>
           </p:cNvPr>
@@ -3133,7 +3264,7 @@
           <p:cNvPr id="7" name="">
             <a:extLst xmlns:a="http://schemas.openxmlformats.org/drawingml/2006/main">
               <a:ext uri="{FF2B5EF4-FFF2-40B4-BE49-F238E27FC236}">
-                <a16:creationId xmlns:a16="http://schemas.microsoft.com/office/drawing/2014/main" id="{E701A27C-D7FE-4A89-995D-4808330309D9}"/>
+                <a16:creationId xmlns:a16="http://schemas.microsoft.com/office/drawing/2014/main" id="{CEEC1BCE-E1C8-4BBB-B4D0-02143361B641}"/>
               </a:ext>
             </a:extLst>
           </p:cNvPr>
@@ -3183,7 +3314,7 @@
           <p:cNvPr id="8" name="">
             <a:extLst xmlns:a="http://schemas.openxmlformats.org/drawingml/2006/main">
               <a:ext uri="{FF2B5EF4-FFF2-40B4-BE49-F238E27FC236}">
-                <a16:creationId xmlns:a16="http://schemas.microsoft.com/office/drawing/2014/main" id="{B6C9D830-0847-4418-B2AE-AEAC0ABC60DB}"/>
+                <a16:creationId xmlns:a16="http://schemas.microsoft.com/office/drawing/2014/main" id="{7490D35B-823E-4B13-A125-83DEE4178F45}"/>
               </a:ext>
             </a:extLst>
           </p:cNvPr>
@@ -3233,7 +3364,7 @@
           <p:cNvPr id="9" name="">
             <a:extLst xmlns:a="http://schemas.openxmlformats.org/drawingml/2006/main">
               <a:ext uri="{FF2B5EF4-FFF2-40B4-BE49-F238E27FC236}">
-                <a16:creationId xmlns:a16="http://schemas.microsoft.com/office/drawing/2014/main" id="{FE44BC0C-EA7E-4AA1-A3D5-E11523AB73E9}"/>
+                <a16:creationId xmlns:a16="http://schemas.microsoft.com/office/drawing/2014/main" id="{19994D61-C176-4C99-B6DD-66D320B78E2B}"/>
               </a:ext>
             </a:extLst>
           </p:cNvPr>
@@ -3264,7 +3395,7 @@
           <p:cNvPr id="10" name="">
             <a:extLst xmlns:a="http://schemas.openxmlformats.org/drawingml/2006/main">
               <a:ext uri="{FF2B5EF4-FFF2-40B4-BE49-F238E27FC236}">
-                <a16:creationId xmlns:a16="http://schemas.microsoft.com/office/drawing/2014/main" id="{64EBC96D-A24C-48F0-8C84-041C22AA2255}"/>
+                <a16:creationId xmlns:a16="http://schemas.microsoft.com/office/drawing/2014/main" id="{A752F26B-5BBC-438C-B0F4-A02EEA959328}"/>
               </a:ext>
             </a:extLst>
           </p:cNvPr>
@@ -3295,7 +3426,7 @@
           <p:cNvPr id="11" name="">
             <a:extLst xmlns:a="http://schemas.openxmlformats.org/drawingml/2006/main">
               <a:ext uri="{FF2B5EF4-FFF2-40B4-BE49-F238E27FC236}">
-                <a16:creationId xmlns:a16="http://schemas.microsoft.com/office/drawing/2014/main" id="{3A0B6A39-ED34-4ACA-B760-917C34DF7ABC}"/>
+                <a16:creationId xmlns:a16="http://schemas.microsoft.com/office/drawing/2014/main" id="{EF4565B1-707C-42DD-BB49-09149D7D6FBA}"/>
               </a:ext>
             </a:extLst>
           </p:cNvPr>
@@ -3345,7 +3476,7 @@
           <p:cNvPr id="12" name="">
             <a:extLst xmlns:a="http://schemas.openxmlformats.org/drawingml/2006/main">
               <a:ext uri="{FF2B5EF4-FFF2-40B4-BE49-F238E27FC236}">
-                <a16:creationId xmlns:a16="http://schemas.microsoft.com/office/drawing/2014/main" id="{F0FAB74B-10CB-46CA-B28E-389BF25B540A}"/>
+                <a16:creationId xmlns:a16="http://schemas.microsoft.com/office/drawing/2014/main" id="{783F2BDF-56E3-4E1C-9AFE-7C429B059F59}"/>
               </a:ext>
             </a:extLst>
           </p:cNvPr>
@@ -3395,7 +3526,7 @@
           <p:cNvPr id="13" name="">
             <a:extLst xmlns:a="http://schemas.openxmlformats.org/drawingml/2006/main">
               <a:ext uri="{FF2B5EF4-FFF2-40B4-BE49-F238E27FC236}">
-                <a16:creationId xmlns:a16="http://schemas.microsoft.com/office/drawing/2014/main" id="{CDDB4C5C-A448-4BFB-A7E1-8C2A6A457B0E}"/>
+                <a16:creationId xmlns:a16="http://schemas.microsoft.com/office/drawing/2014/main" id="{3C93DCB5-523D-4DAE-B2D6-35E467C4A578}"/>
               </a:ext>
             </a:extLst>
           </p:cNvPr>
@@ -3426,7 +3557,7 @@
           <p:cNvPr id="14" name="">
             <a:extLst xmlns:a="http://schemas.openxmlformats.org/drawingml/2006/main">
               <a:ext uri="{FF2B5EF4-FFF2-40B4-BE49-F238E27FC236}">
-                <a16:creationId xmlns:a16="http://schemas.microsoft.com/office/drawing/2014/main" id="{9D940383-4883-43F6-BB85-00C2809D3640}"/>
+                <a16:creationId xmlns:a16="http://schemas.microsoft.com/office/drawing/2014/main" id="{C3D46494-E5CD-40A0-9C3F-C7755E77F17C}"/>
               </a:ext>
             </a:extLst>
           </p:cNvPr>
@@ -3457,7 +3588,7 @@
           <p:cNvPr id="15" name="">
             <a:extLst xmlns:a="http://schemas.openxmlformats.org/drawingml/2006/main">
               <a:ext uri="{FF2B5EF4-FFF2-40B4-BE49-F238E27FC236}">
-                <a16:creationId xmlns:a16="http://schemas.microsoft.com/office/drawing/2014/main" id="{E53CE799-245B-452D-AABE-F47C47582FAD}"/>
+                <a16:creationId xmlns:a16="http://schemas.microsoft.com/office/drawing/2014/main" id="{1C88C5B5-6D54-43E9-86B4-040DC247954C}"/>
               </a:ext>
             </a:extLst>
           </p:cNvPr>
@@ -3507,7 +3638,7 @@
           <p:cNvPr id="16" name="">
             <a:extLst xmlns:a="http://schemas.openxmlformats.org/drawingml/2006/main">
               <a:ext uri="{FF2B5EF4-FFF2-40B4-BE49-F238E27FC236}">
-                <a16:creationId xmlns:a16="http://schemas.microsoft.com/office/drawing/2014/main" id="{E1BF7580-E2F1-4297-839B-87960132FF3C}"/>
+                <a16:creationId xmlns:a16="http://schemas.microsoft.com/office/drawing/2014/main" id="{3A1E42DE-C065-4A8B-B652-3245ED2C031D}"/>
               </a:ext>
             </a:extLst>
           </p:cNvPr>
@@ -3557,7 +3688,7 @@
           <p:cNvPr id="17" name="">
             <a:extLst xmlns:a="http://schemas.openxmlformats.org/drawingml/2006/main">
               <a:ext uri="{FF2B5EF4-FFF2-40B4-BE49-F238E27FC236}">
-                <a16:creationId xmlns:a16="http://schemas.microsoft.com/office/drawing/2014/main" id="{F1956BA0-98DD-43AB-B719-AD2067614E84}"/>
+                <a16:creationId xmlns:a16="http://schemas.microsoft.com/office/drawing/2014/main" id="{0716224D-1378-480D-B360-A213D4D510C9}"/>
               </a:ext>
             </a:extLst>
           </p:cNvPr>
@@ -3588,7 +3719,7 @@
           <p:cNvPr id="18" name="">
             <a:extLst xmlns:a="http://schemas.openxmlformats.org/drawingml/2006/main">
               <a:ext uri="{FF2B5EF4-FFF2-40B4-BE49-F238E27FC236}">
-                <a16:creationId xmlns:a16="http://schemas.microsoft.com/office/drawing/2014/main" id="{18ED5041-A4B1-4B9F-861C-E91711A7CC31}"/>
+                <a16:creationId xmlns:a16="http://schemas.microsoft.com/office/drawing/2014/main" id="{6857BF25-A980-41F4-8D7D-76C0CD54904D}"/>
               </a:ext>
             </a:extLst>
           </p:cNvPr>
@@ -3619,7 +3750,7 @@
           <p:cNvPr id="19" name="">
             <a:extLst xmlns:a="http://schemas.openxmlformats.org/drawingml/2006/main">
               <a:ext uri="{FF2B5EF4-FFF2-40B4-BE49-F238E27FC236}">
-                <a16:creationId xmlns:a16="http://schemas.microsoft.com/office/drawing/2014/main" id="{F3926DFC-03CD-4324-A2BD-99ADE9A49801}"/>
+                <a16:creationId xmlns:a16="http://schemas.microsoft.com/office/drawing/2014/main" id="{920D9010-5E7A-4057-80F9-531C7E48B1FD}"/>
               </a:ext>
             </a:extLst>
           </p:cNvPr>
@@ -3669,7 +3800,7 @@
           <p:cNvPr id="20" name="">
             <a:extLst xmlns:a="http://schemas.openxmlformats.org/drawingml/2006/main">
               <a:ext uri="{FF2B5EF4-FFF2-40B4-BE49-F238E27FC236}">
-                <a16:creationId xmlns:a16="http://schemas.microsoft.com/office/drawing/2014/main" id="{C1A6661A-2880-4CCA-9399-B76FD7FA8391}"/>
+                <a16:creationId xmlns:a16="http://schemas.microsoft.com/office/drawing/2014/main" id="{8E4B014C-294F-4C65-86FE-9657CA803D9F}"/>
               </a:ext>
             </a:extLst>
           </p:cNvPr>
@@ -3719,7 +3850,7 @@
           <p:cNvPr id="21" name="">
             <a:extLst xmlns:a="http://schemas.openxmlformats.org/drawingml/2006/main">
               <a:ext uri="{FF2B5EF4-FFF2-40B4-BE49-F238E27FC236}">
-                <a16:creationId xmlns:a16="http://schemas.microsoft.com/office/drawing/2014/main" id="{449F9626-C939-408F-B538-0DA4C59050D1}"/>
+                <a16:creationId xmlns:a16="http://schemas.microsoft.com/office/drawing/2014/main" id="{F7B74C10-BE50-44F5-911B-458C32CA0730}"/>
               </a:ext>
             </a:extLst>
           </p:cNvPr>
@@ -3769,7 +3900,7 @@
           <p:cNvPr id="22" name="">
             <a:extLst xmlns:a="http://schemas.openxmlformats.org/drawingml/2006/main">
               <a:ext uri="{FF2B5EF4-FFF2-40B4-BE49-F238E27FC236}">
-                <a16:creationId xmlns:a16="http://schemas.microsoft.com/office/drawing/2014/main" id="{5F65973B-298B-43B5-B733-23BDEFDE0CB8}"/>
+                <a16:creationId xmlns:a16="http://schemas.microsoft.com/office/drawing/2014/main" id="{58BE34A3-DC1B-439A-BFC3-69E239941B00}"/>
               </a:ext>
             </a:extLst>
           </p:cNvPr>
@@ -3819,7 +3950,7 @@
           <p:cNvPr id="23" name="">
             <a:extLst xmlns:a="http://schemas.openxmlformats.org/drawingml/2006/main">
               <a:ext uri="{FF2B5EF4-FFF2-40B4-BE49-F238E27FC236}">
-                <a16:creationId xmlns:a16="http://schemas.microsoft.com/office/drawing/2014/main" id="{6169AAD7-48B6-4D3B-882E-2B8580772B11}"/>
+                <a16:creationId xmlns:a16="http://schemas.microsoft.com/office/drawing/2014/main" id="{F415AB2B-27DF-4988-B87C-42E461B21A4B}"/>
               </a:ext>
             </a:extLst>
           </p:cNvPr>
@@ -3869,7 +4000,7 @@
           <p:cNvPr id="24" name="">
             <a:extLst xmlns:a="http://schemas.openxmlformats.org/drawingml/2006/main">
               <a:ext uri="{FF2B5EF4-FFF2-40B4-BE49-F238E27FC236}">
-                <a16:creationId xmlns:a16="http://schemas.microsoft.com/office/drawing/2014/main" id="{6A6C2CE0-739E-4953-A6AE-D58CAC7B59F2}"/>
+                <a16:creationId xmlns:a16="http://schemas.microsoft.com/office/drawing/2014/main" id="{609FF0A8-A358-4CF7-BCD9-F3A6F3859022}"/>
               </a:ext>
             </a:extLst>
           </p:cNvPr>
@@ -3919,7 +4050,7 @@
           <p:cNvPr id="25" name="">
             <a:extLst xmlns:a="http://schemas.openxmlformats.org/drawingml/2006/main">
               <a:ext uri="{FF2B5EF4-FFF2-40B4-BE49-F238E27FC236}">
-                <a16:creationId xmlns:a16="http://schemas.microsoft.com/office/drawing/2014/main" id="{F2DE570A-0555-4BC0-8529-AF0BE4B10243}"/>
+                <a16:creationId xmlns:a16="http://schemas.microsoft.com/office/drawing/2014/main" id="{08D45B2E-E20B-4A28-8E53-A77964493958}"/>
               </a:ext>
             </a:extLst>
           </p:cNvPr>
@@ -3969,7 +4100,7 @@
           <p:cNvPr id="26" name="">
             <a:extLst xmlns:a="http://schemas.openxmlformats.org/drawingml/2006/main">
               <a:ext uri="{FF2B5EF4-FFF2-40B4-BE49-F238E27FC236}">
-                <a16:creationId xmlns:a16="http://schemas.microsoft.com/office/drawing/2014/main" id="{72D1B4E9-4BF4-47BE-91AA-01F402B118FB}"/>
+                <a16:creationId xmlns:a16="http://schemas.microsoft.com/office/drawing/2014/main" id="{5EEE287C-B009-4C6B-84EF-0BDD96A26303}"/>
               </a:ext>
             </a:extLst>
           </p:cNvPr>
@@ -4019,7 +4150,7 @@
           <p:cNvPr id="27" name="">
             <a:extLst xmlns:a="http://schemas.openxmlformats.org/drawingml/2006/main">
               <a:ext uri="{FF2B5EF4-FFF2-40B4-BE49-F238E27FC236}">
-                <a16:creationId xmlns:a16="http://schemas.microsoft.com/office/drawing/2014/main" id="{115F4705-0107-4C84-915A-FABBDA65DDD9}"/>
+                <a16:creationId xmlns:a16="http://schemas.microsoft.com/office/drawing/2014/main" id="{5193337F-8A0E-437E-8732-C55D9E484DAB}"/>
               </a:ext>
             </a:extLst>
           </p:cNvPr>
@@ -4069,7 +4200,7 @@
           <p:cNvPr id="28" name="">
             <a:extLst xmlns:a="http://schemas.openxmlformats.org/drawingml/2006/main">
               <a:ext uri="{FF2B5EF4-FFF2-40B4-BE49-F238E27FC236}">
-                <a16:creationId xmlns:a16="http://schemas.microsoft.com/office/drawing/2014/main" id="{6004C2CE-57FE-4029-A951-95511F78DEF8}"/>
+                <a16:creationId xmlns:a16="http://schemas.microsoft.com/office/drawing/2014/main" id="{C4C02767-D79C-4355-A8C2-FAF1A18AE381}"/>
               </a:ext>
             </a:extLst>
           </p:cNvPr>
@@ -4119,7 +4250,7 @@
           <p:cNvPr id="29" name="">
             <a:extLst xmlns:a="http://schemas.openxmlformats.org/drawingml/2006/main">
               <a:ext uri="{FF2B5EF4-FFF2-40B4-BE49-F238E27FC236}">
-                <a16:creationId xmlns:a16="http://schemas.microsoft.com/office/drawing/2014/main" id="{751DEB80-2BE8-4093-B23C-8B8DDD829382}"/>
+                <a16:creationId xmlns:a16="http://schemas.microsoft.com/office/drawing/2014/main" id="{5089AF67-153D-47EC-9C37-1415E5BA191C}"/>
               </a:ext>
             </a:extLst>
           </p:cNvPr>
@@ -4169,7 +4300,7 @@
           <p:cNvPr id="30" name="">
             <a:extLst xmlns:a="http://schemas.openxmlformats.org/drawingml/2006/main">
               <a:ext uri="{FF2B5EF4-FFF2-40B4-BE49-F238E27FC236}">
-                <a16:creationId xmlns:a16="http://schemas.microsoft.com/office/drawing/2014/main" id="{F24FF85A-93F6-4D3D-ACA3-F0B97AE484D5}"/>
+                <a16:creationId xmlns:a16="http://schemas.microsoft.com/office/drawing/2014/main" id="{047D4D82-E60C-4D51-B19C-DEFC7FC3F644}"/>
               </a:ext>
             </a:extLst>
           </p:cNvPr>
@@ -4217,7 +4348,7 @@
     </p:spTree>
     <p:extLst>
       <p:ext uri="{BB962C8B-B14F-4D97-AF65-F5344CB8AC3E}">
-        <p14:creationId xmlns:p14="http://schemas.microsoft.com/office/powerpoint/2010/main" val="376083003"/>
+        <p14:creationId xmlns:p14="http://schemas.microsoft.com/office/powerpoint/2010/main" val="1433719632"/>
       </p:ext>
     </p:extLst>
   </p:cSld>
@@ -4248,7 +4379,7 @@
           <p:cNvPr id="27" name="">
             <a:extLst xmlns:a="http://schemas.openxmlformats.org/drawingml/2006/main">
               <a:ext uri="{FF2B5EF4-FFF2-40B4-BE49-F238E27FC236}">
-                <a16:creationId xmlns:a16="http://schemas.microsoft.com/office/drawing/2014/main" id="{AB3CDF4C-DFDF-40CF-81AD-49FB26903182}"/>
+                <a16:creationId xmlns:a16="http://schemas.microsoft.com/office/drawing/2014/main" id="{BD43ECF6-7837-40C9-8D3C-D309A7FA9080}"/>
               </a:ext>
             </a:extLst>
           </p:cNvPr>
@@ -4298,7 +4429,7 @@
           <p:cNvPr id="2" name="">
             <a:extLst xmlns:a="http://schemas.openxmlformats.org/drawingml/2006/main">
               <a:ext uri="{FF2B5EF4-FFF2-40B4-BE49-F238E27FC236}">
-                <a16:creationId xmlns:a16="http://schemas.microsoft.com/office/drawing/2014/main" id="{31BC364D-128B-438A-A81E-69D766C80DB0}"/>
+                <a16:creationId xmlns:a16="http://schemas.microsoft.com/office/drawing/2014/main" id="{DFC269E5-5C5E-4179-BCC9-9230EB612727}"/>
               </a:ext>
             </a:extLst>
           </p:cNvPr>
@@ -4348,7 +4479,7 @@
           <p:cNvPr id="3" name="">
             <a:extLst xmlns:a="http://schemas.openxmlformats.org/drawingml/2006/main">
               <a:ext uri="{FF2B5EF4-FFF2-40B4-BE49-F238E27FC236}">
-                <a16:creationId xmlns:a16="http://schemas.microsoft.com/office/drawing/2014/main" id="{992AA751-A635-4E30-9B1B-39B887B0D611}"/>
+                <a16:creationId xmlns:a16="http://schemas.microsoft.com/office/drawing/2014/main" id="{52E8B219-F698-419B-A263-9B1EFDB24BB5}"/>
               </a:ext>
             </a:extLst>
           </p:cNvPr>
@@ -4383,7 +4514,7 @@
           <p:cNvPr id="4" name="">
             <a:extLst xmlns:a="http://schemas.openxmlformats.org/drawingml/2006/main">
               <a:ext uri="{FF2B5EF4-FFF2-40B4-BE49-F238E27FC236}">
-                <a16:creationId xmlns:a16="http://schemas.microsoft.com/office/drawing/2014/main" id="{C5C7AF1E-A118-46C9-9FC0-5FAD1AD40333}"/>
+                <a16:creationId xmlns:a16="http://schemas.microsoft.com/office/drawing/2014/main" id="{6C2B6F47-87C0-41D9-B91D-EF0B552A8880}"/>
               </a:ext>
             </a:extLst>
           </p:cNvPr>
@@ -4433,7 +4564,7 @@
           <p:cNvPr id="5" name="">
             <a:extLst xmlns:a="http://schemas.openxmlformats.org/drawingml/2006/main">
               <a:ext uri="{FF2B5EF4-FFF2-40B4-BE49-F238E27FC236}">
-                <a16:creationId xmlns:a16="http://schemas.microsoft.com/office/drawing/2014/main" id="{53E12522-9504-4E3D-A347-FC49A61D7170}"/>
+                <a16:creationId xmlns:a16="http://schemas.microsoft.com/office/drawing/2014/main" id="{109ABB7B-CF99-49C0-8127-AB604AFC55DB}"/>
               </a:ext>
             </a:extLst>
           </p:cNvPr>
@@ -4483,7 +4614,7 @@
           <p:cNvPr id="6" name="">
             <a:extLst xmlns:a="http://schemas.openxmlformats.org/drawingml/2006/main">
               <a:ext uri="{FF2B5EF4-FFF2-40B4-BE49-F238E27FC236}">
-                <a16:creationId xmlns:a16="http://schemas.microsoft.com/office/drawing/2014/main" id="{31906EA8-FC4A-40C7-8DE6-45B5AB8F0FA9}"/>
+                <a16:creationId xmlns:a16="http://schemas.microsoft.com/office/drawing/2014/main" id="{A73AF120-8C92-4715-B621-002F295DB22D}"/>
               </a:ext>
             </a:extLst>
           </p:cNvPr>
@@ -4533,7 +4664,7 @@
           <p:cNvPr id="7" name="">
             <a:extLst xmlns:a="http://schemas.openxmlformats.org/drawingml/2006/main">
               <a:ext uri="{FF2B5EF4-FFF2-40B4-BE49-F238E27FC236}">
-                <a16:creationId xmlns:a16="http://schemas.microsoft.com/office/drawing/2014/main" id="{EFA210CD-3813-4F21-8FBC-28088437D038}"/>
+                <a16:creationId xmlns:a16="http://schemas.microsoft.com/office/drawing/2014/main" id="{A46CA753-2789-4E00-A078-2F8058DA2C45}"/>
               </a:ext>
             </a:extLst>
           </p:cNvPr>
@@ -4568,7 +4699,7 @@
           <p:cNvPr id="8" name="">
             <a:extLst xmlns:a="http://schemas.openxmlformats.org/drawingml/2006/main">
               <a:ext uri="{FF2B5EF4-FFF2-40B4-BE49-F238E27FC236}">
-                <a16:creationId xmlns:a16="http://schemas.microsoft.com/office/drawing/2014/main" id="{9FA0875B-B47A-4E9A-B735-4315B1BD9A62}"/>
+                <a16:creationId xmlns:a16="http://schemas.microsoft.com/office/drawing/2014/main" id="{193514AB-8299-463E-8B3C-74C3BCCC86F0}"/>
               </a:ext>
             </a:extLst>
           </p:cNvPr>
@@ -4618,7 +4749,7 @@
           <p:cNvPr id="9" name="">
             <a:extLst xmlns:a="http://schemas.openxmlformats.org/drawingml/2006/main">
               <a:ext uri="{FF2B5EF4-FFF2-40B4-BE49-F238E27FC236}">
-                <a16:creationId xmlns:a16="http://schemas.microsoft.com/office/drawing/2014/main" id="{06F536BB-F0D1-4327-B553-B74BC3607264}"/>
+                <a16:creationId xmlns:a16="http://schemas.microsoft.com/office/drawing/2014/main" id="{2F57B8A4-0BE2-43B6-A5B4-4F2C54CEC83C}"/>
               </a:ext>
             </a:extLst>
           </p:cNvPr>
@@ -4668,7 +4799,7 @@
           <p:cNvPr id="10" name="">
             <a:extLst xmlns:a="http://schemas.openxmlformats.org/drawingml/2006/main">
               <a:ext uri="{FF2B5EF4-FFF2-40B4-BE49-F238E27FC236}">
-                <a16:creationId xmlns:a16="http://schemas.microsoft.com/office/drawing/2014/main" id="{B1BA9DC7-6BD4-4BB3-8B97-9E0F5DA79058}"/>
+                <a16:creationId xmlns:a16="http://schemas.microsoft.com/office/drawing/2014/main" id="{FA7FE50E-E621-4840-8956-9BECD118FDBE}"/>
               </a:ext>
             </a:extLst>
           </p:cNvPr>
@@ -4718,7 +4849,7 @@
           <p:cNvPr id="11" name="">
             <a:extLst xmlns:a="http://schemas.openxmlformats.org/drawingml/2006/main">
               <a:ext uri="{FF2B5EF4-FFF2-40B4-BE49-F238E27FC236}">
-                <a16:creationId xmlns:a16="http://schemas.microsoft.com/office/drawing/2014/main" id="{B6C98075-53C7-46EF-9BDF-6F39318CA253}"/>
+                <a16:creationId xmlns:a16="http://schemas.microsoft.com/office/drawing/2014/main" id="{E18C34FD-6012-41B7-9AE9-487B20073D4D}"/>
               </a:ext>
             </a:extLst>
           </p:cNvPr>
@@ -4753,7 +4884,7 @@
           <p:cNvPr id="12" name="">
             <a:extLst xmlns:a="http://schemas.openxmlformats.org/drawingml/2006/main">
               <a:ext uri="{FF2B5EF4-FFF2-40B4-BE49-F238E27FC236}">
-                <a16:creationId xmlns:a16="http://schemas.microsoft.com/office/drawing/2014/main" id="{B01D008D-3448-4B07-BD29-D3F86ABEB7A9}"/>
+                <a16:creationId xmlns:a16="http://schemas.microsoft.com/office/drawing/2014/main" id="{7D1C6F93-C56B-4EAE-826C-CA2570B1BB46}"/>
               </a:ext>
             </a:extLst>
           </p:cNvPr>
@@ -4803,7 +4934,7 @@
           <p:cNvPr id="13" name="">
             <a:extLst xmlns:a="http://schemas.openxmlformats.org/drawingml/2006/main">
               <a:ext uri="{FF2B5EF4-FFF2-40B4-BE49-F238E27FC236}">
-                <a16:creationId xmlns:a16="http://schemas.microsoft.com/office/drawing/2014/main" id="{98992C13-FC0A-4FE7-A4D5-83CD06138A8E}"/>
+                <a16:creationId xmlns:a16="http://schemas.microsoft.com/office/drawing/2014/main" id="{FF7BF9B4-8A7A-4FBD-A19C-DC6569407870}"/>
               </a:ext>
             </a:extLst>
           </p:cNvPr>
@@ -4853,7 +4984,7 @@
           <p:cNvPr id="14" name="">
             <a:extLst xmlns:a="http://schemas.openxmlformats.org/drawingml/2006/main">
               <a:ext uri="{FF2B5EF4-FFF2-40B4-BE49-F238E27FC236}">
-                <a16:creationId xmlns:a16="http://schemas.microsoft.com/office/drawing/2014/main" id="{2C55BD9B-3409-459D-8F3C-B02B0235863A}"/>
+                <a16:creationId xmlns:a16="http://schemas.microsoft.com/office/drawing/2014/main" id="{B39DEE0E-D69A-4F97-99C0-82F78220C634}"/>
               </a:ext>
             </a:extLst>
           </p:cNvPr>
@@ -4903,7 +5034,7 @@
           <p:cNvPr id="15" name="">
             <a:extLst xmlns:a="http://schemas.openxmlformats.org/drawingml/2006/main">
               <a:ext uri="{FF2B5EF4-FFF2-40B4-BE49-F238E27FC236}">
-                <a16:creationId xmlns:a16="http://schemas.microsoft.com/office/drawing/2014/main" id="{E2D81A97-AB2A-4BA1-8C1A-8D8BC13B0ECC}"/>
+                <a16:creationId xmlns:a16="http://schemas.microsoft.com/office/drawing/2014/main" id="{66938FBA-D52B-4781-8359-EE4BBF6FB2CD}"/>
               </a:ext>
             </a:extLst>
           </p:cNvPr>
@@ -4938,7 +5069,7 @@
           <p:cNvPr id="16" name="">
             <a:extLst xmlns:a="http://schemas.openxmlformats.org/drawingml/2006/main">
               <a:ext uri="{FF2B5EF4-FFF2-40B4-BE49-F238E27FC236}">
-                <a16:creationId xmlns:a16="http://schemas.microsoft.com/office/drawing/2014/main" id="{4AE21288-3B6B-4AEE-A027-7171EF38E0B8}"/>
+                <a16:creationId xmlns:a16="http://schemas.microsoft.com/office/drawing/2014/main" id="{176AF4EC-D08B-456A-8520-83EB4224D85D}"/>
               </a:ext>
             </a:extLst>
           </p:cNvPr>
@@ -4988,7 +5119,7 @@
           <p:cNvPr id="17" name="">
             <a:extLst xmlns:a="http://schemas.openxmlformats.org/drawingml/2006/main">
               <a:ext uri="{FF2B5EF4-FFF2-40B4-BE49-F238E27FC236}">
-                <a16:creationId xmlns:a16="http://schemas.microsoft.com/office/drawing/2014/main" id="{81E58BE7-77D2-4DF4-AB23-2A2AB20D9EF3}"/>
+                <a16:creationId xmlns:a16="http://schemas.microsoft.com/office/drawing/2014/main" id="{8DF2E7C7-1765-4CA4-99D9-2C9A0B27AA83}"/>
               </a:ext>
             </a:extLst>
           </p:cNvPr>
@@ -5038,7 +5169,7 @@
           <p:cNvPr id="18" name="">
             <a:extLst xmlns:a="http://schemas.openxmlformats.org/drawingml/2006/main">
               <a:ext uri="{FF2B5EF4-FFF2-40B4-BE49-F238E27FC236}">
-                <a16:creationId xmlns:a16="http://schemas.microsoft.com/office/drawing/2014/main" id="{858704BF-7362-43CB-A91F-BB3A13EA2D4A}"/>
+                <a16:creationId xmlns:a16="http://schemas.microsoft.com/office/drawing/2014/main" id="{C474E521-8FC3-4DEA-8FFE-0CA8D237074A}"/>
               </a:ext>
             </a:extLst>
           </p:cNvPr>
@@ -5088,7 +5219,7 @@
           <p:cNvPr id="19" name="">
             <a:extLst xmlns:a="http://schemas.openxmlformats.org/drawingml/2006/main">
               <a:ext uri="{FF2B5EF4-FFF2-40B4-BE49-F238E27FC236}">
-                <a16:creationId xmlns:a16="http://schemas.microsoft.com/office/drawing/2014/main" id="{82AABF1D-E664-4C90-8E95-81CC561DEF0F}"/>
+                <a16:creationId xmlns:a16="http://schemas.microsoft.com/office/drawing/2014/main" id="{85736A07-EF24-484C-9AEC-7F2E257E6446}"/>
               </a:ext>
             </a:extLst>
           </p:cNvPr>
@@ -5121,7 +5252,7 @@
           <p:cNvPr id="20" name="">
             <a:extLst xmlns:a="http://schemas.openxmlformats.org/drawingml/2006/main">
               <a:ext uri="{FF2B5EF4-FFF2-40B4-BE49-F238E27FC236}">
-                <a16:creationId xmlns:a16="http://schemas.microsoft.com/office/drawing/2014/main" id="{208146D7-FA09-4B6C-BC55-4BC2FCC0782D}"/>
+                <a16:creationId xmlns:a16="http://schemas.microsoft.com/office/drawing/2014/main" id="{2C5F9F7E-1B63-40C7-AC7F-5DA25C843223}"/>
               </a:ext>
             </a:extLst>
           </p:cNvPr>
@@ -5171,7 +5302,7 @@
           <p:cNvPr id="21" name="">
             <a:extLst xmlns:a="http://schemas.openxmlformats.org/drawingml/2006/main">
               <a:ext uri="{FF2B5EF4-FFF2-40B4-BE49-F238E27FC236}">
-                <a16:creationId xmlns:a16="http://schemas.microsoft.com/office/drawing/2014/main" id="{F11F8835-CED6-4D74-A6BD-692477BB8317}"/>
+                <a16:creationId xmlns:a16="http://schemas.microsoft.com/office/drawing/2014/main" id="{DC602424-4225-4712-B2F3-475E50650B0A}"/>
               </a:ext>
             </a:extLst>
           </p:cNvPr>
@@ -5204,7 +5335,7 @@
           <p:cNvPr id="22" name="">
             <a:extLst xmlns:a="http://schemas.openxmlformats.org/drawingml/2006/main">
               <a:ext uri="{FF2B5EF4-FFF2-40B4-BE49-F238E27FC236}">
-                <a16:creationId xmlns:a16="http://schemas.microsoft.com/office/drawing/2014/main" id="{BD62104E-3BB2-4E2C-BA94-0201A446F86F}"/>
+                <a16:creationId xmlns:a16="http://schemas.microsoft.com/office/drawing/2014/main" id="{B8616893-479F-444D-AD88-E7D3EBFEBF14}"/>
               </a:ext>
             </a:extLst>
           </p:cNvPr>
@@ -5254,7 +5385,7 @@
           <p:cNvPr id="23" name="">
             <a:extLst xmlns:a="http://schemas.openxmlformats.org/drawingml/2006/main">
               <a:ext uri="{FF2B5EF4-FFF2-40B4-BE49-F238E27FC236}">
-                <a16:creationId xmlns:a16="http://schemas.microsoft.com/office/drawing/2014/main" id="{FD8F8EEE-814B-4C93-8AA1-0D4A9556A655}"/>
+                <a16:creationId xmlns:a16="http://schemas.microsoft.com/office/drawing/2014/main" id="{C79676E8-5540-4778-B7DE-976699A8ABF5}"/>
               </a:ext>
             </a:extLst>
           </p:cNvPr>
@@ -5287,7 +5418,7 @@
           <p:cNvPr id="24" name="">
             <a:extLst xmlns:a="http://schemas.openxmlformats.org/drawingml/2006/main">
               <a:ext uri="{FF2B5EF4-FFF2-40B4-BE49-F238E27FC236}">
-                <a16:creationId xmlns:a16="http://schemas.microsoft.com/office/drawing/2014/main" id="{6903A74C-90D0-44AC-B601-5AEBEF07FF2A}"/>
+                <a16:creationId xmlns:a16="http://schemas.microsoft.com/office/drawing/2014/main" id="{C24E9D9B-3B32-4CB4-A286-E3FD3F83398B}"/>
               </a:ext>
             </a:extLst>
           </p:cNvPr>
@@ -5337,7 +5468,7 @@
           <p:cNvPr id="25" name="">
             <a:extLst xmlns:a="http://schemas.openxmlformats.org/drawingml/2006/main">
               <a:ext uri="{FF2B5EF4-FFF2-40B4-BE49-F238E27FC236}">
-                <a16:creationId xmlns:a16="http://schemas.microsoft.com/office/drawing/2014/main" id="{61B5A7F7-D7B7-4A02-9D8E-5D8638036768}"/>
+                <a16:creationId xmlns:a16="http://schemas.microsoft.com/office/drawing/2014/main" id="{1F65E313-5DE8-41FB-BD34-772DF0D9CF7C}"/>
               </a:ext>
             </a:extLst>
           </p:cNvPr>
@@ -5387,7 +5518,7 @@
           <p:cNvPr id="26" name="">
             <a:extLst xmlns:a="http://schemas.openxmlformats.org/drawingml/2006/main">
               <a:ext uri="{FF2B5EF4-FFF2-40B4-BE49-F238E27FC236}">
-                <a16:creationId xmlns:a16="http://schemas.microsoft.com/office/drawing/2014/main" id="{1186E2E4-41CB-4CC5-B268-7307D9D13F43}"/>
+                <a16:creationId xmlns:a16="http://schemas.microsoft.com/office/drawing/2014/main" id="{B15BD674-C4EC-453C-B09E-5D8C844AAFD2}"/>
               </a:ext>
             </a:extLst>
           </p:cNvPr>
@@ -5435,7 +5566,7 @@
     </p:spTree>
     <p:extLst>
       <p:ext uri="{BB962C8B-B14F-4D97-AF65-F5344CB8AC3E}">
-        <p14:creationId xmlns:p14="http://schemas.microsoft.com/office/powerpoint/2010/main" val="1807320814"/>
+        <p14:creationId xmlns:p14="http://schemas.microsoft.com/office/powerpoint/2010/main" val="1658464000"/>
       </p:ext>
     </p:extLst>
   </p:cSld>
@@ -5466,7 +5597,7 @@
           <p:cNvPr id="20" name="">
             <a:extLst xmlns:a="http://schemas.openxmlformats.org/drawingml/2006/main">
               <a:ext uri="{FF2B5EF4-FFF2-40B4-BE49-F238E27FC236}">
-                <a16:creationId xmlns:a16="http://schemas.microsoft.com/office/drawing/2014/main" id="{4DD9398D-DB6E-4ECC-B4E1-459D2161776A}"/>
+                <a16:creationId xmlns:a16="http://schemas.microsoft.com/office/drawing/2014/main" id="{FE29DF48-9F6B-48A3-B6D4-4FE8144B7CDD}"/>
               </a:ext>
             </a:extLst>
           </p:cNvPr>
@@ -5516,7 +5647,7 @@
           <p:cNvPr id="2" name="">
             <a:extLst xmlns:a="http://schemas.openxmlformats.org/drawingml/2006/main">
               <a:ext uri="{FF2B5EF4-FFF2-40B4-BE49-F238E27FC236}">
-                <a16:creationId xmlns:a16="http://schemas.microsoft.com/office/drawing/2014/main" id="{2B9C3F4C-3D72-4360-983E-D67DC7AC6F92}"/>
+                <a16:creationId xmlns:a16="http://schemas.microsoft.com/office/drawing/2014/main" id="{D8BF1CC4-E84D-4DA3-ADBA-7FE09D2114E0}"/>
               </a:ext>
             </a:extLst>
           </p:cNvPr>
@@ -5566,7 +5697,7 @@
           <p:cNvPr id="3" name="">
             <a:extLst xmlns:a="http://schemas.openxmlformats.org/drawingml/2006/main">
               <a:ext uri="{FF2B5EF4-FFF2-40B4-BE49-F238E27FC236}">
-                <a16:creationId xmlns:a16="http://schemas.microsoft.com/office/drawing/2014/main" id="{4272E99F-9FB7-41B2-BA74-68AB1F4779C2}"/>
+                <a16:creationId xmlns:a16="http://schemas.microsoft.com/office/drawing/2014/main" id="{A55B25FA-0BC5-4590-B3D4-680B60C1281E}"/>
               </a:ext>
             </a:extLst>
           </p:cNvPr>
@@ -5601,7 +5732,7 @@
           <p:cNvPr id="4" name="">
             <a:extLst xmlns:a="http://schemas.openxmlformats.org/drawingml/2006/main">
               <a:ext uri="{FF2B5EF4-FFF2-40B4-BE49-F238E27FC236}">
-                <a16:creationId xmlns:a16="http://schemas.microsoft.com/office/drawing/2014/main" id="{077D7CCB-4F38-480E-BB98-B3D3940F2275}"/>
+                <a16:creationId xmlns:a16="http://schemas.microsoft.com/office/drawing/2014/main" id="{5838926C-05E8-4C7B-99BB-9892BA19758A}"/>
               </a:ext>
             </a:extLst>
           </p:cNvPr>
@@ -5651,7 +5782,7 @@
           <p:cNvPr id="5" name="">
             <a:extLst xmlns:a="http://schemas.openxmlformats.org/drawingml/2006/main">
               <a:ext uri="{FF2B5EF4-FFF2-40B4-BE49-F238E27FC236}">
-                <a16:creationId xmlns:a16="http://schemas.microsoft.com/office/drawing/2014/main" id="{122A13D2-9C35-4BD1-8A0A-09FD0BA7D877}"/>
+                <a16:creationId xmlns:a16="http://schemas.microsoft.com/office/drawing/2014/main" id="{47AFEC25-66EA-4769-B8A9-5BC17FF08ADF}"/>
               </a:ext>
             </a:extLst>
           </p:cNvPr>
@@ -5769,7 +5900,7 @@
           <p:cNvPr id="6" name="">
             <a:extLst xmlns:a="http://schemas.openxmlformats.org/drawingml/2006/main">
               <a:ext uri="{FF2B5EF4-FFF2-40B4-BE49-F238E27FC236}">
-                <a16:creationId xmlns:a16="http://schemas.microsoft.com/office/drawing/2014/main" id="{C41121DC-D0AB-4CBA-A8E2-FAE51E3F9360}"/>
+                <a16:creationId xmlns:a16="http://schemas.microsoft.com/office/drawing/2014/main" id="{CCC60DAC-ECD3-414C-91A6-BD0D44CFA395}"/>
               </a:ext>
             </a:extLst>
           </p:cNvPr>
@@ -5804,7 +5935,7 @@
           <p:cNvPr id="7" name="">
             <a:extLst xmlns:a="http://schemas.openxmlformats.org/drawingml/2006/main">
               <a:ext uri="{FF2B5EF4-FFF2-40B4-BE49-F238E27FC236}">
-                <a16:creationId xmlns:a16="http://schemas.microsoft.com/office/drawing/2014/main" id="{89CC1B62-F9C1-473C-A8C4-83441EBA9D45}"/>
+                <a16:creationId xmlns:a16="http://schemas.microsoft.com/office/drawing/2014/main" id="{46704C83-E19D-4A01-96D1-BBA679C474AE}"/>
               </a:ext>
             </a:extLst>
           </p:cNvPr>
@@ -5854,7 +5985,7 @@
           <p:cNvPr id="8" name="">
             <a:extLst xmlns:a="http://schemas.openxmlformats.org/drawingml/2006/main">
               <a:ext uri="{FF2B5EF4-FFF2-40B4-BE49-F238E27FC236}">
-                <a16:creationId xmlns:a16="http://schemas.microsoft.com/office/drawing/2014/main" id="{0489AA72-897B-44E4-A89C-D565AE9CF7AC}"/>
+                <a16:creationId xmlns:a16="http://schemas.microsoft.com/office/drawing/2014/main" id="{BCB3F270-8721-4FA6-B8C9-1BDF3CDE824A}"/>
               </a:ext>
             </a:extLst>
           </p:cNvPr>
@@ -5889,7 +6020,7 @@
           <p:cNvPr id="9" name="">
             <a:extLst xmlns:a="http://schemas.openxmlformats.org/drawingml/2006/main">
               <a:ext uri="{FF2B5EF4-FFF2-40B4-BE49-F238E27FC236}">
-                <a16:creationId xmlns:a16="http://schemas.microsoft.com/office/drawing/2014/main" id="{6D81EFDC-77C9-41BA-8D36-EE7CFA8CC04A}"/>
+                <a16:creationId xmlns:a16="http://schemas.microsoft.com/office/drawing/2014/main" id="{7D7935D0-59B3-457C-8A76-880D4C57A9BB}"/>
               </a:ext>
             </a:extLst>
           </p:cNvPr>
@@ -5939,7 +6070,7 @@
           <p:cNvPr id="10" name="">
             <a:extLst xmlns:a="http://schemas.openxmlformats.org/drawingml/2006/main">
               <a:ext uri="{FF2B5EF4-FFF2-40B4-BE49-F238E27FC236}">
-                <a16:creationId xmlns:a16="http://schemas.microsoft.com/office/drawing/2014/main" id="{C89D1654-87F7-42B5-A912-6368BB91594F}"/>
+                <a16:creationId xmlns:a16="http://schemas.microsoft.com/office/drawing/2014/main" id="{6A353DD0-2B49-49E1-865C-310B5F78C795}"/>
               </a:ext>
             </a:extLst>
           </p:cNvPr>
@@ -6040,7 +6171,7 @@
           <p:cNvPr id="11" name="">
             <a:extLst xmlns:a="http://schemas.openxmlformats.org/drawingml/2006/main">
               <a:ext uri="{FF2B5EF4-FFF2-40B4-BE49-F238E27FC236}">
-                <a16:creationId xmlns:a16="http://schemas.microsoft.com/office/drawing/2014/main" id="{50FF5E9A-3177-45BA-A119-662CAF254D74}"/>
+                <a16:creationId xmlns:a16="http://schemas.microsoft.com/office/drawing/2014/main" id="{6B31480A-12D6-4AA8-B6F3-1305F2C41B35}"/>
               </a:ext>
             </a:extLst>
           </p:cNvPr>
@@ -6075,7 +6206,7 @@
           <p:cNvPr id="12" name="">
             <a:extLst xmlns:a="http://schemas.openxmlformats.org/drawingml/2006/main">
               <a:ext uri="{FF2B5EF4-FFF2-40B4-BE49-F238E27FC236}">
-                <a16:creationId xmlns:a16="http://schemas.microsoft.com/office/drawing/2014/main" id="{6D0BC502-6E12-4955-9B85-ACA6F9AC9EC0}"/>
+                <a16:creationId xmlns:a16="http://schemas.microsoft.com/office/drawing/2014/main" id="{A19E602B-718D-4AB0-B692-991557713A39}"/>
               </a:ext>
             </a:extLst>
           </p:cNvPr>
@@ -6125,7 +6256,7 @@
           <p:cNvPr id="13" name="">
             <a:extLst xmlns:a="http://schemas.openxmlformats.org/drawingml/2006/main">
               <a:ext uri="{FF2B5EF4-FFF2-40B4-BE49-F238E27FC236}">
-                <a16:creationId xmlns:a16="http://schemas.microsoft.com/office/drawing/2014/main" id="{85553B9A-2930-4C2E-8D49-454DDB24E5E2}"/>
+                <a16:creationId xmlns:a16="http://schemas.microsoft.com/office/drawing/2014/main" id="{477E7C2A-B7F4-46B9-8A71-D5B8CB9B54B5}"/>
               </a:ext>
             </a:extLst>
           </p:cNvPr>
@@ -6160,7 +6291,7 @@
           <p:cNvPr id="14" name="">
             <a:extLst xmlns:a="http://schemas.openxmlformats.org/drawingml/2006/main">
               <a:ext uri="{FF2B5EF4-FFF2-40B4-BE49-F238E27FC236}">
-                <a16:creationId xmlns:a16="http://schemas.microsoft.com/office/drawing/2014/main" id="{E44E85C8-7036-4504-812A-AEC6992EED7D}"/>
+                <a16:creationId xmlns:a16="http://schemas.microsoft.com/office/drawing/2014/main" id="{06FDD06C-B756-4594-B162-85CEFFAFB93A}"/>
               </a:ext>
             </a:extLst>
           </p:cNvPr>
@@ -6210,7 +6341,7 @@
           <p:cNvPr id="15" name="">
             <a:extLst xmlns:a="http://schemas.openxmlformats.org/drawingml/2006/main">
               <a:ext uri="{FF2B5EF4-FFF2-40B4-BE49-F238E27FC236}">
-                <a16:creationId xmlns:a16="http://schemas.microsoft.com/office/drawing/2014/main" id="{5BF27BDD-7E78-45FC-8CB2-E14A62BFEB01}"/>
+                <a16:creationId xmlns:a16="http://schemas.microsoft.com/office/drawing/2014/main" id="{A1CE4009-E3EC-4107-87D7-1B87EAB66B44}"/>
               </a:ext>
             </a:extLst>
           </p:cNvPr>
@@ -6311,7 +6442,7 @@
           <p:cNvPr id="16" name="">
             <a:extLst xmlns:a="http://schemas.openxmlformats.org/drawingml/2006/main">
               <a:ext uri="{FF2B5EF4-FFF2-40B4-BE49-F238E27FC236}">
-                <a16:creationId xmlns:a16="http://schemas.microsoft.com/office/drawing/2014/main" id="{1797B037-D1DD-418D-9080-F8134BAC280E}"/>
+                <a16:creationId xmlns:a16="http://schemas.microsoft.com/office/drawing/2014/main" id="{5D94CEC0-52D1-4AFE-921B-0AA5F830C5E7}"/>
               </a:ext>
             </a:extLst>
           </p:cNvPr>
@@ -6346,7 +6477,7 @@
           <p:cNvPr id="17" name="">
             <a:extLst xmlns:a="http://schemas.openxmlformats.org/drawingml/2006/main">
               <a:ext uri="{FF2B5EF4-FFF2-40B4-BE49-F238E27FC236}">
-                <a16:creationId xmlns:a16="http://schemas.microsoft.com/office/drawing/2014/main" id="{D788D8A2-1E0A-49F4-A551-9267456936E4}"/>
+                <a16:creationId xmlns:a16="http://schemas.microsoft.com/office/drawing/2014/main" id="{E4199238-1609-4929-A962-5B786BE77A45}"/>
               </a:ext>
             </a:extLst>
           </p:cNvPr>
@@ -6396,7 +6527,7 @@
           <p:cNvPr id="18" name="">
             <a:extLst xmlns:a="http://schemas.openxmlformats.org/drawingml/2006/main">
               <a:ext uri="{FF2B5EF4-FFF2-40B4-BE49-F238E27FC236}">
-                <a16:creationId xmlns:a16="http://schemas.microsoft.com/office/drawing/2014/main" id="{713C7864-AE6C-4F9F-A053-83F8EFCB2E15}"/>
+                <a16:creationId xmlns:a16="http://schemas.microsoft.com/office/drawing/2014/main" id="{BAFBCBE6-9525-4480-9CAA-890A26AD5D69}"/>
               </a:ext>
             </a:extLst>
           </p:cNvPr>
@@ -6446,7 +6577,7 @@
           <p:cNvPr id="19" name="">
             <a:extLst xmlns:a="http://schemas.openxmlformats.org/drawingml/2006/main">
               <a:ext uri="{FF2B5EF4-FFF2-40B4-BE49-F238E27FC236}">
-                <a16:creationId xmlns:a16="http://schemas.microsoft.com/office/drawing/2014/main" id="{8928B645-C646-4B80-8F2E-AD074B0FB9E8}"/>
+                <a16:creationId xmlns:a16="http://schemas.microsoft.com/office/drawing/2014/main" id="{B8118C1C-7156-42DC-92D7-0E57BB30BC70}"/>
               </a:ext>
             </a:extLst>
           </p:cNvPr>
@@ -6494,7 +6625,7 @@
     </p:spTree>
     <p:extLst>
       <p:ext uri="{BB962C8B-B14F-4D97-AF65-F5344CB8AC3E}">
-        <p14:creationId xmlns:p14="http://schemas.microsoft.com/office/powerpoint/2010/main" val="1521551950"/>
+        <p14:creationId xmlns:p14="http://schemas.microsoft.com/office/powerpoint/2010/main" val="2065953176"/>
       </p:ext>
     </p:extLst>
   </p:cSld>
@@ -6502,6 +6633,1407 @@
 </file>
 
 <file path=ppt/slides/slide13.xml><?xml version="1.0" encoding="utf-8"?>
+<p:sld xmlns:p="http://schemas.openxmlformats.org/presentationml/2006/main">
+  <p:cSld>
+    <p:bg>
+      <p:bgPr>
+        <a:solidFill xmlns:a="http://schemas.openxmlformats.org/drawingml/2006/main">
+          <a:srgbClr val="F8FAFC"/>
+        </a:solidFill>
+      </p:bgPr>
+    </p:bg>
+    <p:spTree>
+      <p:nvGrpSpPr>
+        <p:cNvPr id="1" name=""/>
+        <p:cNvGrpSpPr/>
+        <p:nvPr/>
+      </p:nvGrpSpPr>
+      <p:grpSpPr>
+        <a:xfrm xmlns:a="http://schemas.openxmlformats.org/drawingml/2006/main"/>
+      </p:grpSpPr>
+      <p:sp>
+        <p:nvSpPr>
+          <p:cNvPr id="29" name="">
+            <a:extLst xmlns:a="http://schemas.openxmlformats.org/drawingml/2006/main">
+              <a:ext uri="{FF2B5EF4-FFF2-40B4-BE49-F238E27FC236}">
+                <a16:creationId xmlns:a16="http://schemas.microsoft.com/office/drawing/2014/main" id="{705D3FCC-B61E-45F4-A512-17CBB5742807}"/>
+              </a:ext>
+            </a:extLst>
+          </p:cNvPr>
+          <p:cNvSpPr>
+            <a:spLocks xmlns:a="http://schemas.openxmlformats.org/drawingml/2006/main" noGrp="1"/>
+          </p:cNvSpPr>
+          <p:nvPr/>
+        </p:nvSpPr>
+        <p:spPr>
+          <a:xfrm xmlns:a="http://schemas.openxmlformats.org/drawingml/2006/main">
+            <a:off x="609600" y="361950"/>
+            <a:ext cx="5905500" cy="266700"/>
+          </a:xfrm>
+          <a:prstGeom xmlns:a="http://schemas.openxmlformats.org/drawingml/2006/main" prst="rect">
+            <a:avLst/>
+          </a:prstGeom>
+          <a:noFill xmlns:a="http://schemas.openxmlformats.org/drawingml/2006/main"/>
+          <a:ln xmlns:a="http://schemas.openxmlformats.org/drawingml/2006/main" w="0">
+            <a:noFill/>
+            <a:prstDash val="solid"/>
+          </a:ln>
+        </p:spPr>
+        <p:txBody>
+          <a:bodyPr xmlns:a="http://schemas.openxmlformats.org/drawingml/2006/main"/>
+          <a:lstStyle xmlns:a="http://schemas.openxmlformats.org/drawingml/2006/main"/>
+          <a:p xmlns:a="http://schemas.openxmlformats.org/drawingml/2006/main">
+            <a:pPr algn="l">
+              <a:defRPr sz="1200" b="1">
+                <a:solidFill>
+                  <a:srgbClr val="F97316"/>
+                </a:solidFill>
+              </a:defRPr>
+            </a:pPr>
+            <a:r>
+              <a:rPr sz="1200" b="1">
+                <a:solidFill>
+                  <a:srgbClr val="F97316"/>
+                </a:solidFill>
+              </a:rPr>
+              <a:t>商业价值与护城河</a:t>
+            </a:r>
+          </a:p>
+        </p:txBody>
+      </p:sp>
+      <p:sp>
+        <p:nvSpPr>
+          <p:cNvPr id="2" name="">
+            <a:extLst xmlns:a="http://schemas.openxmlformats.org/drawingml/2006/main">
+              <a:ext uri="{FF2B5EF4-FFF2-40B4-BE49-F238E27FC236}">
+                <a16:creationId xmlns:a16="http://schemas.microsoft.com/office/drawing/2014/main" id="{639903D6-C69C-4A46-8032-76AB4EF38F54}"/>
+              </a:ext>
+            </a:extLst>
+          </p:cNvPr>
+          <p:cNvSpPr>
+            <a:spLocks xmlns:a="http://schemas.openxmlformats.org/drawingml/2006/main" noGrp="1"/>
+          </p:cNvSpPr>
+          <p:nvPr/>
+        </p:nvSpPr>
+        <p:spPr>
+          <a:xfrm xmlns:a="http://schemas.openxmlformats.org/drawingml/2006/main">
+            <a:off x="609600" y="704850"/>
+            <a:ext cx="10287000" cy="742950"/>
+          </a:xfrm>
+          <a:prstGeom xmlns:a="http://schemas.openxmlformats.org/drawingml/2006/main" prst="rect">
+            <a:avLst/>
+          </a:prstGeom>
+          <a:noFill xmlns:a="http://schemas.openxmlformats.org/drawingml/2006/main"/>
+          <a:ln xmlns:a="http://schemas.openxmlformats.org/drawingml/2006/main" w="0">
+            <a:noFill/>
+            <a:prstDash val="solid"/>
+          </a:ln>
+        </p:spPr>
+        <p:txBody>
+          <a:bodyPr xmlns:a="http://schemas.openxmlformats.org/drawingml/2006/main"/>
+          <a:lstStyle xmlns:a="http://schemas.openxmlformats.org/drawingml/2006/main"/>
+          <a:p xmlns:a="http://schemas.openxmlformats.org/drawingml/2006/main">
+            <a:pPr algn="l">
+              <a:defRPr sz="2850" b="1">
+                <a:solidFill>
+                  <a:srgbClr val="0F172A"/>
+                </a:solidFill>
+              </a:defRPr>
+            </a:pPr>
+            <a:r>
+              <a:rPr sz="2850" b="1">
+                <a:solidFill>
+                  <a:srgbClr val="0F172A"/>
+                </a:solidFill>
+              </a:rPr>
+              <a:t>商业价值不止是缩短 MTTR，而是把事故变成研发质量资产</a:t>
+            </a:r>
+          </a:p>
+        </p:txBody>
+      </p:sp>
+      <p:sp>
+        <p:nvSpPr>
+          <p:cNvPr id="3" name="">
+            <a:extLst xmlns:a="http://schemas.openxmlformats.org/drawingml/2006/main">
+              <a:ext uri="{FF2B5EF4-FFF2-40B4-BE49-F238E27FC236}">
+                <a16:creationId xmlns:a16="http://schemas.microsoft.com/office/drawing/2014/main" id="{F9959433-08E2-4ADF-8ACD-E464B388CEAA}"/>
+              </a:ext>
+            </a:extLst>
+          </p:cNvPr>
+          <p:cNvSpPr>
+            <a:spLocks xmlns:a="http://schemas.openxmlformats.org/drawingml/2006/main" noGrp="1"/>
+          </p:cNvSpPr>
+          <p:nvPr/>
+        </p:nvSpPr>
+        <p:spPr>
+          <a:xfrm xmlns:a="http://schemas.openxmlformats.org/drawingml/2006/main">
+            <a:off x="800100" y="1657350"/>
+            <a:ext cx="2857500" cy="1466850"/>
+          </a:xfrm>
+          <a:prstGeom xmlns:a="http://schemas.openxmlformats.org/drawingml/2006/main" prst="roundRect">
+            <a:avLst>
+              <a:gd name="adj" fmla="val 5195"/>
+            </a:avLst>
+          </a:prstGeom>
+          <a:solidFill xmlns:a="http://schemas.openxmlformats.org/drawingml/2006/main">
+            <a:srgbClr val="EAF2FF"/>
+          </a:solidFill>
+          <a:ln xmlns:a="http://schemas.openxmlformats.org/drawingml/2006/main" w="9525">
+            <a:solidFill>
+              <a:srgbClr val="2563EB"/>
+            </a:solidFill>
+            <a:prstDash val="solid"/>
+          </a:ln>
+        </p:spPr>
+      </p:sp>
+      <p:sp>
+        <p:nvSpPr>
+          <p:cNvPr id="4" name="">
+            <a:extLst xmlns:a="http://schemas.openxmlformats.org/drawingml/2006/main">
+              <a:ext uri="{FF2B5EF4-FFF2-40B4-BE49-F238E27FC236}">
+                <a16:creationId xmlns:a16="http://schemas.microsoft.com/office/drawing/2014/main" id="{1E1A37B3-9B8A-4C2A-9838-4AD7AF51EB3F}"/>
+              </a:ext>
+            </a:extLst>
+          </p:cNvPr>
+          <p:cNvSpPr>
+            <a:spLocks xmlns:a="http://schemas.openxmlformats.org/drawingml/2006/main" noGrp="1"/>
+          </p:cNvSpPr>
+          <p:nvPr/>
+        </p:nvSpPr>
+        <p:spPr>
+          <a:xfrm xmlns:a="http://schemas.openxmlformats.org/drawingml/2006/main">
+            <a:off x="990600" y="1828800"/>
+            <a:ext cx="2476500" cy="323850"/>
+          </a:xfrm>
+          <a:prstGeom xmlns:a="http://schemas.openxmlformats.org/drawingml/2006/main" prst="rect">
+            <a:avLst/>
+          </a:prstGeom>
+          <a:noFill xmlns:a="http://schemas.openxmlformats.org/drawingml/2006/main"/>
+          <a:ln xmlns:a="http://schemas.openxmlformats.org/drawingml/2006/main" w="0">
+            <a:noFill/>
+            <a:prstDash val="solid"/>
+          </a:ln>
+        </p:spPr>
+        <p:txBody>
+          <a:bodyPr xmlns:a="http://schemas.openxmlformats.org/drawingml/2006/main"/>
+          <a:lstStyle xmlns:a="http://schemas.openxmlformats.org/drawingml/2006/main"/>
+          <a:p xmlns:a="http://schemas.openxmlformats.org/drawingml/2006/main">
+            <a:pPr algn="ctr">
+              <a:defRPr sz="1725" b="1">
+                <a:solidFill>
+                  <a:srgbClr val="2563EB"/>
+                </a:solidFill>
+              </a:defRPr>
+            </a:pPr>
+            <a:r>
+              <a:rPr sz="1725" b="1">
+                <a:solidFill>
+                  <a:srgbClr val="2563EB"/>
+                </a:solidFill>
+              </a:rPr>
+              <a:t>研发组织</a:t>
+            </a:r>
+          </a:p>
+        </p:txBody>
+      </p:sp>
+      <p:sp>
+        <p:nvSpPr>
+          <p:cNvPr id="5" name="">
+            <a:extLst xmlns:a="http://schemas.openxmlformats.org/drawingml/2006/main">
+              <a:ext uri="{FF2B5EF4-FFF2-40B4-BE49-F238E27FC236}">
+                <a16:creationId xmlns:a16="http://schemas.microsoft.com/office/drawing/2014/main" id="{2B23DD7D-3350-41E0-8171-7A27F6ACE677}"/>
+              </a:ext>
+            </a:extLst>
+          </p:cNvPr>
+          <p:cNvSpPr>
+            <a:spLocks xmlns:a="http://schemas.openxmlformats.org/drawingml/2006/main" noGrp="1"/>
+          </p:cNvSpPr>
+          <p:nvPr/>
+        </p:nvSpPr>
+        <p:spPr>
+          <a:xfrm xmlns:a="http://schemas.openxmlformats.org/drawingml/2006/main">
+            <a:off x="1028700" y="2286000"/>
+            <a:ext cx="2400300" cy="704850"/>
+          </a:xfrm>
+          <a:prstGeom xmlns:a="http://schemas.openxmlformats.org/drawingml/2006/main" prst="rect">
+            <a:avLst/>
+          </a:prstGeom>
+          <a:noFill xmlns:a="http://schemas.openxmlformats.org/drawingml/2006/main"/>
+          <a:ln xmlns:a="http://schemas.openxmlformats.org/drawingml/2006/main" w="0">
+            <a:noFill/>
+            <a:prstDash val="solid"/>
+          </a:ln>
+        </p:spPr>
+        <p:txBody>
+          <a:bodyPr xmlns:a="http://schemas.openxmlformats.org/drawingml/2006/main"/>
+          <a:lstStyle xmlns:a="http://schemas.openxmlformats.org/drawingml/2006/main"/>
+          <a:p xmlns:a="http://schemas.openxmlformats.org/drawingml/2006/main">
+            <a:pPr algn="ctr">
+              <a:defRPr sz="1350" b="0">
+                <a:solidFill>
+                  <a:srgbClr val="0F172A"/>
+                </a:solidFill>
+              </a:defRPr>
+            </a:pPr>
+            <a:r>
+              <a:rPr sz="1350" b="0">
+                <a:solidFill>
+                  <a:srgbClr val="0F172A"/>
+                </a:solidFill>
+              </a:rPr>
+              <a:t>减少定位时间</a:t>
+            </a:r>
+          </a:p>
+          <a:p xmlns:a="http://schemas.openxmlformats.org/drawingml/2006/main">
+            <a:pPr algn="ctr">
+              <a:defRPr sz="1350" b="0">
+                <a:solidFill>
+                  <a:srgbClr val="0F172A"/>
+                </a:solidFill>
+              </a:defRPr>
+            </a:pPr>
+            <a:r>
+              <a:rPr sz="1350" b="0">
+                <a:solidFill>
+                  <a:srgbClr val="0F172A"/>
+                </a:solidFill>
+              </a:rPr>
+              <a:t>降低误修复风险</a:t>
+            </a:r>
+          </a:p>
+          <a:p xmlns:a="http://schemas.openxmlformats.org/drawingml/2006/main">
+            <a:pPr algn="ctr">
+              <a:defRPr sz="1350" b="0">
+                <a:solidFill>
+                  <a:srgbClr val="0F172A"/>
+                </a:solidFill>
+              </a:defRPr>
+            </a:pPr>
+            <a:r>
+              <a:rPr sz="1350" b="0">
+                <a:solidFill>
+                  <a:srgbClr val="0F172A"/>
+                </a:solidFill>
+              </a:rPr>
+              <a:t>跨团队复用经验</a:t>
+            </a:r>
+          </a:p>
+        </p:txBody>
+      </p:sp>
+      <p:sp>
+        <p:nvSpPr>
+          <p:cNvPr id="6" name="">
+            <a:extLst xmlns:a="http://schemas.openxmlformats.org/drawingml/2006/main">
+              <a:ext uri="{FF2B5EF4-FFF2-40B4-BE49-F238E27FC236}">
+                <a16:creationId xmlns:a16="http://schemas.microsoft.com/office/drawing/2014/main" id="{D0BE41CD-4DC4-4047-B5C2-208CCFC513FE}"/>
+              </a:ext>
+            </a:extLst>
+          </p:cNvPr>
+          <p:cNvSpPr>
+            <a:spLocks xmlns:a="http://schemas.openxmlformats.org/drawingml/2006/main" noGrp="1"/>
+          </p:cNvSpPr>
+          <p:nvPr/>
+        </p:nvSpPr>
+        <p:spPr>
+          <a:xfrm xmlns:a="http://schemas.openxmlformats.org/drawingml/2006/main">
+            <a:off x="4324350" y="1657350"/>
+            <a:ext cx="2857500" cy="1466850"/>
+          </a:xfrm>
+          <a:prstGeom xmlns:a="http://schemas.openxmlformats.org/drawingml/2006/main" prst="roundRect">
+            <a:avLst>
+              <a:gd name="adj" fmla="val 5195"/>
+            </a:avLst>
+          </a:prstGeom>
+          <a:solidFill xmlns:a="http://schemas.openxmlformats.org/drawingml/2006/main">
+            <a:srgbClr val="ECFDF5"/>
+          </a:solidFill>
+          <a:ln xmlns:a="http://schemas.openxmlformats.org/drawingml/2006/main" w="9525">
+            <a:solidFill>
+              <a:srgbClr val="14B8A6"/>
+            </a:solidFill>
+            <a:prstDash val="solid"/>
+          </a:ln>
+        </p:spPr>
+      </p:sp>
+      <p:sp>
+        <p:nvSpPr>
+          <p:cNvPr id="7" name="">
+            <a:extLst xmlns:a="http://schemas.openxmlformats.org/drawingml/2006/main">
+              <a:ext uri="{FF2B5EF4-FFF2-40B4-BE49-F238E27FC236}">
+                <a16:creationId xmlns:a16="http://schemas.microsoft.com/office/drawing/2014/main" id="{5B018538-AE8D-4969-BAAB-85D79D59C028}"/>
+              </a:ext>
+            </a:extLst>
+          </p:cNvPr>
+          <p:cNvSpPr>
+            <a:spLocks xmlns:a="http://schemas.openxmlformats.org/drawingml/2006/main" noGrp="1"/>
+          </p:cNvSpPr>
+          <p:nvPr/>
+        </p:nvSpPr>
+        <p:spPr>
+          <a:xfrm xmlns:a="http://schemas.openxmlformats.org/drawingml/2006/main">
+            <a:off x="4514850" y="1828800"/>
+            <a:ext cx="2476500" cy="323850"/>
+          </a:xfrm>
+          <a:prstGeom xmlns:a="http://schemas.openxmlformats.org/drawingml/2006/main" prst="rect">
+            <a:avLst/>
+          </a:prstGeom>
+          <a:noFill xmlns:a="http://schemas.openxmlformats.org/drawingml/2006/main"/>
+          <a:ln xmlns:a="http://schemas.openxmlformats.org/drawingml/2006/main" w="0">
+            <a:noFill/>
+            <a:prstDash val="solid"/>
+          </a:ln>
+        </p:spPr>
+        <p:txBody>
+          <a:bodyPr xmlns:a="http://schemas.openxmlformats.org/drawingml/2006/main"/>
+          <a:lstStyle xmlns:a="http://schemas.openxmlformats.org/drawingml/2006/main"/>
+          <a:p xmlns:a="http://schemas.openxmlformats.org/drawingml/2006/main">
+            <a:pPr algn="ctr">
+              <a:defRPr sz="1725" b="1">
+                <a:solidFill>
+                  <a:srgbClr val="14B8A6"/>
+                </a:solidFill>
+              </a:defRPr>
+            </a:pPr>
+            <a:r>
+              <a:rPr sz="1725" b="1">
+                <a:solidFill>
+                  <a:srgbClr val="14B8A6"/>
+                </a:solidFill>
+              </a:rPr>
+              <a:t>云与 DevOps 平台</a:t>
+            </a:r>
+          </a:p>
+        </p:txBody>
+      </p:sp>
+      <p:sp>
+        <p:nvSpPr>
+          <p:cNvPr id="8" name="">
+            <a:extLst xmlns:a="http://schemas.openxmlformats.org/drawingml/2006/main">
+              <a:ext uri="{FF2B5EF4-FFF2-40B4-BE49-F238E27FC236}">
+                <a16:creationId xmlns:a16="http://schemas.microsoft.com/office/drawing/2014/main" id="{40D85E9D-FA7E-4B9F-B284-4193F61A2F2B}"/>
+              </a:ext>
+            </a:extLst>
+          </p:cNvPr>
+          <p:cNvSpPr>
+            <a:spLocks xmlns:a="http://schemas.openxmlformats.org/drawingml/2006/main" noGrp="1"/>
+          </p:cNvSpPr>
+          <p:nvPr/>
+        </p:nvSpPr>
+        <p:spPr>
+          <a:xfrm xmlns:a="http://schemas.openxmlformats.org/drawingml/2006/main">
+            <a:off x="4552950" y="2286000"/>
+            <a:ext cx="2400300" cy="704850"/>
+          </a:xfrm>
+          <a:prstGeom xmlns:a="http://schemas.openxmlformats.org/drawingml/2006/main" prst="rect">
+            <a:avLst/>
+          </a:prstGeom>
+          <a:noFill xmlns:a="http://schemas.openxmlformats.org/drawingml/2006/main"/>
+          <a:ln xmlns:a="http://schemas.openxmlformats.org/drawingml/2006/main" w="0">
+            <a:noFill/>
+            <a:prstDash val="solid"/>
+          </a:ln>
+        </p:spPr>
+        <p:txBody>
+          <a:bodyPr xmlns:a="http://schemas.openxmlformats.org/drawingml/2006/main"/>
+          <a:lstStyle xmlns:a="http://schemas.openxmlformats.org/drawingml/2006/main"/>
+          <a:p xmlns:a="http://schemas.openxmlformats.org/drawingml/2006/main">
+            <a:pPr algn="ctr">
+              <a:defRPr sz="1350" b="0">
+                <a:solidFill>
+                  <a:srgbClr val="0F172A"/>
+                </a:solidFill>
+              </a:defRPr>
+            </a:pPr>
+            <a:r>
+              <a:rPr sz="1350" b="0">
+                <a:solidFill>
+                  <a:srgbClr val="0F172A"/>
+                </a:solidFill>
+              </a:rPr>
+              <a:t>嵌入 AIOps / CI/CD</a:t>
+            </a:r>
+          </a:p>
+          <a:p xmlns:a="http://schemas.openxmlformats.org/drawingml/2006/main">
+            <a:pPr algn="ctr">
+              <a:defRPr sz="1350" b="0">
+                <a:solidFill>
+                  <a:srgbClr val="0F172A"/>
+                </a:solidFill>
+              </a:defRPr>
+            </a:pPr>
+            <a:r>
+              <a:rPr sz="1350" b="0">
+                <a:solidFill>
+                  <a:srgbClr val="0F172A"/>
+                </a:solidFill>
+              </a:rPr>
+              <a:t>连接配置中心与工单</a:t>
+            </a:r>
+          </a:p>
+          <a:p xmlns:a="http://schemas.openxmlformats.org/drawingml/2006/main">
+            <a:pPr algn="ctr">
+              <a:defRPr sz="1350" b="0">
+                <a:solidFill>
+                  <a:srgbClr val="0F172A"/>
+                </a:solidFill>
+              </a:defRPr>
+            </a:pPr>
+            <a:r>
+              <a:rPr sz="1350" b="0">
+                <a:solidFill>
+                  <a:srgbClr val="0F172A"/>
+                </a:solidFill>
+              </a:rPr>
+              <a:t>提供带证据的自动修复</a:t>
+            </a:r>
+          </a:p>
+        </p:txBody>
+      </p:sp>
+      <p:sp>
+        <p:nvSpPr>
+          <p:cNvPr id="9" name="">
+            <a:extLst xmlns:a="http://schemas.openxmlformats.org/drawingml/2006/main">
+              <a:ext uri="{FF2B5EF4-FFF2-40B4-BE49-F238E27FC236}">
+                <a16:creationId xmlns:a16="http://schemas.microsoft.com/office/drawing/2014/main" id="{D8F07A0F-A9D2-4CC4-8518-17822896F44F}"/>
+              </a:ext>
+            </a:extLst>
+          </p:cNvPr>
+          <p:cNvSpPr>
+            <a:spLocks xmlns:a="http://schemas.openxmlformats.org/drawingml/2006/main" noGrp="1"/>
+          </p:cNvSpPr>
+          <p:nvPr/>
+        </p:nvSpPr>
+        <p:spPr>
+          <a:xfrm xmlns:a="http://schemas.openxmlformats.org/drawingml/2006/main">
+            <a:off x="7848600" y="1657350"/>
+            <a:ext cx="2857500" cy="1466850"/>
+          </a:xfrm>
+          <a:prstGeom xmlns:a="http://schemas.openxmlformats.org/drawingml/2006/main" prst="roundRect">
+            <a:avLst>
+              <a:gd name="adj" fmla="val 5195"/>
+            </a:avLst>
+          </a:prstGeom>
+          <a:solidFill xmlns:a="http://schemas.openxmlformats.org/drawingml/2006/main">
+            <a:srgbClr val="FFF7ED"/>
+          </a:solidFill>
+          <a:ln xmlns:a="http://schemas.openxmlformats.org/drawingml/2006/main" w="9525">
+            <a:solidFill>
+              <a:srgbClr val="F97316"/>
+            </a:solidFill>
+            <a:prstDash val="solid"/>
+          </a:ln>
+        </p:spPr>
+      </p:sp>
+      <p:sp>
+        <p:nvSpPr>
+          <p:cNvPr id="10" name="">
+            <a:extLst xmlns:a="http://schemas.openxmlformats.org/drawingml/2006/main">
+              <a:ext uri="{FF2B5EF4-FFF2-40B4-BE49-F238E27FC236}">
+                <a16:creationId xmlns:a16="http://schemas.microsoft.com/office/drawing/2014/main" id="{268EF2A4-D323-4EAD-BE9E-CD08E617B0F1}"/>
+              </a:ext>
+            </a:extLst>
+          </p:cNvPr>
+          <p:cNvSpPr>
+            <a:spLocks xmlns:a="http://schemas.openxmlformats.org/drawingml/2006/main" noGrp="1"/>
+          </p:cNvSpPr>
+          <p:nvPr/>
+        </p:nvSpPr>
+        <p:spPr>
+          <a:xfrm xmlns:a="http://schemas.openxmlformats.org/drawingml/2006/main">
+            <a:off x="8039100" y="1828800"/>
+            <a:ext cx="2476500" cy="323850"/>
+          </a:xfrm>
+          <a:prstGeom xmlns:a="http://schemas.openxmlformats.org/drawingml/2006/main" prst="rect">
+            <a:avLst/>
+          </a:prstGeom>
+          <a:noFill xmlns:a="http://schemas.openxmlformats.org/drawingml/2006/main"/>
+          <a:ln xmlns:a="http://schemas.openxmlformats.org/drawingml/2006/main" w="0">
+            <a:noFill/>
+            <a:prstDash val="solid"/>
+          </a:ln>
+        </p:spPr>
+        <p:txBody>
+          <a:bodyPr xmlns:a="http://schemas.openxmlformats.org/drawingml/2006/main"/>
+          <a:lstStyle xmlns:a="http://schemas.openxmlformats.org/drawingml/2006/main"/>
+          <a:p xmlns:a="http://schemas.openxmlformats.org/drawingml/2006/main">
+            <a:pPr algn="ctr">
+              <a:defRPr sz="1725" b="1">
+                <a:solidFill>
+                  <a:srgbClr val="F97316"/>
+                </a:solidFill>
+              </a:defRPr>
+            </a:pPr>
+            <a:r>
+              <a:rPr sz="1725" b="1">
+                <a:solidFill>
+                  <a:srgbClr val="F97316"/>
+                </a:solidFill>
+              </a:rPr>
+              <a:t>高审计行业</a:t>
+            </a:r>
+          </a:p>
+        </p:txBody>
+      </p:sp>
+      <p:sp>
+        <p:nvSpPr>
+          <p:cNvPr id="11" name="">
+            <a:extLst xmlns:a="http://schemas.openxmlformats.org/drawingml/2006/main">
+              <a:ext uri="{FF2B5EF4-FFF2-40B4-BE49-F238E27FC236}">
+                <a16:creationId xmlns:a16="http://schemas.microsoft.com/office/drawing/2014/main" id="{D3E68174-1126-44AD-AE0C-2C4A758125B9}"/>
+              </a:ext>
+            </a:extLst>
+          </p:cNvPr>
+          <p:cNvSpPr>
+            <a:spLocks xmlns:a="http://schemas.openxmlformats.org/drawingml/2006/main" noGrp="1"/>
+          </p:cNvSpPr>
+          <p:nvPr/>
+        </p:nvSpPr>
+        <p:spPr>
+          <a:xfrm xmlns:a="http://schemas.openxmlformats.org/drawingml/2006/main">
+            <a:off x="8077200" y="2286000"/>
+            <a:ext cx="2400300" cy="704850"/>
+          </a:xfrm>
+          <a:prstGeom xmlns:a="http://schemas.openxmlformats.org/drawingml/2006/main" prst="rect">
+            <a:avLst/>
+          </a:prstGeom>
+          <a:noFill xmlns:a="http://schemas.openxmlformats.org/drawingml/2006/main"/>
+          <a:ln xmlns:a="http://schemas.openxmlformats.org/drawingml/2006/main" w="0">
+            <a:noFill/>
+            <a:prstDash val="solid"/>
+          </a:ln>
+        </p:spPr>
+        <p:txBody>
+          <a:bodyPr xmlns:a="http://schemas.openxmlformats.org/drawingml/2006/main"/>
+          <a:lstStyle xmlns:a="http://schemas.openxmlformats.org/drawingml/2006/main"/>
+          <a:p xmlns:a="http://schemas.openxmlformats.org/drawingml/2006/main">
+            <a:pPr algn="ctr">
+              <a:defRPr sz="1350" b="0">
+                <a:solidFill>
+                  <a:srgbClr val="0F172A"/>
+                </a:solidFill>
+              </a:defRPr>
+            </a:pPr>
+            <a:r>
+              <a:rPr sz="1350" b="0">
+                <a:solidFill>
+                  <a:srgbClr val="0F172A"/>
+                </a:solidFill>
+              </a:rPr>
+              <a:t>审批留痕</a:t>
+            </a:r>
+          </a:p>
+          <a:p xmlns:a="http://schemas.openxmlformats.org/drawingml/2006/main">
+            <a:pPr algn="ctr">
+              <a:defRPr sz="1350" b="0">
+                <a:solidFill>
+                  <a:srgbClr val="0F172A"/>
+                </a:solidFill>
+              </a:defRPr>
+            </a:pPr>
+            <a:r>
+              <a:rPr sz="1350" b="0">
+                <a:solidFill>
+                  <a:srgbClr val="0F172A"/>
+                </a:solidFill>
+              </a:rPr>
+              <a:t>回滚证明</a:t>
+            </a:r>
+          </a:p>
+          <a:p xmlns:a="http://schemas.openxmlformats.org/drawingml/2006/main">
+            <a:pPr algn="ctr">
+              <a:defRPr sz="1350" b="0">
+                <a:solidFill>
+                  <a:srgbClr val="0F172A"/>
+                </a:solidFill>
+              </a:defRPr>
+            </a:pPr>
+            <a:r>
+              <a:rPr sz="1350" b="0">
+                <a:solidFill>
+                  <a:srgbClr val="0F172A"/>
+                </a:solidFill>
+              </a:rPr>
+              <a:t>复盘报告自动化</a:t>
+            </a:r>
+          </a:p>
+        </p:txBody>
+      </p:sp>
+      <p:sp>
+        <p:nvSpPr>
+          <p:cNvPr id="12" name="">
+            <a:extLst xmlns:a="http://schemas.openxmlformats.org/drawingml/2006/main">
+              <a:ext uri="{FF2B5EF4-FFF2-40B4-BE49-F238E27FC236}">
+                <a16:creationId xmlns:a16="http://schemas.microsoft.com/office/drawing/2014/main" id="{E45AAD00-3309-49B9-A99D-A6C968B32759}"/>
+              </a:ext>
+            </a:extLst>
+          </p:cNvPr>
+          <p:cNvSpPr>
+            <a:spLocks xmlns:a="http://schemas.openxmlformats.org/drawingml/2006/main" noGrp="1"/>
+          </p:cNvSpPr>
+          <p:nvPr/>
+        </p:nvSpPr>
+        <p:spPr>
+          <a:xfrm xmlns:a="http://schemas.openxmlformats.org/drawingml/2006/main">
+            <a:off x="2914650" y="4095750"/>
+            <a:ext cx="1219200" cy="685800"/>
+          </a:xfrm>
+          <a:prstGeom xmlns:a="http://schemas.openxmlformats.org/drawingml/2006/main" prst="ellipse">
+            <a:avLst/>
+          </a:prstGeom>
+          <a:solidFill xmlns:a="http://schemas.openxmlformats.org/drawingml/2006/main">
+            <a:srgbClr val="FFFFFF"/>
+          </a:solidFill>
+          <a:ln xmlns:a="http://schemas.openxmlformats.org/drawingml/2006/main" w="9525">
+            <a:solidFill>
+              <a:srgbClr val="2563EB"/>
+            </a:solidFill>
+            <a:prstDash val="solid"/>
+          </a:ln>
+        </p:spPr>
+      </p:sp>
+      <p:sp>
+        <p:nvSpPr>
+          <p:cNvPr id="13" name="">
+            <a:extLst xmlns:a="http://schemas.openxmlformats.org/drawingml/2006/main">
+              <a:ext uri="{FF2B5EF4-FFF2-40B4-BE49-F238E27FC236}">
+                <a16:creationId xmlns:a16="http://schemas.microsoft.com/office/drawing/2014/main" id="{93267AE8-4E26-44A6-B31F-F2D5458E4ABC}"/>
+              </a:ext>
+            </a:extLst>
+          </p:cNvPr>
+          <p:cNvSpPr>
+            <a:spLocks xmlns:a="http://schemas.openxmlformats.org/drawingml/2006/main" noGrp="1"/>
+          </p:cNvSpPr>
+          <p:nvPr/>
+        </p:nvSpPr>
+        <p:spPr>
+          <a:xfrm xmlns:a="http://schemas.openxmlformats.org/drawingml/2006/main">
+            <a:off x="3009900" y="4314825"/>
+            <a:ext cx="1028700" cy="247650"/>
+          </a:xfrm>
+          <a:prstGeom xmlns:a="http://schemas.openxmlformats.org/drawingml/2006/main" prst="rect">
+            <a:avLst/>
+          </a:prstGeom>
+          <a:noFill xmlns:a="http://schemas.openxmlformats.org/drawingml/2006/main"/>
+          <a:ln xmlns:a="http://schemas.openxmlformats.org/drawingml/2006/main" w="0">
+            <a:noFill/>
+            <a:prstDash val="solid"/>
+          </a:ln>
+        </p:spPr>
+        <p:txBody>
+          <a:bodyPr xmlns:a="http://schemas.openxmlformats.org/drawingml/2006/main"/>
+          <a:lstStyle xmlns:a="http://schemas.openxmlformats.org/drawingml/2006/main"/>
+          <a:p xmlns:a="http://schemas.openxmlformats.org/drawingml/2006/main">
+            <a:pPr algn="ctr">
+              <a:defRPr sz="1275" b="1">
+                <a:solidFill>
+                  <a:srgbClr val="2563EB"/>
+                </a:solidFill>
+              </a:defRPr>
+            </a:pPr>
+            <a:r>
+              <a:rPr sz="1275" b="1">
+                <a:solidFill>
+                  <a:srgbClr val="2563EB"/>
+                </a:solidFill>
+              </a:rPr>
+              <a:t>事故证据</a:t>
+            </a:r>
+          </a:p>
+        </p:txBody>
+      </p:sp>
+      <p:sp>
+        <p:nvSpPr>
+          <p:cNvPr id="14" name="">
+            <a:extLst xmlns:a="http://schemas.openxmlformats.org/drawingml/2006/main">
+              <a:ext uri="{FF2B5EF4-FFF2-40B4-BE49-F238E27FC236}">
+                <a16:creationId xmlns:a16="http://schemas.microsoft.com/office/drawing/2014/main" id="{096B140D-7B79-4E8B-83D5-C57AE3E14C6F}"/>
+              </a:ext>
+            </a:extLst>
+          </p:cNvPr>
+          <p:cNvSpPr>
+            <a:spLocks xmlns:a="http://schemas.openxmlformats.org/drawingml/2006/main" noGrp="1"/>
+          </p:cNvSpPr>
+          <p:nvPr/>
+        </p:nvSpPr>
+        <p:spPr>
+          <a:xfrm xmlns:a="http://schemas.openxmlformats.org/drawingml/2006/main">
+            <a:off x="4648200" y="3390900"/>
+            <a:ext cx="1219200" cy="685800"/>
+          </a:xfrm>
+          <a:prstGeom xmlns:a="http://schemas.openxmlformats.org/drawingml/2006/main" prst="ellipse">
+            <a:avLst/>
+          </a:prstGeom>
+          <a:solidFill xmlns:a="http://schemas.openxmlformats.org/drawingml/2006/main">
+            <a:srgbClr val="FFFFFF"/>
+          </a:solidFill>
+          <a:ln xmlns:a="http://schemas.openxmlformats.org/drawingml/2006/main" w="9525">
+            <a:solidFill>
+              <a:srgbClr val="7C3AED"/>
+            </a:solidFill>
+            <a:prstDash val="solid"/>
+          </a:ln>
+        </p:spPr>
+      </p:sp>
+      <p:sp>
+        <p:nvSpPr>
+          <p:cNvPr id="15" name="">
+            <a:extLst xmlns:a="http://schemas.openxmlformats.org/drawingml/2006/main">
+              <a:ext uri="{FF2B5EF4-FFF2-40B4-BE49-F238E27FC236}">
+                <a16:creationId xmlns:a16="http://schemas.microsoft.com/office/drawing/2014/main" id="{1884137F-F16E-475C-96C3-B58B9723CB65}"/>
+              </a:ext>
+            </a:extLst>
+          </p:cNvPr>
+          <p:cNvSpPr>
+            <a:spLocks xmlns:a="http://schemas.openxmlformats.org/drawingml/2006/main" noGrp="1"/>
+          </p:cNvSpPr>
+          <p:nvPr/>
+        </p:nvSpPr>
+        <p:spPr>
+          <a:xfrm xmlns:a="http://schemas.openxmlformats.org/drawingml/2006/main">
+            <a:off x="4743450" y="3609975"/>
+            <a:ext cx="1028700" cy="247650"/>
+          </a:xfrm>
+          <a:prstGeom xmlns:a="http://schemas.openxmlformats.org/drawingml/2006/main" prst="rect">
+            <a:avLst/>
+          </a:prstGeom>
+          <a:noFill xmlns:a="http://schemas.openxmlformats.org/drawingml/2006/main"/>
+          <a:ln xmlns:a="http://schemas.openxmlformats.org/drawingml/2006/main" w="0">
+            <a:noFill/>
+            <a:prstDash val="solid"/>
+          </a:ln>
+        </p:spPr>
+        <p:txBody>
+          <a:bodyPr xmlns:a="http://schemas.openxmlformats.org/drawingml/2006/main"/>
+          <a:lstStyle xmlns:a="http://schemas.openxmlformats.org/drawingml/2006/main"/>
+          <a:p xmlns:a="http://schemas.openxmlformats.org/drawingml/2006/main">
+            <a:pPr algn="ctr">
+              <a:defRPr sz="1275" b="1">
+                <a:solidFill>
+                  <a:srgbClr val="7C3AED"/>
+                </a:solidFill>
+              </a:defRPr>
+            </a:pPr>
+            <a:r>
+              <a:rPr sz="1275" b="1">
+                <a:solidFill>
+                  <a:srgbClr val="7C3AED"/>
+                </a:solidFill>
+              </a:rPr>
+              <a:t>反事实实验</a:t>
+            </a:r>
+          </a:p>
+        </p:txBody>
+      </p:sp>
+      <p:sp>
+        <p:nvSpPr>
+          <p:cNvPr id="16" name="">
+            <a:extLst xmlns:a="http://schemas.openxmlformats.org/drawingml/2006/main">
+              <a:ext uri="{FF2B5EF4-FFF2-40B4-BE49-F238E27FC236}">
+                <a16:creationId xmlns:a16="http://schemas.microsoft.com/office/drawing/2014/main" id="{1F796608-BAED-49D9-8A85-BD24A209E87E}"/>
+              </a:ext>
+            </a:extLst>
+          </p:cNvPr>
+          <p:cNvSpPr>
+            <a:spLocks xmlns:a="http://schemas.openxmlformats.org/drawingml/2006/main" noGrp="1"/>
+          </p:cNvSpPr>
+          <p:nvPr/>
+        </p:nvSpPr>
+        <p:spPr>
+          <a:xfrm xmlns:a="http://schemas.openxmlformats.org/drawingml/2006/main">
+            <a:off x="6534150" y="3390900"/>
+            <a:ext cx="1219200" cy="685800"/>
+          </a:xfrm>
+          <a:prstGeom xmlns:a="http://schemas.openxmlformats.org/drawingml/2006/main" prst="ellipse">
+            <a:avLst/>
+          </a:prstGeom>
+          <a:solidFill xmlns:a="http://schemas.openxmlformats.org/drawingml/2006/main">
+            <a:srgbClr val="FFFFFF"/>
+          </a:solidFill>
+          <a:ln xmlns:a="http://schemas.openxmlformats.org/drawingml/2006/main" w="9525">
+            <a:solidFill>
+              <a:srgbClr val="16A34A"/>
+            </a:solidFill>
+            <a:prstDash val="solid"/>
+          </a:ln>
+        </p:spPr>
+      </p:sp>
+      <p:sp>
+        <p:nvSpPr>
+          <p:cNvPr id="17" name="">
+            <a:extLst xmlns:a="http://schemas.openxmlformats.org/drawingml/2006/main">
+              <a:ext uri="{FF2B5EF4-FFF2-40B4-BE49-F238E27FC236}">
+                <a16:creationId xmlns:a16="http://schemas.microsoft.com/office/drawing/2014/main" id="{36DEA92C-2E4A-45C8-8F37-A0B468AC6BE3}"/>
+              </a:ext>
+            </a:extLst>
+          </p:cNvPr>
+          <p:cNvSpPr>
+            <a:spLocks xmlns:a="http://schemas.openxmlformats.org/drawingml/2006/main" noGrp="1"/>
+          </p:cNvSpPr>
+          <p:nvPr/>
+        </p:nvSpPr>
+        <p:spPr>
+          <a:xfrm xmlns:a="http://schemas.openxmlformats.org/drawingml/2006/main">
+            <a:off x="6629400" y="3609975"/>
+            <a:ext cx="1028700" cy="247650"/>
+          </a:xfrm>
+          <a:prstGeom xmlns:a="http://schemas.openxmlformats.org/drawingml/2006/main" prst="rect">
+            <a:avLst/>
+          </a:prstGeom>
+          <a:noFill xmlns:a="http://schemas.openxmlformats.org/drawingml/2006/main"/>
+          <a:ln xmlns:a="http://schemas.openxmlformats.org/drawingml/2006/main" w="0">
+            <a:noFill/>
+            <a:prstDash val="solid"/>
+          </a:ln>
+        </p:spPr>
+        <p:txBody>
+          <a:bodyPr xmlns:a="http://schemas.openxmlformats.org/drawingml/2006/main"/>
+          <a:lstStyle xmlns:a="http://schemas.openxmlformats.org/drawingml/2006/main"/>
+          <a:p xmlns:a="http://schemas.openxmlformats.org/drawingml/2006/main">
+            <a:pPr algn="ctr">
+              <a:defRPr sz="1275" b="1">
+                <a:solidFill>
+                  <a:srgbClr val="16A34A"/>
+                </a:solidFill>
+              </a:defRPr>
+            </a:pPr>
+            <a:r>
+              <a:rPr sz="1275" b="1">
+                <a:solidFill>
+                  <a:srgbClr val="16A34A"/>
+                </a:solidFill>
+              </a:rPr>
+              <a:t>证据护照</a:t>
+            </a:r>
+          </a:p>
+        </p:txBody>
+      </p:sp>
+      <p:sp>
+        <p:nvSpPr>
+          <p:cNvPr id="18" name="">
+            <a:extLst xmlns:a="http://schemas.openxmlformats.org/drawingml/2006/main">
+              <a:ext uri="{FF2B5EF4-FFF2-40B4-BE49-F238E27FC236}">
+                <a16:creationId xmlns:a16="http://schemas.microsoft.com/office/drawing/2014/main" id="{CE46C5AF-E2B3-426D-9F6C-146190CAEF3B}"/>
+              </a:ext>
+            </a:extLst>
+          </p:cNvPr>
+          <p:cNvSpPr>
+            <a:spLocks xmlns:a="http://schemas.openxmlformats.org/drawingml/2006/main" noGrp="1"/>
+          </p:cNvSpPr>
+          <p:nvPr/>
+        </p:nvSpPr>
+        <p:spPr>
+          <a:xfrm xmlns:a="http://schemas.openxmlformats.org/drawingml/2006/main">
+            <a:off x="8286750" y="4095750"/>
+            <a:ext cx="1219200" cy="685800"/>
+          </a:xfrm>
+          <a:prstGeom xmlns:a="http://schemas.openxmlformats.org/drawingml/2006/main" prst="ellipse">
+            <a:avLst/>
+          </a:prstGeom>
+          <a:solidFill xmlns:a="http://schemas.openxmlformats.org/drawingml/2006/main">
+            <a:srgbClr val="FFFFFF"/>
+          </a:solidFill>
+          <a:ln xmlns:a="http://schemas.openxmlformats.org/drawingml/2006/main" w="9525">
+            <a:solidFill>
+              <a:srgbClr val="F97316"/>
+            </a:solidFill>
+            <a:prstDash val="solid"/>
+          </a:ln>
+        </p:spPr>
+      </p:sp>
+      <p:sp>
+        <p:nvSpPr>
+          <p:cNvPr id="19" name="">
+            <a:extLst xmlns:a="http://schemas.openxmlformats.org/drawingml/2006/main">
+              <a:ext uri="{FF2B5EF4-FFF2-40B4-BE49-F238E27FC236}">
+                <a16:creationId xmlns:a16="http://schemas.microsoft.com/office/drawing/2014/main" id="{B66C6EAB-65A1-437E-9625-5F0E7C9BCCBE}"/>
+              </a:ext>
+            </a:extLst>
+          </p:cNvPr>
+          <p:cNvSpPr>
+            <a:spLocks xmlns:a="http://schemas.openxmlformats.org/drawingml/2006/main" noGrp="1"/>
+          </p:cNvSpPr>
+          <p:nvPr/>
+        </p:nvSpPr>
+        <p:spPr>
+          <a:xfrm xmlns:a="http://schemas.openxmlformats.org/drawingml/2006/main">
+            <a:off x="8382000" y="4314825"/>
+            <a:ext cx="1028700" cy="247650"/>
+          </a:xfrm>
+          <a:prstGeom xmlns:a="http://schemas.openxmlformats.org/drawingml/2006/main" prst="rect">
+            <a:avLst/>
+          </a:prstGeom>
+          <a:noFill xmlns:a="http://schemas.openxmlformats.org/drawingml/2006/main"/>
+          <a:ln xmlns:a="http://schemas.openxmlformats.org/drawingml/2006/main" w="0">
+            <a:noFill/>
+            <a:prstDash val="solid"/>
+          </a:ln>
+        </p:spPr>
+        <p:txBody>
+          <a:bodyPr xmlns:a="http://schemas.openxmlformats.org/drawingml/2006/main"/>
+          <a:lstStyle xmlns:a="http://schemas.openxmlformats.org/drawingml/2006/main"/>
+          <a:p xmlns:a="http://schemas.openxmlformats.org/drawingml/2006/main">
+            <a:pPr algn="ctr">
+              <a:defRPr sz="1275" b="1">
+                <a:solidFill>
+                  <a:srgbClr val="F97316"/>
+                </a:solidFill>
+              </a:defRPr>
+            </a:pPr>
+            <a:r>
+              <a:rPr sz="1275" b="1">
+                <a:solidFill>
+                  <a:srgbClr val="F97316"/>
+                </a:solidFill>
+              </a:rPr>
+              <a:t>Skill / 基因包</a:t>
+            </a:r>
+          </a:p>
+        </p:txBody>
+      </p:sp>
+      <p:sp>
+        <p:nvSpPr>
+          <p:cNvPr id="20" name="">
+            <a:extLst xmlns:a="http://schemas.openxmlformats.org/drawingml/2006/main">
+              <a:ext uri="{FF2B5EF4-FFF2-40B4-BE49-F238E27FC236}">
+                <a16:creationId xmlns:a16="http://schemas.microsoft.com/office/drawing/2014/main" id="{81B7394F-6563-4FAB-AD3D-16F3D835B91C}"/>
+              </a:ext>
+            </a:extLst>
+          </p:cNvPr>
+          <p:cNvSpPr>
+            <a:spLocks xmlns:a="http://schemas.openxmlformats.org/drawingml/2006/main" noGrp="1"/>
+          </p:cNvSpPr>
+          <p:nvPr/>
+        </p:nvSpPr>
+        <p:spPr>
+          <a:xfrm xmlns:a="http://schemas.openxmlformats.org/drawingml/2006/main">
+            <a:off x="5600700" y="4762500"/>
+            <a:ext cx="1219200" cy="685800"/>
+          </a:xfrm>
+          <a:prstGeom xmlns:a="http://schemas.openxmlformats.org/drawingml/2006/main" prst="ellipse">
+            <a:avLst/>
+          </a:prstGeom>
+          <a:solidFill xmlns:a="http://schemas.openxmlformats.org/drawingml/2006/main">
+            <a:srgbClr val="FFFFFF"/>
+          </a:solidFill>
+          <a:ln xmlns:a="http://schemas.openxmlformats.org/drawingml/2006/main" w="9525">
+            <a:solidFill>
+              <a:srgbClr val="14B8A6"/>
+            </a:solidFill>
+            <a:prstDash val="solid"/>
+          </a:ln>
+        </p:spPr>
+      </p:sp>
+      <p:sp>
+        <p:nvSpPr>
+          <p:cNvPr id="21" name="">
+            <a:extLst xmlns:a="http://schemas.openxmlformats.org/drawingml/2006/main">
+              <a:ext uri="{FF2B5EF4-FFF2-40B4-BE49-F238E27FC236}">
+                <a16:creationId xmlns:a16="http://schemas.microsoft.com/office/drawing/2014/main" id="{B4ECF0DB-0255-4D83-BC23-C0D5BC411547}"/>
+              </a:ext>
+            </a:extLst>
+          </p:cNvPr>
+          <p:cNvSpPr>
+            <a:spLocks xmlns:a="http://schemas.openxmlformats.org/drawingml/2006/main" noGrp="1"/>
+          </p:cNvSpPr>
+          <p:nvPr/>
+        </p:nvSpPr>
+        <p:spPr>
+          <a:xfrm xmlns:a="http://schemas.openxmlformats.org/drawingml/2006/main">
+            <a:off x="5695950" y="4981575"/>
+            <a:ext cx="1028700" cy="247650"/>
+          </a:xfrm>
+          <a:prstGeom xmlns:a="http://schemas.openxmlformats.org/drawingml/2006/main" prst="rect">
+            <a:avLst/>
+          </a:prstGeom>
+          <a:noFill xmlns:a="http://schemas.openxmlformats.org/drawingml/2006/main"/>
+          <a:ln xmlns:a="http://schemas.openxmlformats.org/drawingml/2006/main" w="0">
+            <a:noFill/>
+            <a:prstDash val="solid"/>
+          </a:ln>
+        </p:spPr>
+        <p:txBody>
+          <a:bodyPr xmlns:a="http://schemas.openxmlformats.org/drawingml/2006/main"/>
+          <a:lstStyle xmlns:a="http://schemas.openxmlformats.org/drawingml/2006/main"/>
+          <a:p xmlns:a="http://schemas.openxmlformats.org/drawingml/2006/main">
+            <a:pPr algn="ctr">
+              <a:defRPr sz="1275" b="1">
+                <a:solidFill>
+                  <a:srgbClr val="14B8A6"/>
+                </a:solidFill>
+              </a:defRPr>
+            </a:pPr>
+            <a:r>
+              <a:rPr sz="1275" b="1">
+                <a:solidFill>
+                  <a:srgbClr val="14B8A6"/>
+                </a:solidFill>
+              </a:rPr>
+              <a:t>复用与分发</a:t>
+            </a:r>
+          </a:p>
+        </p:txBody>
+      </p:sp>
+      <p:sp>
+        <p:nvSpPr>
+          <p:cNvPr id="22" name="">
+            <a:extLst xmlns:a="http://schemas.openxmlformats.org/drawingml/2006/main">
+              <a:ext uri="{FF2B5EF4-FFF2-40B4-BE49-F238E27FC236}">
+                <a16:creationId xmlns:a16="http://schemas.microsoft.com/office/drawing/2014/main" id="{3867FCA3-B548-4EA3-8484-D26840440EA8}"/>
+              </a:ext>
+            </a:extLst>
+          </p:cNvPr>
+          <p:cNvSpPr>
+            <a:spLocks xmlns:a="http://schemas.openxmlformats.org/drawingml/2006/main" noGrp="1"/>
+          </p:cNvSpPr>
+          <p:nvPr/>
+        </p:nvSpPr>
+        <p:spPr>
+          <a:xfrm xmlns:a="http://schemas.openxmlformats.org/drawingml/2006/main">
+            <a:off x="4210050" y="4038600"/>
+            <a:ext cx="381000" cy="285750"/>
+          </a:xfrm>
+          <a:prstGeom xmlns:a="http://schemas.openxmlformats.org/drawingml/2006/main" prst="rect">
+            <a:avLst/>
+          </a:prstGeom>
+          <a:noFill xmlns:a="http://schemas.openxmlformats.org/drawingml/2006/main"/>
+          <a:ln xmlns:a="http://schemas.openxmlformats.org/drawingml/2006/main" w="0">
+            <a:noFill/>
+            <a:prstDash val="solid"/>
+          </a:ln>
+        </p:spPr>
+        <p:txBody>
+          <a:bodyPr xmlns:a="http://schemas.openxmlformats.org/drawingml/2006/main"/>
+          <a:lstStyle xmlns:a="http://schemas.openxmlformats.org/drawingml/2006/main"/>
+          <a:p xmlns:a="http://schemas.openxmlformats.org/drawingml/2006/main">
+            <a:pPr algn="ctr">
+              <a:defRPr sz="1950" b="1">
+                <a:solidFill>
+                  <a:srgbClr val="14B8A6"/>
+                </a:solidFill>
+              </a:defRPr>
+            </a:pPr>
+            <a:r>
+              <a:rPr sz="1950" b="1">
+                <a:solidFill>
+                  <a:srgbClr val="14B8A6"/>
+                </a:solidFill>
+              </a:rPr>
+              <a:t>→</a:t>
+            </a:r>
+          </a:p>
+        </p:txBody>
+      </p:sp>
+      <p:sp>
+        <p:nvSpPr>
+          <p:cNvPr id="23" name="">
+            <a:extLst xmlns:a="http://schemas.openxmlformats.org/drawingml/2006/main">
+              <a:ext uri="{FF2B5EF4-FFF2-40B4-BE49-F238E27FC236}">
+                <a16:creationId xmlns:a16="http://schemas.microsoft.com/office/drawing/2014/main" id="{DA7B1AE8-D1AD-4533-8BE8-F9F6819A3F75}"/>
+              </a:ext>
+            </a:extLst>
+          </p:cNvPr>
+          <p:cNvSpPr>
+            <a:spLocks xmlns:a="http://schemas.openxmlformats.org/drawingml/2006/main" noGrp="1"/>
+          </p:cNvSpPr>
+          <p:nvPr/>
+        </p:nvSpPr>
+        <p:spPr>
+          <a:xfrm xmlns:a="http://schemas.openxmlformats.org/drawingml/2006/main">
+            <a:off x="5981700" y="3562350"/>
+            <a:ext cx="381000" cy="285750"/>
+          </a:xfrm>
+          <a:prstGeom xmlns:a="http://schemas.openxmlformats.org/drawingml/2006/main" prst="rect">
+            <a:avLst/>
+          </a:prstGeom>
+          <a:noFill xmlns:a="http://schemas.openxmlformats.org/drawingml/2006/main"/>
+          <a:ln xmlns:a="http://schemas.openxmlformats.org/drawingml/2006/main" w="0">
+            <a:noFill/>
+            <a:prstDash val="solid"/>
+          </a:ln>
+        </p:spPr>
+        <p:txBody>
+          <a:bodyPr xmlns:a="http://schemas.openxmlformats.org/drawingml/2006/main"/>
+          <a:lstStyle xmlns:a="http://schemas.openxmlformats.org/drawingml/2006/main"/>
+          <a:p xmlns:a="http://schemas.openxmlformats.org/drawingml/2006/main">
+            <a:pPr algn="ctr">
+              <a:defRPr sz="1950" b="1">
+                <a:solidFill>
+                  <a:srgbClr val="14B8A6"/>
+                </a:solidFill>
+              </a:defRPr>
+            </a:pPr>
+            <a:r>
+              <a:rPr sz="1950" b="1">
+                <a:solidFill>
+                  <a:srgbClr val="14B8A6"/>
+                </a:solidFill>
+              </a:rPr>
+              <a:t>→</a:t>
+            </a:r>
+          </a:p>
+        </p:txBody>
+      </p:sp>
+      <p:sp>
+        <p:nvSpPr>
+          <p:cNvPr id="24" name="">
+            <a:extLst xmlns:a="http://schemas.openxmlformats.org/drawingml/2006/main">
+              <a:ext uri="{FF2B5EF4-FFF2-40B4-BE49-F238E27FC236}">
+                <a16:creationId xmlns:a16="http://schemas.microsoft.com/office/drawing/2014/main" id="{63829E5A-F5DA-47DE-97CB-9DCA996499BA}"/>
+              </a:ext>
+            </a:extLst>
+          </p:cNvPr>
+          <p:cNvSpPr>
+            <a:spLocks xmlns:a="http://schemas.openxmlformats.org/drawingml/2006/main" noGrp="1"/>
+          </p:cNvSpPr>
+          <p:nvPr/>
+        </p:nvSpPr>
+        <p:spPr>
+          <a:xfrm xmlns:a="http://schemas.openxmlformats.org/drawingml/2006/main">
+            <a:off x="7848600" y="4038600"/>
+            <a:ext cx="381000" cy="285750"/>
+          </a:xfrm>
+          <a:prstGeom xmlns:a="http://schemas.openxmlformats.org/drawingml/2006/main" prst="rect">
+            <a:avLst/>
+          </a:prstGeom>
+          <a:noFill xmlns:a="http://schemas.openxmlformats.org/drawingml/2006/main"/>
+          <a:ln xmlns:a="http://schemas.openxmlformats.org/drawingml/2006/main" w="0">
+            <a:noFill/>
+            <a:prstDash val="solid"/>
+          </a:ln>
+        </p:spPr>
+        <p:txBody>
+          <a:bodyPr xmlns:a="http://schemas.openxmlformats.org/drawingml/2006/main"/>
+          <a:lstStyle xmlns:a="http://schemas.openxmlformats.org/drawingml/2006/main"/>
+          <a:p xmlns:a="http://schemas.openxmlformats.org/drawingml/2006/main">
+            <a:pPr algn="ctr">
+              <a:defRPr sz="1950" b="1">
+                <a:solidFill>
+                  <a:srgbClr val="14B8A6"/>
+                </a:solidFill>
+              </a:defRPr>
+            </a:pPr>
+            <a:r>
+              <a:rPr sz="1950" b="1">
+                <a:solidFill>
+                  <a:srgbClr val="14B8A6"/>
+                </a:solidFill>
+              </a:rPr>
+              <a:t>→</a:t>
+            </a:r>
+          </a:p>
+        </p:txBody>
+      </p:sp>
+      <p:sp>
+        <p:nvSpPr>
+          <p:cNvPr id="25" name="">
+            <a:extLst xmlns:a="http://schemas.openxmlformats.org/drawingml/2006/main">
+              <a:ext uri="{FF2B5EF4-FFF2-40B4-BE49-F238E27FC236}">
+                <a16:creationId xmlns:a16="http://schemas.microsoft.com/office/drawing/2014/main" id="{4B3E901F-F4C4-48C5-BF2A-F0D1A0AF0FE9}"/>
+              </a:ext>
+            </a:extLst>
+          </p:cNvPr>
+          <p:cNvSpPr>
+            <a:spLocks xmlns:a="http://schemas.openxmlformats.org/drawingml/2006/main" noGrp="1"/>
+          </p:cNvSpPr>
+          <p:nvPr/>
+        </p:nvSpPr>
+        <p:spPr>
+          <a:xfrm xmlns:a="http://schemas.openxmlformats.org/drawingml/2006/main">
+            <a:off x="6705600" y="4648200"/>
+            <a:ext cx="457200" cy="323850"/>
+          </a:xfrm>
+          <a:prstGeom xmlns:a="http://schemas.openxmlformats.org/drawingml/2006/main" prst="rect">
+            <a:avLst/>
+          </a:prstGeom>
+          <a:noFill xmlns:a="http://schemas.openxmlformats.org/drawingml/2006/main"/>
+          <a:ln xmlns:a="http://schemas.openxmlformats.org/drawingml/2006/main" w="0">
+            <a:noFill/>
+            <a:prstDash val="solid"/>
+          </a:ln>
+        </p:spPr>
+        <p:txBody>
+          <a:bodyPr xmlns:a="http://schemas.openxmlformats.org/drawingml/2006/main"/>
+          <a:lstStyle xmlns:a="http://schemas.openxmlformats.org/drawingml/2006/main"/>
+          <a:p xmlns:a="http://schemas.openxmlformats.org/drawingml/2006/main">
+            <a:pPr algn="ctr">
+              <a:defRPr sz="2100" b="1">
+                <a:solidFill>
+                  <a:srgbClr val="14B8A6"/>
+                </a:solidFill>
+              </a:defRPr>
+            </a:pPr>
+            <a:r>
+              <a:rPr sz="2100" b="1">
+                <a:solidFill>
+                  <a:srgbClr val="14B8A6"/>
+                </a:solidFill>
+              </a:rPr>
+              <a:t>↺</a:t>
+            </a:r>
+          </a:p>
+        </p:txBody>
+      </p:sp>
+      <p:sp>
+        <p:nvSpPr>
+          <p:cNvPr id="26" name="">
+            <a:extLst xmlns:a="http://schemas.openxmlformats.org/drawingml/2006/main">
+              <a:ext uri="{FF2B5EF4-FFF2-40B4-BE49-F238E27FC236}">
+                <a16:creationId xmlns:a16="http://schemas.microsoft.com/office/drawing/2014/main" id="{278B126B-D187-4EFF-B0AA-381236349242}"/>
+              </a:ext>
+            </a:extLst>
+          </p:cNvPr>
+          <p:cNvSpPr>
+            <a:spLocks xmlns:a="http://schemas.openxmlformats.org/drawingml/2006/main" noGrp="1"/>
+          </p:cNvSpPr>
+          <p:nvPr/>
+        </p:nvSpPr>
+        <p:spPr>
+          <a:xfrm xmlns:a="http://schemas.openxmlformats.org/drawingml/2006/main">
+            <a:off x="990600" y="5753100"/>
+            <a:ext cx="10191750" cy="323850"/>
+          </a:xfrm>
+          <a:prstGeom xmlns:a="http://schemas.openxmlformats.org/drawingml/2006/main" prst="rect">
+            <a:avLst/>
+          </a:prstGeom>
+          <a:noFill xmlns:a="http://schemas.openxmlformats.org/drawingml/2006/main"/>
+          <a:ln xmlns:a="http://schemas.openxmlformats.org/drawingml/2006/main" w="0">
+            <a:noFill/>
+            <a:prstDash val="solid"/>
+          </a:ln>
+        </p:spPr>
+        <p:txBody>
+          <a:bodyPr xmlns:a="http://schemas.openxmlformats.org/drawingml/2006/main"/>
+          <a:lstStyle xmlns:a="http://schemas.openxmlformats.org/drawingml/2006/main"/>
+          <a:p xmlns:a="http://schemas.openxmlformats.org/drawingml/2006/main">
+            <a:pPr algn="ctr">
+              <a:defRPr sz="1650" b="1">
+                <a:solidFill>
+                  <a:srgbClr val="0F172A"/>
+                </a:solidFill>
+              </a:defRPr>
+            </a:pPr>
+            <a:r>
+              <a:rPr sz="1650" b="1">
+                <a:solidFill>
+                  <a:srgbClr val="0F172A"/>
+                </a:solidFill>
+              </a:rPr>
+              <a:t>可收费形态：团队版 SaaS、企业私有化、云市场插件、故障基因包 / Skill 市场、审计合规模块</a:t>
+            </a:r>
+          </a:p>
+        </p:txBody>
+      </p:sp>
+      <p:sp>
+        <p:nvSpPr>
+          <p:cNvPr id="27" name="">
+            <a:extLst xmlns:a="http://schemas.openxmlformats.org/drawingml/2006/main">
+              <a:ext uri="{FF2B5EF4-FFF2-40B4-BE49-F238E27FC236}">
+                <a16:creationId xmlns:a16="http://schemas.microsoft.com/office/drawing/2014/main" id="{EF17F80C-FB22-433D-A48C-513D610CB5DF}"/>
+              </a:ext>
+            </a:extLst>
+          </p:cNvPr>
+          <p:cNvSpPr>
+            <a:spLocks xmlns:a="http://schemas.openxmlformats.org/drawingml/2006/main" noGrp="1"/>
+          </p:cNvSpPr>
+          <p:nvPr/>
+        </p:nvSpPr>
+        <p:spPr>
+          <a:xfrm xmlns:a="http://schemas.openxmlformats.org/drawingml/2006/main">
+            <a:off x="609600" y="6362700"/>
+            <a:ext cx="6191250" cy="228600"/>
+          </a:xfrm>
+          <a:prstGeom xmlns:a="http://schemas.openxmlformats.org/drawingml/2006/main" prst="rect">
+            <a:avLst/>
+          </a:prstGeom>
+          <a:noFill xmlns:a="http://schemas.openxmlformats.org/drawingml/2006/main"/>
+          <a:ln xmlns:a="http://schemas.openxmlformats.org/drawingml/2006/main" w="0">
+            <a:noFill/>
+            <a:prstDash val="solid"/>
+          </a:ln>
+        </p:spPr>
+        <p:txBody>
+          <a:bodyPr xmlns:a="http://schemas.openxmlformats.org/drawingml/2006/main"/>
+          <a:lstStyle xmlns:a="http://schemas.openxmlformats.org/drawingml/2006/main"/>
+          <a:p xmlns:a="http://schemas.openxmlformats.org/drawingml/2006/main">
+            <a:pPr algn="l">
+              <a:defRPr sz="900" b="0">
+                <a:solidFill>
+                  <a:srgbClr val="526071"/>
+                </a:solidFill>
+              </a:defRPr>
+            </a:pPr>
+            <a:r>
+              <a:rPr sz="900" b="0">
+                <a:solidFill>
+                  <a:srgbClr val="526071"/>
+                </a:solidFill>
+              </a:rPr>
+              <a:t>AsoulAI · ChronosFix · GOAI Agent Infra 初赛方案</a:t>
+            </a:r>
+          </a:p>
+        </p:txBody>
+      </p:sp>
+      <p:sp>
+        <p:nvSpPr>
+          <p:cNvPr id="28" name="">
+            <a:extLst xmlns:a="http://schemas.openxmlformats.org/drawingml/2006/main">
+              <a:ext uri="{FF2B5EF4-FFF2-40B4-BE49-F238E27FC236}">
+                <a16:creationId xmlns:a16="http://schemas.microsoft.com/office/drawing/2014/main" id="{2E8C7FAB-7B58-4FC9-8813-2954EDF9E98C}"/>
+              </a:ext>
+            </a:extLst>
+          </p:cNvPr>
+          <p:cNvSpPr>
+            <a:spLocks xmlns:a="http://schemas.openxmlformats.org/drawingml/2006/main" noGrp="1"/>
+          </p:cNvSpPr>
+          <p:nvPr/>
+        </p:nvSpPr>
+        <p:spPr>
+          <a:xfrm xmlns:a="http://schemas.openxmlformats.org/drawingml/2006/main">
+            <a:off x="11125200" y="6362700"/>
+            <a:ext cx="476250" cy="228600"/>
+          </a:xfrm>
+          <a:prstGeom xmlns:a="http://schemas.openxmlformats.org/drawingml/2006/main" prst="rect">
+            <a:avLst/>
+          </a:prstGeom>
+          <a:noFill xmlns:a="http://schemas.openxmlformats.org/drawingml/2006/main"/>
+          <a:ln xmlns:a="http://schemas.openxmlformats.org/drawingml/2006/main" w="0">
+            <a:noFill/>
+            <a:prstDash val="solid"/>
+          </a:ln>
+        </p:spPr>
+        <p:txBody>
+          <a:bodyPr xmlns:a="http://schemas.openxmlformats.org/drawingml/2006/main"/>
+          <a:lstStyle xmlns:a="http://schemas.openxmlformats.org/drawingml/2006/main"/>
+          <a:p xmlns:a="http://schemas.openxmlformats.org/drawingml/2006/main">
+            <a:pPr algn="r">
+              <a:defRPr sz="900" b="0">
+                <a:solidFill>
+                  <a:srgbClr val="526071"/>
+                </a:solidFill>
+              </a:defRPr>
+            </a:pPr>
+            <a:r>
+              <a:rPr sz="900" b="0">
+                <a:solidFill>
+                  <a:srgbClr val="526071"/>
+                </a:solidFill>
+              </a:rPr>
+              <a:t>13</a:t>
+            </a:r>
+          </a:p>
+        </p:txBody>
+      </p:sp>
+    </p:spTree>
+    <p:extLst>
+      <p:ext uri="{BB962C8B-B14F-4D97-AF65-F5344CB8AC3E}">
+        <p14:creationId xmlns:p14="http://schemas.microsoft.com/office/powerpoint/2010/main" val="599174516"/>
+      </p:ext>
+    </p:extLst>
+  </p:cSld>
+</p:sld>
+</file>
+
+<file path=ppt/slides/slide14.xml><?xml version="1.0" encoding="utf-8"?>
 <p:sld xmlns:p="http://schemas.openxmlformats.org/presentationml/2006/main">
   <p:cSld>
     <p:bg>
@@ -6525,18 +8057,18 @@
           <p:cNvPr id="16" name="">
             <a:extLst xmlns:a="http://schemas.openxmlformats.org/drawingml/2006/main">
               <a:ext uri="{FF2B5EF4-FFF2-40B4-BE49-F238E27FC236}">
-                <a16:creationId xmlns:a16="http://schemas.microsoft.com/office/drawing/2014/main" id="{71AA948E-C60E-45F7-9E53-08463BC689D2}"/>
-              </a:ext>
-            </a:extLst>
-          </p:cNvPr>
-          <p:cNvSpPr>
-            <a:spLocks xmlns:a="http://schemas.openxmlformats.org/drawingml/2006/main" noGrp="1"/>
-          </p:cNvSpPr>
-          <p:nvPr/>
-        </p:nvSpPr>
-        <p:spPr>
-          <a:xfrm xmlns:a="http://schemas.openxmlformats.org/drawingml/2006/main">
-            <a:off x="800100" y="1085850"/>
+                <a16:creationId xmlns:a16="http://schemas.microsoft.com/office/drawing/2014/main" id="{B1005E75-0B38-4BA6-AB4C-81C59E53F7C8}"/>
+              </a:ext>
+            </a:extLst>
+          </p:cNvPr>
+          <p:cNvSpPr>
+            <a:spLocks xmlns:a="http://schemas.openxmlformats.org/drawingml/2006/main" noGrp="1"/>
+          </p:cNvSpPr>
+          <p:nvPr/>
+        </p:nvSpPr>
+        <p:spPr>
+          <a:xfrm xmlns:a="http://schemas.openxmlformats.org/drawingml/2006/main">
+            <a:off x="800100" y="990600"/>
             <a:ext cx="9334500" cy="609600"/>
           </a:xfrm>
           <a:prstGeom xmlns:a="http://schemas.openxmlformats.org/drawingml/2006/main" prst="rect">
@@ -6575,19 +8107,19 @@
           <p:cNvPr id="2" name="">
             <a:extLst xmlns:a="http://schemas.openxmlformats.org/drawingml/2006/main">
               <a:ext uri="{FF2B5EF4-FFF2-40B4-BE49-F238E27FC236}">
-                <a16:creationId xmlns:a16="http://schemas.microsoft.com/office/drawing/2014/main" id="{61D3C697-43E4-4418-AF24-E7CAF8CA801D}"/>
-              </a:ext>
-            </a:extLst>
-          </p:cNvPr>
-          <p:cNvSpPr>
-            <a:spLocks xmlns:a="http://schemas.openxmlformats.org/drawingml/2006/main" noGrp="1"/>
-          </p:cNvSpPr>
-          <p:nvPr/>
-        </p:nvSpPr>
-        <p:spPr>
-          <a:xfrm xmlns:a="http://schemas.openxmlformats.org/drawingml/2006/main">
-            <a:off x="800100" y="1790700"/>
-            <a:ext cx="9334500" cy="609600"/>
+                <a16:creationId xmlns:a16="http://schemas.microsoft.com/office/drawing/2014/main" id="{1838BDF6-4133-40B0-92A7-29AC3B966559}"/>
+              </a:ext>
+            </a:extLst>
+          </p:cNvPr>
+          <p:cNvSpPr>
+            <a:spLocks xmlns:a="http://schemas.openxmlformats.org/drawingml/2006/main" noGrp="1"/>
+          </p:cNvSpPr>
+          <p:nvPr/>
+        </p:nvSpPr>
+        <p:spPr>
+          <a:xfrm xmlns:a="http://schemas.openxmlformats.org/drawingml/2006/main">
+            <a:off x="800100" y="1695450"/>
+            <a:ext cx="9906000" cy="609600"/>
           </a:xfrm>
           <a:prstGeom xmlns:a="http://schemas.openxmlformats.org/drawingml/2006/main" prst="rect">
             <a:avLst/>
@@ -6615,7 +8147,7 @@
                   <a:srgbClr val="14B8A6"/>
                 </a:solidFill>
               </a:rPr>
-              <a:t>而是把判断所需的证据自动组织起来</a:t>
+              <a:t>而是把判断所需的证据变成可复利的质量资产</a:t>
             </a:r>
           </a:p>
         </p:txBody>
@@ -6625,7 +8157,7 @@
           <p:cNvPr id="3" name="">
             <a:extLst xmlns:a="http://schemas.openxmlformats.org/drawingml/2006/main">
               <a:ext uri="{FF2B5EF4-FFF2-40B4-BE49-F238E27FC236}">
-                <a16:creationId xmlns:a16="http://schemas.microsoft.com/office/drawing/2014/main" id="{3807122A-6AFA-4747-93BC-B6CF97B9B78C}"/>
+                <a16:creationId xmlns:a16="http://schemas.microsoft.com/office/drawing/2014/main" id="{A6549519-7815-4A76-B39B-FA53FA9A3A22}"/>
               </a:ext>
             </a:extLst>
           </p:cNvPr>
@@ -6660,7 +8192,7 @@
           <p:cNvPr id="4" name="">
             <a:extLst xmlns:a="http://schemas.openxmlformats.org/drawingml/2006/main">
               <a:ext uri="{FF2B5EF4-FFF2-40B4-BE49-F238E27FC236}">
-                <a16:creationId xmlns:a16="http://schemas.microsoft.com/office/drawing/2014/main" id="{C28E1C09-EA95-43C9-8145-4EBC2B9A1B92}"/>
+                <a16:creationId xmlns:a16="http://schemas.microsoft.com/office/drawing/2014/main" id="{F36C852B-AA88-49C1-BA4E-70E5660A9249}"/>
               </a:ext>
             </a:extLst>
           </p:cNvPr>
@@ -6710,7 +8242,7 @@
           <p:cNvPr id="5" name="">
             <a:extLst xmlns:a="http://schemas.openxmlformats.org/drawingml/2006/main">
               <a:ext uri="{FF2B5EF4-FFF2-40B4-BE49-F238E27FC236}">
-                <a16:creationId xmlns:a16="http://schemas.microsoft.com/office/drawing/2014/main" id="{20B5F874-E402-4380-BE8B-8A507E2F84D9}"/>
+                <a16:creationId xmlns:a16="http://schemas.microsoft.com/office/drawing/2014/main" id="{F7086EEC-33C6-4A40-8DA8-44373D1B34A1}"/>
               </a:ext>
             </a:extLst>
           </p:cNvPr>
@@ -6760,7 +8292,7 @@
           <p:cNvPr id="6" name="">
             <a:extLst xmlns:a="http://schemas.openxmlformats.org/drawingml/2006/main">
               <a:ext uri="{FF2B5EF4-FFF2-40B4-BE49-F238E27FC236}">
-                <a16:creationId xmlns:a16="http://schemas.microsoft.com/office/drawing/2014/main" id="{A0A0BBE2-E7E4-4169-937F-495824B43E75}"/>
+                <a16:creationId xmlns:a16="http://schemas.microsoft.com/office/drawing/2014/main" id="{44AF336F-27B7-4AB6-9241-0D3057F63932}"/>
               </a:ext>
             </a:extLst>
           </p:cNvPr>
@@ -6795,7 +8327,7 @@
           <p:cNvPr id="7" name="">
             <a:extLst xmlns:a="http://schemas.openxmlformats.org/drawingml/2006/main">
               <a:ext uri="{FF2B5EF4-FFF2-40B4-BE49-F238E27FC236}">
-                <a16:creationId xmlns:a16="http://schemas.microsoft.com/office/drawing/2014/main" id="{DFE710AA-E0B2-4FBD-9485-82DFFCE482A4}"/>
+                <a16:creationId xmlns:a16="http://schemas.microsoft.com/office/drawing/2014/main" id="{F56507FA-DA7B-41B3-BB91-A1F20D697735}"/>
               </a:ext>
             </a:extLst>
           </p:cNvPr>
@@ -6845,7 +8377,7 @@
           <p:cNvPr id="8" name="">
             <a:extLst xmlns:a="http://schemas.openxmlformats.org/drawingml/2006/main">
               <a:ext uri="{FF2B5EF4-FFF2-40B4-BE49-F238E27FC236}">
-                <a16:creationId xmlns:a16="http://schemas.microsoft.com/office/drawing/2014/main" id="{67587BDE-CC74-430D-9A86-E92F60CF1F15}"/>
+                <a16:creationId xmlns:a16="http://schemas.microsoft.com/office/drawing/2014/main" id="{EEDDDC2B-B20C-4BC1-A477-B874F87C1746}"/>
               </a:ext>
             </a:extLst>
           </p:cNvPr>
@@ -6895,7 +8427,7 @@
           <p:cNvPr id="9" name="">
             <a:extLst xmlns:a="http://schemas.openxmlformats.org/drawingml/2006/main">
               <a:ext uri="{FF2B5EF4-FFF2-40B4-BE49-F238E27FC236}">
-                <a16:creationId xmlns:a16="http://schemas.microsoft.com/office/drawing/2014/main" id="{F10D20B0-C833-4A7E-A01A-62925798759B}"/>
+                <a16:creationId xmlns:a16="http://schemas.microsoft.com/office/drawing/2014/main" id="{1A507E35-BCC1-457D-A015-F2FAB7F903F3}"/>
               </a:ext>
             </a:extLst>
           </p:cNvPr>
@@ -6930,7 +8462,7 @@
           <p:cNvPr id="10" name="">
             <a:extLst xmlns:a="http://schemas.openxmlformats.org/drawingml/2006/main">
               <a:ext uri="{FF2B5EF4-FFF2-40B4-BE49-F238E27FC236}">
-                <a16:creationId xmlns:a16="http://schemas.microsoft.com/office/drawing/2014/main" id="{520247A3-7AF9-478F-A9EB-2776AA773957}"/>
+                <a16:creationId xmlns:a16="http://schemas.microsoft.com/office/drawing/2014/main" id="{6A6EBCA3-8BEB-4297-B61E-C9EEF1251999}"/>
               </a:ext>
             </a:extLst>
           </p:cNvPr>
@@ -6980,7 +8512,7 @@
           <p:cNvPr id="11" name="">
             <a:extLst xmlns:a="http://schemas.openxmlformats.org/drawingml/2006/main">
               <a:ext uri="{FF2B5EF4-FFF2-40B4-BE49-F238E27FC236}">
-                <a16:creationId xmlns:a16="http://schemas.microsoft.com/office/drawing/2014/main" id="{89C1975D-0B51-461E-A071-87C6845E246D}"/>
+                <a16:creationId xmlns:a16="http://schemas.microsoft.com/office/drawing/2014/main" id="{32FC903D-03CB-45F0-9CB8-342410E6BD46}"/>
               </a:ext>
             </a:extLst>
           </p:cNvPr>
@@ -7030,7 +8562,7 @@
           <p:cNvPr id="12" name="">
             <a:extLst xmlns:a="http://schemas.openxmlformats.org/drawingml/2006/main">
               <a:ext uri="{FF2B5EF4-FFF2-40B4-BE49-F238E27FC236}">
-                <a16:creationId xmlns:a16="http://schemas.microsoft.com/office/drawing/2014/main" id="{81554287-7111-4183-930C-BA96258D79ED}"/>
+                <a16:creationId xmlns:a16="http://schemas.microsoft.com/office/drawing/2014/main" id="{B09D82DC-4F96-4C08-AB5A-A0915E67E9F3}"/>
               </a:ext>
             </a:extLst>
           </p:cNvPr>
@@ -7065,7 +8597,7 @@
           <p:cNvPr id="13" name="">
             <a:extLst xmlns:a="http://schemas.openxmlformats.org/drawingml/2006/main">
               <a:ext uri="{FF2B5EF4-FFF2-40B4-BE49-F238E27FC236}">
-                <a16:creationId xmlns:a16="http://schemas.microsoft.com/office/drawing/2014/main" id="{548499E2-E266-41AB-9439-DA33AD841553}"/>
+                <a16:creationId xmlns:a16="http://schemas.microsoft.com/office/drawing/2014/main" id="{03379651-9B0D-460C-A6C0-90B04D5782C5}"/>
               </a:ext>
             </a:extLst>
           </p:cNvPr>
@@ -7115,7 +8647,7 @@
           <p:cNvPr id="14" name="">
             <a:extLst xmlns:a="http://schemas.openxmlformats.org/drawingml/2006/main">
               <a:ext uri="{FF2B5EF4-FFF2-40B4-BE49-F238E27FC236}">
-                <a16:creationId xmlns:a16="http://schemas.microsoft.com/office/drawing/2014/main" id="{45AFAC8D-274F-4504-8547-E963777830DB}"/>
+                <a16:creationId xmlns:a16="http://schemas.microsoft.com/office/drawing/2014/main" id="{87C570BD-1C69-45D5-BE37-90E796341F99}"/>
               </a:ext>
             </a:extLst>
           </p:cNvPr>
@@ -7165,7 +8697,7 @@
           <p:cNvPr id="15" name="">
             <a:extLst xmlns:a="http://schemas.openxmlformats.org/drawingml/2006/main">
               <a:ext uri="{FF2B5EF4-FFF2-40B4-BE49-F238E27FC236}">
-                <a16:creationId xmlns:a16="http://schemas.microsoft.com/office/drawing/2014/main" id="{A3FD721C-A688-4B82-81E1-7B66667AE570}"/>
+                <a16:creationId xmlns:a16="http://schemas.microsoft.com/office/drawing/2014/main" id="{13726C59-F0DF-4420-9FC0-0BEC6C81A854}"/>
               </a:ext>
             </a:extLst>
           </p:cNvPr>
@@ -7193,19 +8725,19 @@
           <a:lstStyle xmlns:a="http://schemas.openxmlformats.org/drawingml/2006/main"/>
           <a:p xmlns:a="http://schemas.openxmlformats.org/drawingml/2006/main">
             <a:pPr algn="ctr">
-              <a:defRPr sz="1950" b="1">
+              <a:defRPr sz="1875" b="1">
                 <a:solidFill>
                   <a:srgbClr val="D7E3F5"/>
                 </a:solidFill>
               </a:defRPr>
             </a:pPr>
             <a:r>
-              <a:rPr sz="1950" b="1">
+              <a:rPr sz="1875" b="1">
                 <a:solidFill>
                   <a:srgbClr val="D7E3F5"/>
                 </a:solidFill>
               </a:rPr>
-              <a:t>AsoulAI 让软件修复从经验猜测升级为可回放、可审计、可复用的实验闭环。</a:t>
+              <a:t>AsoulAI 让软件修复从经验猜测升级为可回放、可审计、可复用、可商业化的实验闭环。</a:t>
             </a:r>
           </a:p>
         </p:txBody>
@@ -7213,7 +8745,7 @@
     </p:spTree>
     <p:extLst>
       <p:ext uri="{BB962C8B-B14F-4D97-AF65-F5344CB8AC3E}">
-        <p14:creationId xmlns:p14="http://schemas.microsoft.com/office/powerpoint/2010/main" val="285018691"/>
+        <p14:creationId xmlns:p14="http://schemas.microsoft.com/office/powerpoint/2010/main" val="638756860"/>
       </p:ext>
     </p:extLst>
   </p:cSld>
@@ -7244,7 +8776,7 @@
           <p:cNvPr id="19" name="">
             <a:extLst xmlns:a="http://schemas.openxmlformats.org/drawingml/2006/main">
               <a:ext uri="{FF2B5EF4-FFF2-40B4-BE49-F238E27FC236}">
-                <a16:creationId xmlns:a16="http://schemas.microsoft.com/office/drawing/2014/main" id="{66135D1F-1E5C-4478-95B6-3AFBD3AF25AC}"/>
+                <a16:creationId xmlns:a16="http://schemas.microsoft.com/office/drawing/2014/main" id="{499838F3-754C-42C6-BED8-A68DE48B96DB}"/>
               </a:ext>
             </a:extLst>
           </p:cNvPr>
@@ -7294,7 +8826,7 @@
           <p:cNvPr id="2" name="">
             <a:extLst xmlns:a="http://schemas.openxmlformats.org/drawingml/2006/main">
               <a:ext uri="{FF2B5EF4-FFF2-40B4-BE49-F238E27FC236}">
-                <a16:creationId xmlns:a16="http://schemas.microsoft.com/office/drawing/2014/main" id="{0D3580E4-A335-474E-822C-3357F9FB2721}"/>
+                <a16:creationId xmlns:a16="http://schemas.microsoft.com/office/drawing/2014/main" id="{DF7CD015-EBFB-44BB-AD85-2044FE7308C1}"/>
               </a:ext>
             </a:extLst>
           </p:cNvPr>
@@ -7344,7 +8876,7 @@
           <p:cNvPr id="3" name="">
             <a:extLst xmlns:a="http://schemas.openxmlformats.org/drawingml/2006/main">
               <a:ext uri="{FF2B5EF4-FFF2-40B4-BE49-F238E27FC236}">
-                <a16:creationId xmlns:a16="http://schemas.microsoft.com/office/drawing/2014/main" id="{C77F79C7-6F3A-42EC-8EC6-F757EBC46F0D}"/>
+                <a16:creationId xmlns:a16="http://schemas.microsoft.com/office/drawing/2014/main" id="{81AF6BE6-969B-4813-B80F-E3221B7C733D}"/>
               </a:ext>
             </a:extLst>
           </p:cNvPr>
@@ -7377,7 +8909,7 @@
           <p:cNvPr id="4" name="">
             <a:extLst xmlns:a="http://schemas.openxmlformats.org/drawingml/2006/main">
               <a:ext uri="{FF2B5EF4-FFF2-40B4-BE49-F238E27FC236}">
-                <a16:creationId xmlns:a16="http://schemas.microsoft.com/office/drawing/2014/main" id="{506EB7D4-8D74-4B4D-AC42-114634315F42}"/>
+                <a16:creationId xmlns:a16="http://schemas.microsoft.com/office/drawing/2014/main" id="{38E04726-CE33-4224-B790-B6F2907B99F6}"/>
               </a:ext>
             </a:extLst>
           </p:cNvPr>
@@ -7427,7 +8959,7 @@
           <p:cNvPr id="5" name="">
             <a:extLst xmlns:a="http://schemas.openxmlformats.org/drawingml/2006/main">
               <a:ext uri="{FF2B5EF4-FFF2-40B4-BE49-F238E27FC236}">
-                <a16:creationId xmlns:a16="http://schemas.microsoft.com/office/drawing/2014/main" id="{AFBE9B35-6224-4A2D-B487-1771E8258709}"/>
+                <a16:creationId xmlns:a16="http://schemas.microsoft.com/office/drawing/2014/main" id="{50DDDF75-E2F9-41A4-BB89-F5493C0D196C}"/>
               </a:ext>
             </a:extLst>
           </p:cNvPr>
@@ -7460,7 +8992,7 @@
           <p:cNvPr id="6" name="">
             <a:extLst xmlns:a="http://schemas.openxmlformats.org/drawingml/2006/main">
               <a:ext uri="{FF2B5EF4-FFF2-40B4-BE49-F238E27FC236}">
-                <a16:creationId xmlns:a16="http://schemas.microsoft.com/office/drawing/2014/main" id="{F31370EC-BC93-44B3-943E-EF5DFBECF7F7}"/>
+                <a16:creationId xmlns:a16="http://schemas.microsoft.com/office/drawing/2014/main" id="{D7A1D7DE-3FC2-42AC-A650-5BA755BC7C7E}"/>
               </a:ext>
             </a:extLst>
           </p:cNvPr>
@@ -7510,7 +9042,7 @@
           <p:cNvPr id="7" name="">
             <a:extLst xmlns:a="http://schemas.openxmlformats.org/drawingml/2006/main">
               <a:ext uri="{FF2B5EF4-FFF2-40B4-BE49-F238E27FC236}">
-                <a16:creationId xmlns:a16="http://schemas.microsoft.com/office/drawing/2014/main" id="{512E13B0-FB1E-4733-9EB7-8086DC93E8B1}"/>
+                <a16:creationId xmlns:a16="http://schemas.microsoft.com/office/drawing/2014/main" id="{291BD26B-2693-443E-B0BA-C016F73B30B0}"/>
               </a:ext>
             </a:extLst>
           </p:cNvPr>
@@ -7543,7 +9075,7 @@
           <p:cNvPr id="8" name="">
             <a:extLst xmlns:a="http://schemas.openxmlformats.org/drawingml/2006/main">
               <a:ext uri="{FF2B5EF4-FFF2-40B4-BE49-F238E27FC236}">
-                <a16:creationId xmlns:a16="http://schemas.microsoft.com/office/drawing/2014/main" id="{CF383BC5-B273-445A-94E7-5EED3A4887A5}"/>
+                <a16:creationId xmlns:a16="http://schemas.microsoft.com/office/drawing/2014/main" id="{337043DF-2D86-4CBE-8227-1CC8AFD4091D}"/>
               </a:ext>
             </a:extLst>
           </p:cNvPr>
@@ -7593,7 +9125,7 @@
           <p:cNvPr id="9" name="">
             <a:extLst xmlns:a="http://schemas.openxmlformats.org/drawingml/2006/main">
               <a:ext uri="{FF2B5EF4-FFF2-40B4-BE49-F238E27FC236}">
-                <a16:creationId xmlns:a16="http://schemas.microsoft.com/office/drawing/2014/main" id="{F9A06C6B-9F80-4924-917E-5152110BA536}"/>
+                <a16:creationId xmlns:a16="http://schemas.microsoft.com/office/drawing/2014/main" id="{5E9AC3E0-59FE-4741-98E7-A3A8DB046F95}"/>
               </a:ext>
             </a:extLst>
           </p:cNvPr>
@@ -7643,7 +9175,7 @@
           <p:cNvPr id="10" name="">
             <a:extLst xmlns:a="http://schemas.openxmlformats.org/drawingml/2006/main">
               <a:ext uri="{FF2B5EF4-FFF2-40B4-BE49-F238E27FC236}">
-                <a16:creationId xmlns:a16="http://schemas.microsoft.com/office/drawing/2014/main" id="{910B5D5E-5E90-400D-914C-BA6262F5A555}"/>
+                <a16:creationId xmlns:a16="http://schemas.microsoft.com/office/drawing/2014/main" id="{1EF09146-4D8A-428D-8C66-5E6D21265B8E}"/>
               </a:ext>
             </a:extLst>
           </p:cNvPr>
@@ -7693,7 +9225,7 @@
           <p:cNvPr id="11" name="">
             <a:extLst xmlns:a="http://schemas.openxmlformats.org/drawingml/2006/main">
               <a:ext uri="{FF2B5EF4-FFF2-40B4-BE49-F238E27FC236}">
-                <a16:creationId xmlns:a16="http://schemas.microsoft.com/office/drawing/2014/main" id="{0C944CB3-61DA-49DA-B3B2-1BFB26E51C3E}"/>
+                <a16:creationId xmlns:a16="http://schemas.microsoft.com/office/drawing/2014/main" id="{1D53A534-A76C-4C16-BA79-D07727BC408B}"/>
               </a:ext>
             </a:extLst>
           </p:cNvPr>
@@ -7743,7 +9275,7 @@
           <p:cNvPr id="12" name="">
             <a:extLst xmlns:a="http://schemas.openxmlformats.org/drawingml/2006/main">
               <a:ext uri="{FF2B5EF4-FFF2-40B4-BE49-F238E27FC236}">
-                <a16:creationId xmlns:a16="http://schemas.microsoft.com/office/drawing/2014/main" id="{9F1DF08C-65FA-49C5-BD00-98CC21C4496C}"/>
+                <a16:creationId xmlns:a16="http://schemas.microsoft.com/office/drawing/2014/main" id="{670B208C-E32C-48ED-B83F-869079F2B071}"/>
               </a:ext>
             </a:extLst>
           </p:cNvPr>
@@ -7793,7 +9325,7 @@
           <p:cNvPr id="13" name="">
             <a:extLst xmlns:a="http://schemas.openxmlformats.org/drawingml/2006/main">
               <a:ext uri="{FF2B5EF4-FFF2-40B4-BE49-F238E27FC236}">
-                <a16:creationId xmlns:a16="http://schemas.microsoft.com/office/drawing/2014/main" id="{B217221F-3707-4B32-BAD7-3D1329BAB421}"/>
+                <a16:creationId xmlns:a16="http://schemas.microsoft.com/office/drawing/2014/main" id="{16FA4A30-A70F-4D4C-8C01-99C39EC671AE}"/>
               </a:ext>
             </a:extLst>
           </p:cNvPr>
@@ -7843,7 +9375,7 @@
           <p:cNvPr id="14" name="">
             <a:extLst xmlns:a="http://schemas.openxmlformats.org/drawingml/2006/main">
               <a:ext uri="{FF2B5EF4-FFF2-40B4-BE49-F238E27FC236}">
-                <a16:creationId xmlns:a16="http://schemas.microsoft.com/office/drawing/2014/main" id="{CCD5B553-18D7-4533-BDC8-BB0259DA8EFD}"/>
+                <a16:creationId xmlns:a16="http://schemas.microsoft.com/office/drawing/2014/main" id="{832C1FEF-BFD9-444B-AFC1-C8D79A1F734F}"/>
               </a:ext>
             </a:extLst>
           </p:cNvPr>
@@ -7893,7 +9425,7 @@
           <p:cNvPr id="15" name="">
             <a:extLst xmlns:a="http://schemas.openxmlformats.org/drawingml/2006/main">
               <a:ext uri="{FF2B5EF4-FFF2-40B4-BE49-F238E27FC236}">
-                <a16:creationId xmlns:a16="http://schemas.microsoft.com/office/drawing/2014/main" id="{F318F0D3-6D08-4371-97DF-4FF14A8E283E}"/>
+                <a16:creationId xmlns:a16="http://schemas.microsoft.com/office/drawing/2014/main" id="{8A4C9D28-CE8A-46B2-959F-71EC6C395DEF}"/>
               </a:ext>
             </a:extLst>
           </p:cNvPr>
@@ -7943,7 +9475,7 @@
           <p:cNvPr id="16" name="">
             <a:extLst xmlns:a="http://schemas.openxmlformats.org/drawingml/2006/main">
               <a:ext uri="{FF2B5EF4-FFF2-40B4-BE49-F238E27FC236}">
-                <a16:creationId xmlns:a16="http://schemas.microsoft.com/office/drawing/2014/main" id="{11C326D2-ED64-49DD-AAEE-348824FD1D95}"/>
+                <a16:creationId xmlns:a16="http://schemas.microsoft.com/office/drawing/2014/main" id="{826C2458-4754-42DD-88B5-2CAE6E56F821}"/>
               </a:ext>
             </a:extLst>
           </p:cNvPr>
@@ -7993,7 +9525,7 @@
           <p:cNvPr id="17" name="">
             <a:extLst xmlns:a="http://schemas.openxmlformats.org/drawingml/2006/main">
               <a:ext uri="{FF2B5EF4-FFF2-40B4-BE49-F238E27FC236}">
-                <a16:creationId xmlns:a16="http://schemas.microsoft.com/office/drawing/2014/main" id="{FE18B88F-869E-4063-A1C2-A1282A5140AC}"/>
+                <a16:creationId xmlns:a16="http://schemas.microsoft.com/office/drawing/2014/main" id="{39B409DF-1363-41B8-96A4-989F15FE592C}"/>
               </a:ext>
             </a:extLst>
           </p:cNvPr>
@@ -8043,7 +9575,7 @@
           <p:cNvPr id="18" name="">
             <a:extLst xmlns:a="http://schemas.openxmlformats.org/drawingml/2006/main">
               <a:ext uri="{FF2B5EF4-FFF2-40B4-BE49-F238E27FC236}">
-                <a16:creationId xmlns:a16="http://schemas.microsoft.com/office/drawing/2014/main" id="{94E4B32F-F08A-46EA-8F59-488A68FD5F0E}"/>
+                <a16:creationId xmlns:a16="http://schemas.microsoft.com/office/drawing/2014/main" id="{A6D6D12F-1159-4AC4-A381-AB8E936ADBD8}"/>
               </a:ext>
             </a:extLst>
           </p:cNvPr>
@@ -8091,7 +9623,7 @@
     </p:spTree>
     <p:extLst>
       <p:ext uri="{BB962C8B-B14F-4D97-AF65-F5344CB8AC3E}">
-        <p14:creationId xmlns:p14="http://schemas.microsoft.com/office/powerpoint/2010/main" val="2105469125"/>
+        <p14:creationId xmlns:p14="http://schemas.microsoft.com/office/powerpoint/2010/main" val="1891141890"/>
       </p:ext>
     </p:extLst>
   </p:cSld>
@@ -8122,7 +9654,7 @@
           <p:cNvPr id="25" name="">
             <a:extLst xmlns:a="http://schemas.openxmlformats.org/drawingml/2006/main">
               <a:ext uri="{FF2B5EF4-FFF2-40B4-BE49-F238E27FC236}">
-                <a16:creationId xmlns:a16="http://schemas.microsoft.com/office/drawing/2014/main" id="{CBF75915-9CBF-4FA7-8A1A-A9C30EA68458}"/>
+                <a16:creationId xmlns:a16="http://schemas.microsoft.com/office/drawing/2014/main" id="{7406BB68-E88D-4DC2-A0D0-54C3EE04DD28}"/>
               </a:ext>
             </a:extLst>
           </p:cNvPr>
@@ -8172,7 +9704,7 @@
           <p:cNvPr id="2" name="">
             <a:extLst xmlns:a="http://schemas.openxmlformats.org/drawingml/2006/main">
               <a:ext uri="{FF2B5EF4-FFF2-40B4-BE49-F238E27FC236}">
-                <a16:creationId xmlns:a16="http://schemas.microsoft.com/office/drawing/2014/main" id="{C12BB7A4-CCF3-4ADA-BF07-1AD4C8B6AF6D}"/>
+                <a16:creationId xmlns:a16="http://schemas.microsoft.com/office/drawing/2014/main" id="{77670B9B-B2E1-47CC-BAA5-D441BBB4E4C8}"/>
               </a:ext>
             </a:extLst>
           </p:cNvPr>
@@ -8222,7 +9754,7 @@
           <p:cNvPr id="3" name="">
             <a:extLst xmlns:a="http://schemas.openxmlformats.org/drawingml/2006/main">
               <a:ext uri="{FF2B5EF4-FFF2-40B4-BE49-F238E27FC236}">
-                <a16:creationId xmlns:a16="http://schemas.microsoft.com/office/drawing/2014/main" id="{57DADC5F-9D71-40CD-BA80-5242D1759AB9}"/>
+                <a16:creationId xmlns:a16="http://schemas.microsoft.com/office/drawing/2014/main" id="{716C3131-D917-4720-89F7-8BF4375BBAA1}"/>
               </a:ext>
             </a:extLst>
           </p:cNvPr>
@@ -8257,7 +9789,7 @@
           <p:cNvPr id="4" name="">
             <a:extLst xmlns:a="http://schemas.openxmlformats.org/drawingml/2006/main">
               <a:ext uri="{FF2B5EF4-FFF2-40B4-BE49-F238E27FC236}">
-                <a16:creationId xmlns:a16="http://schemas.microsoft.com/office/drawing/2014/main" id="{9B01CDBA-B463-4349-9CB5-0ACB69F420F8}"/>
+                <a16:creationId xmlns:a16="http://schemas.microsoft.com/office/drawing/2014/main" id="{3677973B-AF82-4B97-8E13-C37640DDC984}"/>
               </a:ext>
             </a:extLst>
           </p:cNvPr>
@@ -8307,7 +9839,7 @@
           <p:cNvPr id="5" name="">
             <a:extLst xmlns:a="http://schemas.openxmlformats.org/drawingml/2006/main">
               <a:ext uri="{FF2B5EF4-FFF2-40B4-BE49-F238E27FC236}">
-                <a16:creationId xmlns:a16="http://schemas.microsoft.com/office/drawing/2014/main" id="{8A9871E1-5124-4399-AB49-14955C83AF5F}"/>
+                <a16:creationId xmlns:a16="http://schemas.microsoft.com/office/drawing/2014/main" id="{2617D2D5-BA6E-43E7-988C-E7DCD61DE139}"/>
               </a:ext>
             </a:extLst>
           </p:cNvPr>
@@ -8357,7 +9889,7 @@
           <p:cNvPr id="6" name="">
             <a:extLst xmlns:a="http://schemas.openxmlformats.org/drawingml/2006/main">
               <a:ext uri="{FF2B5EF4-FFF2-40B4-BE49-F238E27FC236}">
-                <a16:creationId xmlns:a16="http://schemas.microsoft.com/office/drawing/2014/main" id="{18357ADC-77BF-421E-A51F-3512FF39C0EE}"/>
+                <a16:creationId xmlns:a16="http://schemas.microsoft.com/office/drawing/2014/main" id="{DB74D419-2A56-4A5F-9EDE-3F15525149DB}"/>
               </a:ext>
             </a:extLst>
           </p:cNvPr>
@@ -8388,7 +9920,7 @@
           <p:cNvPr id="7" name="">
             <a:extLst xmlns:a="http://schemas.openxmlformats.org/drawingml/2006/main">
               <a:ext uri="{FF2B5EF4-FFF2-40B4-BE49-F238E27FC236}">
-                <a16:creationId xmlns:a16="http://schemas.microsoft.com/office/drawing/2014/main" id="{ADD4FE83-5F4F-4DC7-8CB0-339B40B749B7}"/>
+                <a16:creationId xmlns:a16="http://schemas.microsoft.com/office/drawing/2014/main" id="{9F543D9C-871B-470A-ABCF-544372352D7B}"/>
               </a:ext>
             </a:extLst>
           </p:cNvPr>
@@ -8423,7 +9955,7 @@
           <p:cNvPr id="8" name="">
             <a:extLst xmlns:a="http://schemas.openxmlformats.org/drawingml/2006/main">
               <a:ext uri="{FF2B5EF4-FFF2-40B4-BE49-F238E27FC236}">
-                <a16:creationId xmlns:a16="http://schemas.microsoft.com/office/drawing/2014/main" id="{C52C4F35-BE5C-4378-AE18-B71C656845CD}"/>
+                <a16:creationId xmlns:a16="http://schemas.microsoft.com/office/drawing/2014/main" id="{98A39672-EA43-4361-9E35-8F75E0984CA4}"/>
               </a:ext>
             </a:extLst>
           </p:cNvPr>
@@ -8473,7 +10005,7 @@
           <p:cNvPr id="9" name="">
             <a:extLst xmlns:a="http://schemas.openxmlformats.org/drawingml/2006/main">
               <a:ext uri="{FF2B5EF4-FFF2-40B4-BE49-F238E27FC236}">
-                <a16:creationId xmlns:a16="http://schemas.microsoft.com/office/drawing/2014/main" id="{ED50E6AF-E75A-4997-BD49-CF1707FAD7EA}"/>
+                <a16:creationId xmlns:a16="http://schemas.microsoft.com/office/drawing/2014/main" id="{A019208D-0717-46C2-9538-9420D802D081}"/>
               </a:ext>
             </a:extLst>
           </p:cNvPr>
@@ -8523,7 +10055,7 @@
           <p:cNvPr id="10" name="">
             <a:extLst xmlns:a="http://schemas.openxmlformats.org/drawingml/2006/main">
               <a:ext uri="{FF2B5EF4-FFF2-40B4-BE49-F238E27FC236}">
-                <a16:creationId xmlns:a16="http://schemas.microsoft.com/office/drawing/2014/main" id="{38E1480B-5B41-42BF-8314-F7E0A7B88366}"/>
+                <a16:creationId xmlns:a16="http://schemas.microsoft.com/office/drawing/2014/main" id="{32B7F416-2D98-412B-AB2E-0C76628834E7}"/>
               </a:ext>
             </a:extLst>
           </p:cNvPr>
@@ -8554,7 +10086,7 @@
           <p:cNvPr id="11" name="">
             <a:extLst xmlns:a="http://schemas.openxmlformats.org/drawingml/2006/main">
               <a:ext uri="{FF2B5EF4-FFF2-40B4-BE49-F238E27FC236}">
-                <a16:creationId xmlns:a16="http://schemas.microsoft.com/office/drawing/2014/main" id="{607280FB-7470-4A89-AB0F-93BD7C8EB9E8}"/>
+                <a16:creationId xmlns:a16="http://schemas.microsoft.com/office/drawing/2014/main" id="{2C512156-5A68-4594-9D6E-1A642E0F30B2}"/>
               </a:ext>
             </a:extLst>
           </p:cNvPr>
@@ -8589,7 +10121,7 @@
           <p:cNvPr id="12" name="">
             <a:extLst xmlns:a="http://schemas.openxmlformats.org/drawingml/2006/main">
               <a:ext uri="{FF2B5EF4-FFF2-40B4-BE49-F238E27FC236}">
-                <a16:creationId xmlns:a16="http://schemas.microsoft.com/office/drawing/2014/main" id="{CB2DF1C5-979E-47FE-9A0B-23916B94A23C}"/>
+                <a16:creationId xmlns:a16="http://schemas.microsoft.com/office/drawing/2014/main" id="{B0C5BD7E-BD13-452B-AEDC-554FBC7DD824}"/>
               </a:ext>
             </a:extLst>
           </p:cNvPr>
@@ -8639,7 +10171,7 @@
           <p:cNvPr id="13" name="">
             <a:extLst xmlns:a="http://schemas.openxmlformats.org/drawingml/2006/main">
               <a:ext uri="{FF2B5EF4-FFF2-40B4-BE49-F238E27FC236}">
-                <a16:creationId xmlns:a16="http://schemas.microsoft.com/office/drawing/2014/main" id="{DF93618B-1A74-4795-BA46-5071C55BF155}"/>
+                <a16:creationId xmlns:a16="http://schemas.microsoft.com/office/drawing/2014/main" id="{89726B03-D7C3-43E5-820E-6AB8CCB40277}"/>
               </a:ext>
             </a:extLst>
           </p:cNvPr>
@@ -8689,7 +10221,7 @@
           <p:cNvPr id="14" name="">
             <a:extLst xmlns:a="http://schemas.openxmlformats.org/drawingml/2006/main">
               <a:ext uri="{FF2B5EF4-FFF2-40B4-BE49-F238E27FC236}">
-                <a16:creationId xmlns:a16="http://schemas.microsoft.com/office/drawing/2014/main" id="{FCEC27C0-F292-4E80-A244-90033B9B5472}"/>
+                <a16:creationId xmlns:a16="http://schemas.microsoft.com/office/drawing/2014/main" id="{91C9CEC7-AB42-42B0-B588-6979626F9281}"/>
               </a:ext>
             </a:extLst>
           </p:cNvPr>
@@ -8720,7 +10252,7 @@
           <p:cNvPr id="15" name="">
             <a:extLst xmlns:a="http://schemas.openxmlformats.org/drawingml/2006/main">
               <a:ext uri="{FF2B5EF4-FFF2-40B4-BE49-F238E27FC236}">
-                <a16:creationId xmlns:a16="http://schemas.microsoft.com/office/drawing/2014/main" id="{39A2AB93-481C-42F1-B030-E76B9720C8C5}"/>
+                <a16:creationId xmlns:a16="http://schemas.microsoft.com/office/drawing/2014/main" id="{72560427-E35B-4391-AC23-4B2F00359A57}"/>
               </a:ext>
             </a:extLst>
           </p:cNvPr>
@@ -8755,7 +10287,7 @@
           <p:cNvPr id="16" name="">
             <a:extLst xmlns:a="http://schemas.openxmlformats.org/drawingml/2006/main">
               <a:ext uri="{FF2B5EF4-FFF2-40B4-BE49-F238E27FC236}">
-                <a16:creationId xmlns:a16="http://schemas.microsoft.com/office/drawing/2014/main" id="{36972917-099B-420A-9404-C69E69AA8792}"/>
+                <a16:creationId xmlns:a16="http://schemas.microsoft.com/office/drawing/2014/main" id="{2810A91F-34D6-48B8-887D-93F2425FB2A3}"/>
               </a:ext>
             </a:extLst>
           </p:cNvPr>
@@ -8805,7 +10337,7 @@
           <p:cNvPr id="17" name="">
             <a:extLst xmlns:a="http://schemas.openxmlformats.org/drawingml/2006/main">
               <a:ext uri="{FF2B5EF4-FFF2-40B4-BE49-F238E27FC236}">
-                <a16:creationId xmlns:a16="http://schemas.microsoft.com/office/drawing/2014/main" id="{15EF0792-BA55-48A3-A7A8-5E6E089F1F7F}"/>
+                <a16:creationId xmlns:a16="http://schemas.microsoft.com/office/drawing/2014/main" id="{7786ED18-D303-411E-920B-4DD432C9D343}"/>
               </a:ext>
             </a:extLst>
           </p:cNvPr>
@@ -8855,7 +10387,7 @@
           <p:cNvPr id="18" name="">
             <a:extLst xmlns:a="http://schemas.openxmlformats.org/drawingml/2006/main">
               <a:ext uri="{FF2B5EF4-FFF2-40B4-BE49-F238E27FC236}">
-                <a16:creationId xmlns:a16="http://schemas.microsoft.com/office/drawing/2014/main" id="{DE73974B-1468-4138-A614-D3E5B016DC76}"/>
+                <a16:creationId xmlns:a16="http://schemas.microsoft.com/office/drawing/2014/main" id="{D86395CB-F64B-49E1-8E1B-B6D8345E3DAD}"/>
               </a:ext>
             </a:extLst>
           </p:cNvPr>
@@ -8886,7 +10418,7 @@
           <p:cNvPr id="19" name="">
             <a:extLst xmlns:a="http://schemas.openxmlformats.org/drawingml/2006/main">
               <a:ext uri="{FF2B5EF4-FFF2-40B4-BE49-F238E27FC236}">
-                <a16:creationId xmlns:a16="http://schemas.microsoft.com/office/drawing/2014/main" id="{E74675B5-3C84-4FAA-97C1-DE6DD519A2F1}"/>
+                <a16:creationId xmlns:a16="http://schemas.microsoft.com/office/drawing/2014/main" id="{59E58795-3D41-4BBB-8568-B180045E603A}"/>
               </a:ext>
             </a:extLst>
           </p:cNvPr>
@@ -8921,7 +10453,7 @@
           <p:cNvPr id="20" name="">
             <a:extLst xmlns:a="http://schemas.openxmlformats.org/drawingml/2006/main">
               <a:ext uri="{FF2B5EF4-FFF2-40B4-BE49-F238E27FC236}">
-                <a16:creationId xmlns:a16="http://schemas.microsoft.com/office/drawing/2014/main" id="{857C7D0E-3B1F-45A2-8D7A-20208F084D91}"/>
+                <a16:creationId xmlns:a16="http://schemas.microsoft.com/office/drawing/2014/main" id="{57E32076-E1B6-4825-8AC2-E6A75C40C3B4}"/>
               </a:ext>
             </a:extLst>
           </p:cNvPr>
@@ -8971,7 +10503,7 @@
           <p:cNvPr id="21" name="">
             <a:extLst xmlns:a="http://schemas.openxmlformats.org/drawingml/2006/main">
               <a:ext uri="{FF2B5EF4-FFF2-40B4-BE49-F238E27FC236}">
-                <a16:creationId xmlns:a16="http://schemas.microsoft.com/office/drawing/2014/main" id="{3A3D72B3-997E-4DDE-9FE5-9D3F2D9574B5}"/>
+                <a16:creationId xmlns:a16="http://schemas.microsoft.com/office/drawing/2014/main" id="{BCE21CEA-BCA5-4C4E-A294-034AD5232174}"/>
               </a:ext>
             </a:extLst>
           </p:cNvPr>
@@ -9021,7 +10553,7 @@
           <p:cNvPr id="22" name="">
             <a:extLst xmlns:a="http://schemas.openxmlformats.org/drawingml/2006/main">
               <a:ext uri="{FF2B5EF4-FFF2-40B4-BE49-F238E27FC236}">
-                <a16:creationId xmlns:a16="http://schemas.microsoft.com/office/drawing/2014/main" id="{E75404BE-A9F8-4A17-AABB-8998F0D44EEF}"/>
+                <a16:creationId xmlns:a16="http://schemas.microsoft.com/office/drawing/2014/main" id="{79D92E69-1FE3-45A7-9D41-08D723FAFB26}"/>
               </a:ext>
             </a:extLst>
           </p:cNvPr>
@@ -9071,7 +10603,7 @@
           <p:cNvPr id="23" name="">
             <a:extLst xmlns:a="http://schemas.openxmlformats.org/drawingml/2006/main">
               <a:ext uri="{FF2B5EF4-FFF2-40B4-BE49-F238E27FC236}">
-                <a16:creationId xmlns:a16="http://schemas.microsoft.com/office/drawing/2014/main" id="{1D3FF711-968D-400A-B08D-F2CDFDCB72C0}"/>
+                <a16:creationId xmlns:a16="http://schemas.microsoft.com/office/drawing/2014/main" id="{D11D1307-2082-4A6C-9F09-6D042AA20942}"/>
               </a:ext>
             </a:extLst>
           </p:cNvPr>
@@ -9121,7 +10653,7 @@
           <p:cNvPr id="24" name="">
             <a:extLst xmlns:a="http://schemas.openxmlformats.org/drawingml/2006/main">
               <a:ext uri="{FF2B5EF4-FFF2-40B4-BE49-F238E27FC236}">
-                <a16:creationId xmlns:a16="http://schemas.microsoft.com/office/drawing/2014/main" id="{14BC4815-0BA0-43E0-82BE-A4CC6172C7CF}"/>
+                <a16:creationId xmlns:a16="http://schemas.microsoft.com/office/drawing/2014/main" id="{A886E21C-44C5-4C3E-BAAD-1AC0D11CB4DC}"/>
               </a:ext>
             </a:extLst>
           </p:cNvPr>
@@ -9169,7 +10701,7 @@
     </p:spTree>
     <p:extLst>
       <p:ext uri="{BB962C8B-B14F-4D97-AF65-F5344CB8AC3E}">
-        <p14:creationId xmlns:p14="http://schemas.microsoft.com/office/powerpoint/2010/main" val="1902812639"/>
+        <p14:creationId xmlns:p14="http://schemas.microsoft.com/office/powerpoint/2010/main" val="1934992382"/>
       </p:ext>
     </p:extLst>
   </p:cSld>
@@ -9200,7 +10732,7 @@
           <p:cNvPr id="40" name="">
             <a:extLst xmlns:a="http://schemas.openxmlformats.org/drawingml/2006/main">
               <a:ext uri="{FF2B5EF4-FFF2-40B4-BE49-F238E27FC236}">
-                <a16:creationId xmlns:a16="http://schemas.microsoft.com/office/drawing/2014/main" id="{BB78EB8D-2C73-43BD-B224-9FAEFBBDE644}"/>
+                <a16:creationId xmlns:a16="http://schemas.microsoft.com/office/drawing/2014/main" id="{FDBDABBD-AC8A-45F3-81AF-2BE0FC859F2C}"/>
               </a:ext>
             </a:extLst>
           </p:cNvPr>
@@ -9250,7 +10782,7 @@
           <p:cNvPr id="2" name="">
             <a:extLst xmlns:a="http://schemas.openxmlformats.org/drawingml/2006/main">
               <a:ext uri="{FF2B5EF4-FFF2-40B4-BE49-F238E27FC236}">
-                <a16:creationId xmlns:a16="http://schemas.microsoft.com/office/drawing/2014/main" id="{10EABEDD-C1E3-4295-AE56-9B185747562D}"/>
+                <a16:creationId xmlns:a16="http://schemas.microsoft.com/office/drawing/2014/main" id="{6400A0E8-4037-4DB6-81F9-6C8185FB0B45}"/>
               </a:ext>
             </a:extLst>
           </p:cNvPr>
@@ -9300,7 +10832,7 @@
           <p:cNvPr id="3" name="">
             <a:extLst xmlns:a="http://schemas.openxmlformats.org/drawingml/2006/main">
               <a:ext uri="{FF2B5EF4-FFF2-40B4-BE49-F238E27FC236}">
-                <a16:creationId xmlns:a16="http://schemas.microsoft.com/office/drawing/2014/main" id="{0BDFD83A-9854-41B7-8CBA-F1171BBD3E1E}"/>
+                <a16:creationId xmlns:a16="http://schemas.microsoft.com/office/drawing/2014/main" id="{99A132BA-0197-4264-B084-AC0F5B58379D}"/>
               </a:ext>
             </a:extLst>
           </p:cNvPr>
@@ -9335,7 +10867,7 @@
           <p:cNvPr id="4" name="">
             <a:extLst xmlns:a="http://schemas.openxmlformats.org/drawingml/2006/main">
               <a:ext uri="{FF2B5EF4-FFF2-40B4-BE49-F238E27FC236}">
-                <a16:creationId xmlns:a16="http://schemas.microsoft.com/office/drawing/2014/main" id="{8BD558F2-612D-4E26-B051-57D271F496F0}"/>
+                <a16:creationId xmlns:a16="http://schemas.microsoft.com/office/drawing/2014/main" id="{0046CEB5-E920-4A52-926F-6F2078F4A6FF}"/>
               </a:ext>
             </a:extLst>
           </p:cNvPr>
@@ -9385,7 +10917,7 @@
           <p:cNvPr id="5" name="">
             <a:extLst xmlns:a="http://schemas.openxmlformats.org/drawingml/2006/main">
               <a:ext uri="{FF2B5EF4-FFF2-40B4-BE49-F238E27FC236}">
-                <a16:creationId xmlns:a16="http://schemas.microsoft.com/office/drawing/2014/main" id="{4815651E-ABDA-42A2-A6EF-E1480D8137DB}"/>
+                <a16:creationId xmlns:a16="http://schemas.microsoft.com/office/drawing/2014/main" id="{3DF41F4C-8121-4902-82F4-79D7A6BA8372}"/>
               </a:ext>
             </a:extLst>
           </p:cNvPr>
@@ -9452,7 +10984,7 @@
           <p:cNvPr id="6" name="">
             <a:extLst xmlns:a="http://schemas.openxmlformats.org/drawingml/2006/main">
               <a:ext uri="{FF2B5EF4-FFF2-40B4-BE49-F238E27FC236}">
-                <a16:creationId xmlns:a16="http://schemas.microsoft.com/office/drawing/2014/main" id="{34E5411B-C722-4BF6-A0B7-0CC24965A92A}"/>
+                <a16:creationId xmlns:a16="http://schemas.microsoft.com/office/drawing/2014/main" id="{FCD55119-95D7-4249-B3C9-AC95981FF43A}"/>
               </a:ext>
             </a:extLst>
           </p:cNvPr>
@@ -9483,7 +11015,7 @@
           <p:cNvPr id="7" name="">
             <a:extLst xmlns:a="http://schemas.openxmlformats.org/drawingml/2006/main">
               <a:ext uri="{FF2B5EF4-FFF2-40B4-BE49-F238E27FC236}">
-                <a16:creationId xmlns:a16="http://schemas.microsoft.com/office/drawing/2014/main" id="{ABC50AF4-A603-4326-96C1-B4B24E0F6F9D}"/>
+                <a16:creationId xmlns:a16="http://schemas.microsoft.com/office/drawing/2014/main" id="{509D2BF9-5194-4A08-A2D7-C2D6221A4EE1}"/>
               </a:ext>
             </a:extLst>
           </p:cNvPr>
@@ -9518,7 +11050,7 @@
           <p:cNvPr id="8" name="">
             <a:extLst xmlns:a="http://schemas.openxmlformats.org/drawingml/2006/main">
               <a:ext uri="{FF2B5EF4-FFF2-40B4-BE49-F238E27FC236}">
-                <a16:creationId xmlns:a16="http://schemas.microsoft.com/office/drawing/2014/main" id="{71303CFC-140C-4867-9ED6-E940E0406CE4}"/>
+                <a16:creationId xmlns:a16="http://schemas.microsoft.com/office/drawing/2014/main" id="{E7D9CB6B-4638-43BB-B265-B65A70DA1D7B}"/>
               </a:ext>
             </a:extLst>
           </p:cNvPr>
@@ -9568,7 +11100,7 @@
           <p:cNvPr id="9" name="">
             <a:extLst xmlns:a="http://schemas.openxmlformats.org/drawingml/2006/main">
               <a:ext uri="{FF2B5EF4-FFF2-40B4-BE49-F238E27FC236}">
-                <a16:creationId xmlns:a16="http://schemas.microsoft.com/office/drawing/2014/main" id="{6E2B9761-73B1-4542-9D8F-EBB63FE9B93E}"/>
+                <a16:creationId xmlns:a16="http://schemas.microsoft.com/office/drawing/2014/main" id="{277E7163-8748-43DF-B7C6-1A33BE1AF07C}"/>
               </a:ext>
             </a:extLst>
           </p:cNvPr>
@@ -9635,7 +11167,7 @@
           <p:cNvPr id="10" name="">
             <a:extLst xmlns:a="http://schemas.openxmlformats.org/drawingml/2006/main">
               <a:ext uri="{FF2B5EF4-FFF2-40B4-BE49-F238E27FC236}">
-                <a16:creationId xmlns:a16="http://schemas.microsoft.com/office/drawing/2014/main" id="{1C85F167-72DC-4321-8881-87185C2495A2}"/>
+                <a16:creationId xmlns:a16="http://schemas.microsoft.com/office/drawing/2014/main" id="{74B6403D-59CF-436A-98E5-4C8EF24CBB63}"/>
               </a:ext>
             </a:extLst>
           </p:cNvPr>
@@ -9666,7 +11198,7 @@
           <p:cNvPr id="11" name="">
             <a:extLst xmlns:a="http://schemas.openxmlformats.org/drawingml/2006/main">
               <a:ext uri="{FF2B5EF4-FFF2-40B4-BE49-F238E27FC236}">
-                <a16:creationId xmlns:a16="http://schemas.microsoft.com/office/drawing/2014/main" id="{DA6710AD-5CA9-4003-9800-7E9522EFBB5F}"/>
+                <a16:creationId xmlns:a16="http://schemas.microsoft.com/office/drawing/2014/main" id="{346F010F-68CB-4881-9565-857258B708D4}"/>
               </a:ext>
             </a:extLst>
           </p:cNvPr>
@@ -9701,7 +11233,7 @@
           <p:cNvPr id="12" name="">
             <a:extLst xmlns:a="http://schemas.openxmlformats.org/drawingml/2006/main">
               <a:ext uri="{FF2B5EF4-FFF2-40B4-BE49-F238E27FC236}">
-                <a16:creationId xmlns:a16="http://schemas.microsoft.com/office/drawing/2014/main" id="{8D0C0383-3604-4667-BA01-18B34C0F5018}"/>
+                <a16:creationId xmlns:a16="http://schemas.microsoft.com/office/drawing/2014/main" id="{FB75D1B1-9FC1-4386-986C-8B22116202AB}"/>
               </a:ext>
             </a:extLst>
           </p:cNvPr>
@@ -9751,7 +11283,7 @@
           <p:cNvPr id="13" name="">
             <a:extLst xmlns:a="http://schemas.openxmlformats.org/drawingml/2006/main">
               <a:ext uri="{FF2B5EF4-FFF2-40B4-BE49-F238E27FC236}">
-                <a16:creationId xmlns:a16="http://schemas.microsoft.com/office/drawing/2014/main" id="{7CF65DC5-BA8B-468D-865B-B74CA77F89D1}"/>
+                <a16:creationId xmlns:a16="http://schemas.microsoft.com/office/drawing/2014/main" id="{1983E9B5-72A5-4233-B95D-88F8F7A02587}"/>
               </a:ext>
             </a:extLst>
           </p:cNvPr>
@@ -9818,7 +11350,7 @@
           <p:cNvPr id="14" name="">
             <a:extLst xmlns:a="http://schemas.openxmlformats.org/drawingml/2006/main">
               <a:ext uri="{FF2B5EF4-FFF2-40B4-BE49-F238E27FC236}">
-                <a16:creationId xmlns:a16="http://schemas.microsoft.com/office/drawing/2014/main" id="{8F9904E0-34C0-4CEF-B503-A7DEC2F519C2}"/>
+                <a16:creationId xmlns:a16="http://schemas.microsoft.com/office/drawing/2014/main" id="{B920A83D-EB21-4EFA-B691-E6F418869964}"/>
               </a:ext>
             </a:extLst>
           </p:cNvPr>
@@ -9849,7 +11381,7 @@
           <p:cNvPr id="15" name="">
             <a:extLst xmlns:a="http://schemas.openxmlformats.org/drawingml/2006/main">
               <a:ext uri="{FF2B5EF4-FFF2-40B4-BE49-F238E27FC236}">
-                <a16:creationId xmlns:a16="http://schemas.microsoft.com/office/drawing/2014/main" id="{89FB2C83-DB1E-46AE-BD97-FFDE759E166F}"/>
+                <a16:creationId xmlns:a16="http://schemas.microsoft.com/office/drawing/2014/main" id="{1A2E9066-BF67-469A-8CAA-69F0845AD6FB}"/>
               </a:ext>
             </a:extLst>
           </p:cNvPr>
@@ -9884,7 +11416,7 @@
           <p:cNvPr id="16" name="">
             <a:extLst xmlns:a="http://schemas.openxmlformats.org/drawingml/2006/main">
               <a:ext uri="{FF2B5EF4-FFF2-40B4-BE49-F238E27FC236}">
-                <a16:creationId xmlns:a16="http://schemas.microsoft.com/office/drawing/2014/main" id="{2A9A883B-B948-49AE-850A-D02E03B11C85}"/>
+                <a16:creationId xmlns:a16="http://schemas.microsoft.com/office/drawing/2014/main" id="{7E0B0B0F-4BBD-4C96-854D-67DBF0E8EE66}"/>
               </a:ext>
             </a:extLst>
           </p:cNvPr>
@@ -9934,7 +11466,7 @@
           <p:cNvPr id="17" name="">
             <a:extLst xmlns:a="http://schemas.openxmlformats.org/drawingml/2006/main">
               <a:ext uri="{FF2B5EF4-FFF2-40B4-BE49-F238E27FC236}">
-                <a16:creationId xmlns:a16="http://schemas.microsoft.com/office/drawing/2014/main" id="{0F0FF8ED-F174-4C60-97BD-C460C7F1DCE0}"/>
+                <a16:creationId xmlns:a16="http://schemas.microsoft.com/office/drawing/2014/main" id="{8F997984-925A-409B-BCE3-0456D32B93D9}"/>
               </a:ext>
             </a:extLst>
           </p:cNvPr>
@@ -10001,7 +11533,7 @@
           <p:cNvPr id="18" name="">
             <a:extLst xmlns:a="http://schemas.openxmlformats.org/drawingml/2006/main">
               <a:ext uri="{FF2B5EF4-FFF2-40B4-BE49-F238E27FC236}">
-                <a16:creationId xmlns:a16="http://schemas.microsoft.com/office/drawing/2014/main" id="{B0B8E340-C0E4-44AE-8492-678AE496F775}"/>
+                <a16:creationId xmlns:a16="http://schemas.microsoft.com/office/drawing/2014/main" id="{1D7B59AB-B919-420B-A348-99773B2D56AE}"/>
               </a:ext>
             </a:extLst>
           </p:cNvPr>
@@ -10032,7 +11564,7 @@
           <p:cNvPr id="19" name="">
             <a:extLst xmlns:a="http://schemas.openxmlformats.org/drawingml/2006/main">
               <a:ext uri="{FF2B5EF4-FFF2-40B4-BE49-F238E27FC236}">
-                <a16:creationId xmlns:a16="http://schemas.microsoft.com/office/drawing/2014/main" id="{B86780E8-8FE2-440A-A308-5FB72E07CBAE}"/>
+                <a16:creationId xmlns:a16="http://schemas.microsoft.com/office/drawing/2014/main" id="{62D0A91A-C410-45DB-AC92-EA5E857B470E}"/>
               </a:ext>
             </a:extLst>
           </p:cNvPr>
@@ -10067,7 +11599,7 @@
           <p:cNvPr id="20" name="">
             <a:extLst xmlns:a="http://schemas.openxmlformats.org/drawingml/2006/main">
               <a:ext uri="{FF2B5EF4-FFF2-40B4-BE49-F238E27FC236}">
-                <a16:creationId xmlns:a16="http://schemas.microsoft.com/office/drawing/2014/main" id="{7878DF66-5847-4498-A295-A0765CB77BFF}"/>
+                <a16:creationId xmlns:a16="http://schemas.microsoft.com/office/drawing/2014/main" id="{329D1E42-D88D-48A5-9461-4C880269E677}"/>
               </a:ext>
             </a:extLst>
           </p:cNvPr>
@@ -10117,7 +11649,7 @@
           <p:cNvPr id="21" name="">
             <a:extLst xmlns:a="http://schemas.openxmlformats.org/drawingml/2006/main">
               <a:ext uri="{FF2B5EF4-FFF2-40B4-BE49-F238E27FC236}">
-                <a16:creationId xmlns:a16="http://schemas.microsoft.com/office/drawing/2014/main" id="{C6C2D769-873D-49D2-A751-6FE8C7A7BBDF}"/>
+                <a16:creationId xmlns:a16="http://schemas.microsoft.com/office/drawing/2014/main" id="{8295CBB9-F6A9-4429-B5A1-C8C8E6243B93}"/>
               </a:ext>
             </a:extLst>
           </p:cNvPr>
@@ -10184,7 +11716,7 @@
           <p:cNvPr id="22" name="">
             <a:extLst xmlns:a="http://schemas.openxmlformats.org/drawingml/2006/main">
               <a:ext uri="{FF2B5EF4-FFF2-40B4-BE49-F238E27FC236}">
-                <a16:creationId xmlns:a16="http://schemas.microsoft.com/office/drawing/2014/main" id="{0A89D4EE-01CA-497F-AD33-F2F0DB9D1A8C}"/>
+                <a16:creationId xmlns:a16="http://schemas.microsoft.com/office/drawing/2014/main" id="{65943A02-2B21-44DC-AF3E-39D26B0A54BD}"/>
               </a:ext>
             </a:extLst>
           </p:cNvPr>
@@ -10215,7 +11747,7 @@
           <p:cNvPr id="23" name="">
             <a:extLst xmlns:a="http://schemas.openxmlformats.org/drawingml/2006/main">
               <a:ext uri="{FF2B5EF4-FFF2-40B4-BE49-F238E27FC236}">
-                <a16:creationId xmlns:a16="http://schemas.microsoft.com/office/drawing/2014/main" id="{102E8CDB-1A51-420E-B71D-9C19DF1375A9}"/>
+                <a16:creationId xmlns:a16="http://schemas.microsoft.com/office/drawing/2014/main" id="{1896D5BA-B8B7-4ACE-B62B-4ED91952241E}"/>
               </a:ext>
             </a:extLst>
           </p:cNvPr>
@@ -10250,7 +11782,7 @@
           <p:cNvPr id="24" name="">
             <a:extLst xmlns:a="http://schemas.openxmlformats.org/drawingml/2006/main">
               <a:ext uri="{FF2B5EF4-FFF2-40B4-BE49-F238E27FC236}">
-                <a16:creationId xmlns:a16="http://schemas.microsoft.com/office/drawing/2014/main" id="{1C157FCE-2734-410E-AD0C-19FEC8285504}"/>
+                <a16:creationId xmlns:a16="http://schemas.microsoft.com/office/drawing/2014/main" id="{FFA50CFC-AADF-45FE-B9F2-F66BEEEC0F2B}"/>
               </a:ext>
             </a:extLst>
           </p:cNvPr>
@@ -10300,7 +11832,7 @@
           <p:cNvPr id="25" name="">
             <a:extLst xmlns:a="http://schemas.openxmlformats.org/drawingml/2006/main">
               <a:ext uri="{FF2B5EF4-FFF2-40B4-BE49-F238E27FC236}">
-                <a16:creationId xmlns:a16="http://schemas.microsoft.com/office/drawing/2014/main" id="{BB7346E0-3F72-4894-885C-3CC5534A82D9}"/>
+                <a16:creationId xmlns:a16="http://schemas.microsoft.com/office/drawing/2014/main" id="{6CF57596-D8EF-49B4-9C4E-0E87C6055CD9}"/>
               </a:ext>
             </a:extLst>
           </p:cNvPr>
@@ -10367,7 +11899,7 @@
           <p:cNvPr id="26" name="">
             <a:extLst xmlns:a="http://schemas.openxmlformats.org/drawingml/2006/main">
               <a:ext uri="{FF2B5EF4-FFF2-40B4-BE49-F238E27FC236}">
-                <a16:creationId xmlns:a16="http://schemas.microsoft.com/office/drawing/2014/main" id="{AB3D417E-1FD8-478D-818B-26D9D6103862}"/>
+                <a16:creationId xmlns:a16="http://schemas.microsoft.com/office/drawing/2014/main" id="{85412A19-E729-4B21-BB07-956B5400BBF6}"/>
               </a:ext>
             </a:extLst>
           </p:cNvPr>
@@ -10398,7 +11930,7 @@
           <p:cNvPr id="27" name="">
             <a:extLst xmlns:a="http://schemas.openxmlformats.org/drawingml/2006/main">
               <a:ext uri="{FF2B5EF4-FFF2-40B4-BE49-F238E27FC236}">
-                <a16:creationId xmlns:a16="http://schemas.microsoft.com/office/drawing/2014/main" id="{07916EF3-E0F9-4C0A-A190-D1F7CDD1D5D7}"/>
+                <a16:creationId xmlns:a16="http://schemas.microsoft.com/office/drawing/2014/main" id="{BB000F0E-8087-4794-AF6D-E551024EF9A9}"/>
               </a:ext>
             </a:extLst>
           </p:cNvPr>
@@ -10433,7 +11965,7 @@
           <p:cNvPr id="28" name="">
             <a:extLst xmlns:a="http://schemas.openxmlformats.org/drawingml/2006/main">
               <a:ext uri="{FF2B5EF4-FFF2-40B4-BE49-F238E27FC236}">
-                <a16:creationId xmlns:a16="http://schemas.microsoft.com/office/drawing/2014/main" id="{F94B7AAF-F403-4003-818A-979CF774799E}"/>
+                <a16:creationId xmlns:a16="http://schemas.microsoft.com/office/drawing/2014/main" id="{EB699F31-96EB-4FAE-AA22-89D3B127E9ED}"/>
               </a:ext>
             </a:extLst>
           </p:cNvPr>
@@ -10483,7 +12015,7 @@
           <p:cNvPr id="29" name="">
             <a:extLst xmlns:a="http://schemas.openxmlformats.org/drawingml/2006/main">
               <a:ext uri="{FF2B5EF4-FFF2-40B4-BE49-F238E27FC236}">
-                <a16:creationId xmlns:a16="http://schemas.microsoft.com/office/drawing/2014/main" id="{3DCD1F69-FA99-4891-91E8-5CB065A725F2}"/>
+                <a16:creationId xmlns:a16="http://schemas.microsoft.com/office/drawing/2014/main" id="{CC7EB8C2-C7FF-46DA-9E30-0E9A14B1C50B}"/>
               </a:ext>
             </a:extLst>
           </p:cNvPr>
@@ -10550,7 +12082,7 @@
           <p:cNvPr id="30" name="">
             <a:extLst xmlns:a="http://schemas.openxmlformats.org/drawingml/2006/main">
               <a:ext uri="{FF2B5EF4-FFF2-40B4-BE49-F238E27FC236}">
-                <a16:creationId xmlns:a16="http://schemas.microsoft.com/office/drawing/2014/main" id="{84C579DA-57D8-42B4-8C9E-DF79F40038D4}"/>
+                <a16:creationId xmlns:a16="http://schemas.microsoft.com/office/drawing/2014/main" id="{81FB6A44-EAF2-4DD3-99AB-90229CCBBD77}"/>
               </a:ext>
             </a:extLst>
           </p:cNvPr>
@@ -10600,7 +12132,7 @@
           <p:cNvPr id="31" name="">
             <a:extLst xmlns:a="http://schemas.openxmlformats.org/drawingml/2006/main">
               <a:ext uri="{FF2B5EF4-FFF2-40B4-BE49-F238E27FC236}">
-                <a16:creationId xmlns:a16="http://schemas.microsoft.com/office/drawing/2014/main" id="{B9815078-B9CC-4201-BC9A-A1F18EA854C7}"/>
+                <a16:creationId xmlns:a16="http://schemas.microsoft.com/office/drawing/2014/main" id="{8407BB9E-68E3-45A6-9F04-BAC2DCBAA21B}"/>
               </a:ext>
             </a:extLst>
           </p:cNvPr>
@@ -10650,7 +12182,7 @@
           <p:cNvPr id="32" name="">
             <a:extLst xmlns:a="http://schemas.openxmlformats.org/drawingml/2006/main">
               <a:ext uri="{FF2B5EF4-FFF2-40B4-BE49-F238E27FC236}">
-                <a16:creationId xmlns:a16="http://schemas.microsoft.com/office/drawing/2014/main" id="{F7722562-8044-4CF6-9FD7-78D8BD27E466}"/>
+                <a16:creationId xmlns:a16="http://schemas.microsoft.com/office/drawing/2014/main" id="{CA6FD25D-3405-413F-8BF2-735D73EAB098}"/>
               </a:ext>
             </a:extLst>
           </p:cNvPr>
@@ -10700,7 +12232,7 @@
           <p:cNvPr id="33" name="">
             <a:extLst xmlns:a="http://schemas.openxmlformats.org/drawingml/2006/main">
               <a:ext uri="{FF2B5EF4-FFF2-40B4-BE49-F238E27FC236}">
-                <a16:creationId xmlns:a16="http://schemas.microsoft.com/office/drawing/2014/main" id="{325D9E88-D1CD-493D-8F1E-4982198A1426}"/>
+                <a16:creationId xmlns:a16="http://schemas.microsoft.com/office/drawing/2014/main" id="{653A996B-B719-45D1-B17B-18A85376A217}"/>
               </a:ext>
             </a:extLst>
           </p:cNvPr>
@@ -10750,7 +12282,7 @@
           <p:cNvPr id="34" name="">
             <a:extLst xmlns:a="http://schemas.openxmlformats.org/drawingml/2006/main">
               <a:ext uri="{FF2B5EF4-FFF2-40B4-BE49-F238E27FC236}">
-                <a16:creationId xmlns:a16="http://schemas.microsoft.com/office/drawing/2014/main" id="{35F8DAB0-9570-4FEC-98F6-D97DEF9D8B85}"/>
+                <a16:creationId xmlns:a16="http://schemas.microsoft.com/office/drawing/2014/main" id="{1F6823E0-022F-4AC6-874C-C391C87D4290}"/>
               </a:ext>
             </a:extLst>
           </p:cNvPr>
@@ -10800,7 +12332,7 @@
           <p:cNvPr id="35" name="">
             <a:extLst xmlns:a="http://schemas.openxmlformats.org/drawingml/2006/main">
               <a:ext uri="{FF2B5EF4-FFF2-40B4-BE49-F238E27FC236}">
-                <a16:creationId xmlns:a16="http://schemas.microsoft.com/office/drawing/2014/main" id="{68730FDD-1F1F-4676-86F0-35EDD250B762}"/>
+                <a16:creationId xmlns:a16="http://schemas.microsoft.com/office/drawing/2014/main" id="{ABD471E8-D029-4172-81BE-1124CBAA0EFA}"/>
               </a:ext>
             </a:extLst>
           </p:cNvPr>
@@ -10850,7 +12382,7 @@
           <p:cNvPr id="36" name="">
             <a:extLst xmlns:a="http://schemas.openxmlformats.org/drawingml/2006/main">
               <a:ext uri="{FF2B5EF4-FFF2-40B4-BE49-F238E27FC236}">
-                <a16:creationId xmlns:a16="http://schemas.microsoft.com/office/drawing/2014/main" id="{0F377BE2-2576-4F90-B5E3-2109B5CC70B8}"/>
+                <a16:creationId xmlns:a16="http://schemas.microsoft.com/office/drawing/2014/main" id="{E6314954-1029-4334-9298-6EFB8B40118A}"/>
               </a:ext>
             </a:extLst>
           </p:cNvPr>
@@ -10900,7 +12432,7 @@
           <p:cNvPr id="37" name="">
             <a:extLst xmlns:a="http://schemas.openxmlformats.org/drawingml/2006/main">
               <a:ext uri="{FF2B5EF4-FFF2-40B4-BE49-F238E27FC236}">
-                <a16:creationId xmlns:a16="http://schemas.microsoft.com/office/drawing/2014/main" id="{26D3EB9C-45B5-418D-9B1D-4575D24DA2C3}"/>
+                <a16:creationId xmlns:a16="http://schemas.microsoft.com/office/drawing/2014/main" id="{BC5002DD-D2D1-4118-A67C-CF04B84EE804}"/>
               </a:ext>
             </a:extLst>
           </p:cNvPr>
@@ -10950,7 +12482,7 @@
           <p:cNvPr id="38" name="">
             <a:extLst xmlns:a="http://schemas.openxmlformats.org/drawingml/2006/main">
               <a:ext uri="{FF2B5EF4-FFF2-40B4-BE49-F238E27FC236}">
-                <a16:creationId xmlns:a16="http://schemas.microsoft.com/office/drawing/2014/main" id="{44FA9703-77CD-494D-9166-811D64DBEC35}"/>
+                <a16:creationId xmlns:a16="http://schemas.microsoft.com/office/drawing/2014/main" id="{398B05E7-BF0B-4C2B-ACEA-70AAF8CE1931}"/>
               </a:ext>
             </a:extLst>
           </p:cNvPr>
@@ -11000,7 +12532,7 @@
           <p:cNvPr id="39" name="">
             <a:extLst xmlns:a="http://schemas.openxmlformats.org/drawingml/2006/main">
               <a:ext uri="{FF2B5EF4-FFF2-40B4-BE49-F238E27FC236}">
-                <a16:creationId xmlns:a16="http://schemas.microsoft.com/office/drawing/2014/main" id="{2DE6BA91-A058-4364-863D-9B191A182BD9}"/>
+                <a16:creationId xmlns:a16="http://schemas.microsoft.com/office/drawing/2014/main" id="{217D3B05-C1D0-4D2F-A2C9-5B99F397421C}"/>
               </a:ext>
             </a:extLst>
           </p:cNvPr>
@@ -11048,7 +12580,7 @@
     </p:spTree>
     <p:extLst>
       <p:ext uri="{BB962C8B-B14F-4D97-AF65-F5344CB8AC3E}">
-        <p14:creationId xmlns:p14="http://schemas.microsoft.com/office/powerpoint/2010/main" val="505127459"/>
+        <p14:creationId xmlns:p14="http://schemas.microsoft.com/office/powerpoint/2010/main" val="271003431"/>
       </p:ext>
     </p:extLst>
   </p:cSld>
@@ -11079,7 +12611,7 @@
           <p:cNvPr id="25" name="">
             <a:extLst xmlns:a="http://schemas.openxmlformats.org/drawingml/2006/main">
               <a:ext uri="{FF2B5EF4-FFF2-40B4-BE49-F238E27FC236}">
-                <a16:creationId xmlns:a16="http://schemas.microsoft.com/office/drawing/2014/main" id="{F14E2D4B-6CC1-4A45-9456-C49B9F2A005E}"/>
+                <a16:creationId xmlns:a16="http://schemas.microsoft.com/office/drawing/2014/main" id="{61621A19-932D-4BA4-9ECB-AF6C61E30103}"/>
               </a:ext>
             </a:extLst>
           </p:cNvPr>
@@ -11129,7 +12661,7 @@
           <p:cNvPr id="2" name="">
             <a:extLst xmlns:a="http://schemas.openxmlformats.org/drawingml/2006/main">
               <a:ext uri="{FF2B5EF4-FFF2-40B4-BE49-F238E27FC236}">
-                <a16:creationId xmlns:a16="http://schemas.microsoft.com/office/drawing/2014/main" id="{ACFBDC6A-0184-4EA1-994E-AA75B712A8F6}"/>
+                <a16:creationId xmlns:a16="http://schemas.microsoft.com/office/drawing/2014/main" id="{E45C173D-72D6-4424-9959-861031042A83}"/>
               </a:ext>
             </a:extLst>
           </p:cNvPr>
@@ -11179,7 +12711,7 @@
           <p:cNvPr id="3" name="">
             <a:extLst xmlns:a="http://schemas.openxmlformats.org/drawingml/2006/main">
               <a:ext uri="{FF2B5EF4-FFF2-40B4-BE49-F238E27FC236}">
-                <a16:creationId xmlns:a16="http://schemas.microsoft.com/office/drawing/2014/main" id="{0961303E-C109-44EB-A1F5-C56B5AB097CD}"/>
+                <a16:creationId xmlns:a16="http://schemas.microsoft.com/office/drawing/2014/main" id="{A9CB910B-A13D-4D42-8281-042AFF792F05}"/>
               </a:ext>
             </a:extLst>
           </p:cNvPr>
@@ -11229,7 +12761,7 @@
           <p:cNvPr id="4" name="">
             <a:extLst xmlns:a="http://schemas.openxmlformats.org/drawingml/2006/main">
               <a:ext uri="{FF2B5EF4-FFF2-40B4-BE49-F238E27FC236}">
-                <a16:creationId xmlns:a16="http://schemas.microsoft.com/office/drawing/2014/main" id="{047CB038-D9FD-45C6-961E-8A61D2D0069F}"/>
+                <a16:creationId xmlns:a16="http://schemas.microsoft.com/office/drawing/2014/main" id="{2E77C76A-A7C9-4B1A-B523-DCF4ADCE9841}"/>
               </a:ext>
             </a:extLst>
           </p:cNvPr>
@@ -11279,7 +12811,7 @@
           <p:cNvPr id="5" name="">
             <a:extLst xmlns:a="http://schemas.openxmlformats.org/drawingml/2006/main">
               <a:ext uri="{FF2B5EF4-FFF2-40B4-BE49-F238E27FC236}">
-                <a16:creationId xmlns:a16="http://schemas.microsoft.com/office/drawing/2014/main" id="{CC4E5638-A576-4BC0-BA04-2CF5F590B88C}"/>
+                <a16:creationId xmlns:a16="http://schemas.microsoft.com/office/drawing/2014/main" id="{8BEE3328-E210-4E7C-AAFE-CA026C7C221A}"/>
               </a:ext>
             </a:extLst>
           </p:cNvPr>
@@ -11329,7 +12861,7 @@
           <p:cNvPr id="6" name="">
             <a:extLst xmlns:a="http://schemas.openxmlformats.org/drawingml/2006/main">
               <a:ext uri="{FF2B5EF4-FFF2-40B4-BE49-F238E27FC236}">
-                <a16:creationId xmlns:a16="http://schemas.microsoft.com/office/drawing/2014/main" id="{3D23BACD-F636-4D5D-B225-F29CF9FB2430}"/>
+                <a16:creationId xmlns:a16="http://schemas.microsoft.com/office/drawing/2014/main" id="{208741EA-F7D0-48F2-91E5-5D72F13D10C6}"/>
               </a:ext>
             </a:extLst>
           </p:cNvPr>
@@ -11379,7 +12911,7 @@
           <p:cNvPr id="7" name="">
             <a:extLst xmlns:a="http://schemas.openxmlformats.org/drawingml/2006/main">
               <a:ext uri="{FF2B5EF4-FFF2-40B4-BE49-F238E27FC236}">
-                <a16:creationId xmlns:a16="http://schemas.microsoft.com/office/drawing/2014/main" id="{05828BA5-14CD-46A1-AAAB-3BD6980247FD}"/>
+                <a16:creationId xmlns:a16="http://schemas.microsoft.com/office/drawing/2014/main" id="{1E8095E7-1E25-4287-9689-5399E42F5757}"/>
               </a:ext>
             </a:extLst>
           </p:cNvPr>
@@ -11414,7 +12946,7 @@
           <p:cNvPr id="8" name="">
             <a:extLst xmlns:a="http://schemas.openxmlformats.org/drawingml/2006/main">
               <a:ext uri="{FF2B5EF4-FFF2-40B4-BE49-F238E27FC236}">
-                <a16:creationId xmlns:a16="http://schemas.microsoft.com/office/drawing/2014/main" id="{702E612A-9AF3-44CB-9499-9596BD7EA5B1}"/>
+                <a16:creationId xmlns:a16="http://schemas.microsoft.com/office/drawing/2014/main" id="{987FFBEF-12CF-461A-AF09-91F1A37B9571}"/>
               </a:ext>
             </a:extLst>
           </p:cNvPr>
@@ -11464,7 +12996,7 @@
           <p:cNvPr id="9" name="">
             <a:extLst xmlns:a="http://schemas.openxmlformats.org/drawingml/2006/main">
               <a:ext uri="{FF2B5EF4-FFF2-40B4-BE49-F238E27FC236}">
-                <a16:creationId xmlns:a16="http://schemas.microsoft.com/office/drawing/2014/main" id="{6D5CD968-FB93-4F6F-85BF-92B46151D93B}"/>
+                <a16:creationId xmlns:a16="http://schemas.microsoft.com/office/drawing/2014/main" id="{97DF2E37-7262-4BB8-8A3F-61F457FE4A1E}"/>
               </a:ext>
             </a:extLst>
           </p:cNvPr>
@@ -11514,7 +13046,7 @@
           <p:cNvPr id="10" name="">
             <a:extLst xmlns:a="http://schemas.openxmlformats.org/drawingml/2006/main">
               <a:ext uri="{FF2B5EF4-FFF2-40B4-BE49-F238E27FC236}">
-                <a16:creationId xmlns:a16="http://schemas.microsoft.com/office/drawing/2014/main" id="{1C82957E-5D91-40A5-9826-33295A6E55D3}"/>
+                <a16:creationId xmlns:a16="http://schemas.microsoft.com/office/drawing/2014/main" id="{2F65621A-D18E-4EF4-8255-8668EB0AF52E}"/>
               </a:ext>
             </a:extLst>
           </p:cNvPr>
@@ -11564,7 +13096,7 @@
           <p:cNvPr id="11" name="">
             <a:extLst xmlns:a="http://schemas.openxmlformats.org/drawingml/2006/main">
               <a:ext uri="{FF2B5EF4-FFF2-40B4-BE49-F238E27FC236}">
-                <a16:creationId xmlns:a16="http://schemas.microsoft.com/office/drawing/2014/main" id="{85DB5AA1-A47C-4AB3-B035-01641CCCBCA7}"/>
+                <a16:creationId xmlns:a16="http://schemas.microsoft.com/office/drawing/2014/main" id="{0C73D4A8-A4BC-4DEE-8860-96A1FC52E74D}"/>
               </a:ext>
             </a:extLst>
           </p:cNvPr>
@@ -11614,7 +13146,7 @@
           <p:cNvPr id="12" name="">
             <a:extLst xmlns:a="http://schemas.openxmlformats.org/drawingml/2006/main">
               <a:ext uri="{FF2B5EF4-FFF2-40B4-BE49-F238E27FC236}">
-                <a16:creationId xmlns:a16="http://schemas.microsoft.com/office/drawing/2014/main" id="{82555E9F-FE99-4AD5-B84E-853AA24B6096}"/>
+                <a16:creationId xmlns:a16="http://schemas.microsoft.com/office/drawing/2014/main" id="{808759C5-4AA4-45EC-B1CB-ADC1CA554C28}"/>
               </a:ext>
             </a:extLst>
           </p:cNvPr>
@@ -11649,7 +13181,7 @@
           <p:cNvPr id="13" name="">
             <a:extLst xmlns:a="http://schemas.openxmlformats.org/drawingml/2006/main">
               <a:ext uri="{FF2B5EF4-FFF2-40B4-BE49-F238E27FC236}">
-                <a16:creationId xmlns:a16="http://schemas.microsoft.com/office/drawing/2014/main" id="{9BC75F9F-4071-4FDE-9710-8D9C1008E60A}"/>
+                <a16:creationId xmlns:a16="http://schemas.microsoft.com/office/drawing/2014/main" id="{6B75E885-1BA8-491E-A567-768AD6BA2F27}"/>
               </a:ext>
             </a:extLst>
           </p:cNvPr>
@@ -11699,7 +13231,7 @@
           <p:cNvPr id="14" name="">
             <a:extLst xmlns:a="http://schemas.openxmlformats.org/drawingml/2006/main">
               <a:ext uri="{FF2B5EF4-FFF2-40B4-BE49-F238E27FC236}">
-                <a16:creationId xmlns:a16="http://schemas.microsoft.com/office/drawing/2014/main" id="{B765BBF5-528E-4AD4-B1FE-42386B0E6F35}"/>
+                <a16:creationId xmlns:a16="http://schemas.microsoft.com/office/drawing/2014/main" id="{7CE4A023-89D0-475B-AA40-5E7CAD959C2C}"/>
               </a:ext>
             </a:extLst>
           </p:cNvPr>
@@ -11749,7 +13281,7 @@
           <p:cNvPr id="15" name="">
             <a:extLst xmlns:a="http://schemas.openxmlformats.org/drawingml/2006/main">
               <a:ext uri="{FF2B5EF4-FFF2-40B4-BE49-F238E27FC236}">
-                <a16:creationId xmlns:a16="http://schemas.microsoft.com/office/drawing/2014/main" id="{3E4BEDD4-D8F0-4BE6-863A-5675CBC19354}"/>
+                <a16:creationId xmlns:a16="http://schemas.microsoft.com/office/drawing/2014/main" id="{1EDB0095-E868-450E-87F7-84986E99B71A}"/>
               </a:ext>
             </a:extLst>
           </p:cNvPr>
@@ -11799,7 +13331,7 @@
           <p:cNvPr id="16" name="">
             <a:extLst xmlns:a="http://schemas.openxmlformats.org/drawingml/2006/main">
               <a:ext uri="{FF2B5EF4-FFF2-40B4-BE49-F238E27FC236}">
-                <a16:creationId xmlns:a16="http://schemas.microsoft.com/office/drawing/2014/main" id="{E7536509-2F72-4E0F-9176-A4335DEA5206}"/>
+                <a16:creationId xmlns:a16="http://schemas.microsoft.com/office/drawing/2014/main" id="{EF02103C-CA1B-42EA-9E13-1EDA9EE62AD7}"/>
               </a:ext>
             </a:extLst>
           </p:cNvPr>
@@ -11849,7 +13381,7 @@
           <p:cNvPr id="17" name="">
             <a:extLst xmlns:a="http://schemas.openxmlformats.org/drawingml/2006/main">
               <a:ext uri="{FF2B5EF4-FFF2-40B4-BE49-F238E27FC236}">
-                <a16:creationId xmlns:a16="http://schemas.microsoft.com/office/drawing/2014/main" id="{A2B1848C-0B81-4508-BC50-9BDB8B7FF335}"/>
+                <a16:creationId xmlns:a16="http://schemas.microsoft.com/office/drawing/2014/main" id="{AFBF9A52-898D-45CA-8F3A-1E9153B6C756}"/>
               </a:ext>
             </a:extLst>
           </p:cNvPr>
@@ -11884,7 +13416,7 @@
           <p:cNvPr id="18" name="">
             <a:extLst xmlns:a="http://schemas.openxmlformats.org/drawingml/2006/main">
               <a:ext uri="{FF2B5EF4-FFF2-40B4-BE49-F238E27FC236}">
-                <a16:creationId xmlns:a16="http://schemas.microsoft.com/office/drawing/2014/main" id="{3A5086AB-34EA-4570-B1A9-697B880E6BD9}"/>
+                <a16:creationId xmlns:a16="http://schemas.microsoft.com/office/drawing/2014/main" id="{278046C0-78B8-4420-BD70-5CBCF079A075}"/>
               </a:ext>
             </a:extLst>
           </p:cNvPr>
@@ -11934,7 +13466,7 @@
           <p:cNvPr id="19" name="">
             <a:extLst xmlns:a="http://schemas.openxmlformats.org/drawingml/2006/main">
               <a:ext uri="{FF2B5EF4-FFF2-40B4-BE49-F238E27FC236}">
-                <a16:creationId xmlns:a16="http://schemas.microsoft.com/office/drawing/2014/main" id="{B5888290-D83E-41DF-9DB6-1980803052D1}"/>
+                <a16:creationId xmlns:a16="http://schemas.microsoft.com/office/drawing/2014/main" id="{F7CC66E1-8B40-4890-B75D-57FCDB875D27}"/>
               </a:ext>
             </a:extLst>
           </p:cNvPr>
@@ -11984,7 +13516,7 @@
           <p:cNvPr id="20" name="">
             <a:extLst xmlns:a="http://schemas.openxmlformats.org/drawingml/2006/main">
               <a:ext uri="{FF2B5EF4-FFF2-40B4-BE49-F238E27FC236}">
-                <a16:creationId xmlns:a16="http://schemas.microsoft.com/office/drawing/2014/main" id="{8B896DF7-EE80-4CA6-9197-7471358D3B36}"/>
+                <a16:creationId xmlns:a16="http://schemas.microsoft.com/office/drawing/2014/main" id="{FE6E93F8-76D6-4BB8-9A38-29331B609DA2}"/>
               </a:ext>
             </a:extLst>
           </p:cNvPr>
@@ -12034,7 +13566,7 @@
           <p:cNvPr id="21" name="">
             <a:extLst xmlns:a="http://schemas.openxmlformats.org/drawingml/2006/main">
               <a:ext uri="{FF2B5EF4-FFF2-40B4-BE49-F238E27FC236}">
-                <a16:creationId xmlns:a16="http://schemas.microsoft.com/office/drawing/2014/main" id="{84D8468C-2687-4400-870B-19D8F0106CEB}"/>
+                <a16:creationId xmlns:a16="http://schemas.microsoft.com/office/drawing/2014/main" id="{77325206-9A0F-4DCC-892B-4D84ABD7F282}"/>
               </a:ext>
             </a:extLst>
           </p:cNvPr>
@@ -12084,7 +13616,7 @@
           <p:cNvPr id="22" name="">
             <a:extLst xmlns:a="http://schemas.openxmlformats.org/drawingml/2006/main">
               <a:ext uri="{FF2B5EF4-FFF2-40B4-BE49-F238E27FC236}">
-                <a16:creationId xmlns:a16="http://schemas.microsoft.com/office/drawing/2014/main" id="{ADB1F6E9-1DBE-4710-A7BC-1E4BF5AE6EAB}"/>
+                <a16:creationId xmlns:a16="http://schemas.microsoft.com/office/drawing/2014/main" id="{E3BC043E-1F32-41CD-B77E-EB23921B431F}"/>
               </a:ext>
             </a:extLst>
           </p:cNvPr>
@@ -12134,7 +13666,7 @@
           <p:cNvPr id="23" name="">
             <a:extLst xmlns:a="http://schemas.openxmlformats.org/drawingml/2006/main">
               <a:ext uri="{FF2B5EF4-FFF2-40B4-BE49-F238E27FC236}">
-                <a16:creationId xmlns:a16="http://schemas.microsoft.com/office/drawing/2014/main" id="{014F103E-ABAE-4FA8-B5CA-66E1653815E5}"/>
+                <a16:creationId xmlns:a16="http://schemas.microsoft.com/office/drawing/2014/main" id="{7AB64E80-0917-43D1-AFAA-E6A23ADE7D3D}"/>
               </a:ext>
             </a:extLst>
           </p:cNvPr>
@@ -12184,7 +13716,7 @@
           <p:cNvPr id="24" name="">
             <a:extLst xmlns:a="http://schemas.openxmlformats.org/drawingml/2006/main">
               <a:ext uri="{FF2B5EF4-FFF2-40B4-BE49-F238E27FC236}">
-                <a16:creationId xmlns:a16="http://schemas.microsoft.com/office/drawing/2014/main" id="{D83B7BA7-46E7-40C7-8381-7143CD4B4D68}"/>
+                <a16:creationId xmlns:a16="http://schemas.microsoft.com/office/drawing/2014/main" id="{CE5C498B-2954-4302-8BF4-17DE57931DA7}"/>
               </a:ext>
             </a:extLst>
           </p:cNvPr>
@@ -12232,7 +13764,7 @@
     </p:spTree>
     <p:extLst>
       <p:ext uri="{BB962C8B-B14F-4D97-AF65-F5344CB8AC3E}">
-        <p14:creationId xmlns:p14="http://schemas.microsoft.com/office/powerpoint/2010/main" val="1260981320"/>
+        <p14:creationId xmlns:p14="http://schemas.microsoft.com/office/powerpoint/2010/main" val="933749673"/>
       </p:ext>
     </p:extLst>
   </p:cSld>
@@ -12263,7 +13795,7 @@
           <p:cNvPr id="30" name="">
             <a:extLst xmlns:a="http://schemas.openxmlformats.org/drawingml/2006/main">
               <a:ext uri="{FF2B5EF4-FFF2-40B4-BE49-F238E27FC236}">
-                <a16:creationId xmlns:a16="http://schemas.microsoft.com/office/drawing/2014/main" id="{5796975B-0642-4390-A41C-31F7391431F7}"/>
+                <a16:creationId xmlns:a16="http://schemas.microsoft.com/office/drawing/2014/main" id="{468FBFCD-7FAF-4A0A-9322-E81AC94A509E}"/>
               </a:ext>
             </a:extLst>
           </p:cNvPr>
@@ -12313,7 +13845,7 @@
           <p:cNvPr id="2" name="">
             <a:extLst xmlns:a="http://schemas.openxmlformats.org/drawingml/2006/main">
               <a:ext uri="{FF2B5EF4-FFF2-40B4-BE49-F238E27FC236}">
-                <a16:creationId xmlns:a16="http://schemas.microsoft.com/office/drawing/2014/main" id="{69B52463-E890-4EDA-B02E-EB64910EF040}"/>
+                <a16:creationId xmlns:a16="http://schemas.microsoft.com/office/drawing/2014/main" id="{982E16BC-9BB2-48D4-A729-D82DFD93534B}"/>
               </a:ext>
             </a:extLst>
           </p:cNvPr>
@@ -12363,7 +13895,7 @@
           <p:cNvPr id="3" name="">
             <a:extLst xmlns:a="http://schemas.openxmlformats.org/drawingml/2006/main">
               <a:ext uri="{FF2B5EF4-FFF2-40B4-BE49-F238E27FC236}">
-                <a16:creationId xmlns:a16="http://schemas.microsoft.com/office/drawing/2014/main" id="{E8ADA41D-81BE-4125-BAB6-F7B77CD42ABF}"/>
+                <a16:creationId xmlns:a16="http://schemas.microsoft.com/office/drawing/2014/main" id="{F791BA65-062A-4388-A0E7-3B2AD0577F44}"/>
               </a:ext>
             </a:extLst>
           </p:cNvPr>
@@ -12398,7 +13930,7 @@
           <p:cNvPr id="4" name="">
             <a:extLst xmlns:a="http://schemas.openxmlformats.org/drawingml/2006/main">
               <a:ext uri="{FF2B5EF4-FFF2-40B4-BE49-F238E27FC236}">
-                <a16:creationId xmlns:a16="http://schemas.microsoft.com/office/drawing/2014/main" id="{1B3E5BCA-0157-46C7-BE7F-5256DFFBDACF}"/>
+                <a16:creationId xmlns:a16="http://schemas.microsoft.com/office/drawing/2014/main" id="{393F3503-AC67-4476-A6AA-3291F138943F}"/>
               </a:ext>
             </a:extLst>
           </p:cNvPr>
@@ -12448,7 +13980,7 @@
           <p:cNvPr id="5" name="">
             <a:extLst xmlns:a="http://schemas.openxmlformats.org/drawingml/2006/main">
               <a:ext uri="{FF2B5EF4-FFF2-40B4-BE49-F238E27FC236}">
-                <a16:creationId xmlns:a16="http://schemas.microsoft.com/office/drawing/2014/main" id="{4E4022A2-1C7B-49CE-82A7-A2037A3B90B2}"/>
+                <a16:creationId xmlns:a16="http://schemas.microsoft.com/office/drawing/2014/main" id="{BC9723A8-5EB2-4926-8E3E-7EA303593D52}"/>
               </a:ext>
             </a:extLst>
           </p:cNvPr>
@@ -12498,7 +14030,7 @@
           <p:cNvPr id="6" name="">
             <a:extLst xmlns:a="http://schemas.openxmlformats.org/drawingml/2006/main">
               <a:ext uri="{FF2B5EF4-FFF2-40B4-BE49-F238E27FC236}">
-                <a16:creationId xmlns:a16="http://schemas.microsoft.com/office/drawing/2014/main" id="{5ED7F18D-FDBD-4CF3-B0EE-A050A27FD22C}"/>
+                <a16:creationId xmlns:a16="http://schemas.microsoft.com/office/drawing/2014/main" id="{9B8CC7EB-4A0A-4296-A018-107CF3E3D4BC}"/>
               </a:ext>
             </a:extLst>
           </p:cNvPr>
@@ -12533,7 +14065,7 @@
           <p:cNvPr id="7" name="">
             <a:extLst xmlns:a="http://schemas.openxmlformats.org/drawingml/2006/main">
               <a:ext uri="{FF2B5EF4-FFF2-40B4-BE49-F238E27FC236}">
-                <a16:creationId xmlns:a16="http://schemas.microsoft.com/office/drawing/2014/main" id="{9AC59EE4-B205-4B2B-A944-4443CDC6D31D}"/>
+                <a16:creationId xmlns:a16="http://schemas.microsoft.com/office/drawing/2014/main" id="{1DE8A51A-8686-4984-99D1-7A5C8A31E03F}"/>
               </a:ext>
             </a:extLst>
           </p:cNvPr>
@@ -12583,7 +14115,7 @@
           <p:cNvPr id="8" name="">
             <a:extLst xmlns:a="http://schemas.openxmlformats.org/drawingml/2006/main">
               <a:ext uri="{FF2B5EF4-FFF2-40B4-BE49-F238E27FC236}">
-                <a16:creationId xmlns:a16="http://schemas.microsoft.com/office/drawing/2014/main" id="{499B87F8-D1B1-4CC6-8263-E6E22DE2B41D}"/>
+                <a16:creationId xmlns:a16="http://schemas.microsoft.com/office/drawing/2014/main" id="{EECE0A0A-3E9D-4225-981D-32E95F389D3C}"/>
               </a:ext>
             </a:extLst>
           </p:cNvPr>
@@ -12633,7 +14165,7 @@
           <p:cNvPr id="9" name="">
             <a:extLst xmlns:a="http://schemas.openxmlformats.org/drawingml/2006/main">
               <a:ext uri="{FF2B5EF4-FFF2-40B4-BE49-F238E27FC236}">
-                <a16:creationId xmlns:a16="http://schemas.microsoft.com/office/drawing/2014/main" id="{94741A39-E80F-4393-9C63-48ED13835FF0}"/>
+                <a16:creationId xmlns:a16="http://schemas.microsoft.com/office/drawing/2014/main" id="{C9FE42F1-0C52-4FCC-90F0-B5568370A460}"/>
               </a:ext>
             </a:extLst>
           </p:cNvPr>
@@ -12668,7 +14200,7 @@
           <p:cNvPr id="10" name="">
             <a:extLst xmlns:a="http://schemas.openxmlformats.org/drawingml/2006/main">
               <a:ext uri="{FF2B5EF4-FFF2-40B4-BE49-F238E27FC236}">
-                <a16:creationId xmlns:a16="http://schemas.microsoft.com/office/drawing/2014/main" id="{87FDF907-C2E1-4311-A5B0-C36B47FA7864}"/>
+                <a16:creationId xmlns:a16="http://schemas.microsoft.com/office/drawing/2014/main" id="{8D02FCB7-0F1F-4D2D-8CFB-5589A337C1EE}"/>
               </a:ext>
             </a:extLst>
           </p:cNvPr>
@@ -12718,7 +14250,7 @@
           <p:cNvPr id="11" name="">
             <a:extLst xmlns:a="http://schemas.openxmlformats.org/drawingml/2006/main">
               <a:ext uri="{FF2B5EF4-FFF2-40B4-BE49-F238E27FC236}">
-                <a16:creationId xmlns:a16="http://schemas.microsoft.com/office/drawing/2014/main" id="{33166243-068D-48A5-B129-EA1AC11ECE5D}"/>
+                <a16:creationId xmlns:a16="http://schemas.microsoft.com/office/drawing/2014/main" id="{C43507B7-2954-426D-A4CB-D6D64D3B5538}"/>
               </a:ext>
             </a:extLst>
           </p:cNvPr>
@@ -12768,7 +14300,7 @@
           <p:cNvPr id="12" name="">
             <a:extLst xmlns:a="http://schemas.openxmlformats.org/drawingml/2006/main">
               <a:ext uri="{FF2B5EF4-FFF2-40B4-BE49-F238E27FC236}">
-                <a16:creationId xmlns:a16="http://schemas.microsoft.com/office/drawing/2014/main" id="{C8C4CD86-FC71-495C-9C82-0FE68B9B6CD2}"/>
+                <a16:creationId xmlns:a16="http://schemas.microsoft.com/office/drawing/2014/main" id="{C5FDF0BD-5447-4A35-BCAA-5B6B90DD8A95}"/>
               </a:ext>
             </a:extLst>
           </p:cNvPr>
@@ -12803,7 +14335,7 @@
           <p:cNvPr id="13" name="">
             <a:extLst xmlns:a="http://schemas.openxmlformats.org/drawingml/2006/main">
               <a:ext uri="{FF2B5EF4-FFF2-40B4-BE49-F238E27FC236}">
-                <a16:creationId xmlns:a16="http://schemas.microsoft.com/office/drawing/2014/main" id="{2503F977-A8E5-45DD-90B7-7A1E94A2FBAC}"/>
+                <a16:creationId xmlns:a16="http://schemas.microsoft.com/office/drawing/2014/main" id="{231D58FC-3CF0-4008-9450-EABE56CED45A}"/>
               </a:ext>
             </a:extLst>
           </p:cNvPr>
@@ -12853,7 +14385,7 @@
           <p:cNvPr id="14" name="">
             <a:extLst xmlns:a="http://schemas.openxmlformats.org/drawingml/2006/main">
               <a:ext uri="{FF2B5EF4-FFF2-40B4-BE49-F238E27FC236}">
-                <a16:creationId xmlns:a16="http://schemas.microsoft.com/office/drawing/2014/main" id="{E5412E52-82D5-4E7F-88DD-812BC1C235BB}"/>
+                <a16:creationId xmlns:a16="http://schemas.microsoft.com/office/drawing/2014/main" id="{A0D9EF3A-57F6-4B21-84C6-9B2E20EA8216}"/>
               </a:ext>
             </a:extLst>
           </p:cNvPr>
@@ -12903,7 +14435,7 @@
           <p:cNvPr id="15" name="">
             <a:extLst xmlns:a="http://schemas.openxmlformats.org/drawingml/2006/main">
               <a:ext uri="{FF2B5EF4-FFF2-40B4-BE49-F238E27FC236}">
-                <a16:creationId xmlns:a16="http://schemas.microsoft.com/office/drawing/2014/main" id="{634229F7-8EB8-4A5D-A440-D8086D67DF6D}"/>
+                <a16:creationId xmlns:a16="http://schemas.microsoft.com/office/drawing/2014/main" id="{CC7418C3-D85F-48C4-AFE7-EAF14E47914F}"/>
               </a:ext>
             </a:extLst>
           </p:cNvPr>
@@ -12938,7 +14470,7 @@
           <p:cNvPr id="16" name="">
             <a:extLst xmlns:a="http://schemas.openxmlformats.org/drawingml/2006/main">
               <a:ext uri="{FF2B5EF4-FFF2-40B4-BE49-F238E27FC236}">
-                <a16:creationId xmlns:a16="http://schemas.microsoft.com/office/drawing/2014/main" id="{19CEAEE5-A97C-4507-9D32-3C29B08D63C8}"/>
+                <a16:creationId xmlns:a16="http://schemas.microsoft.com/office/drawing/2014/main" id="{23F06845-69F0-47D9-8E13-58F653AC7C69}"/>
               </a:ext>
             </a:extLst>
           </p:cNvPr>
@@ -12988,7 +14520,7 @@
           <p:cNvPr id="17" name="">
             <a:extLst xmlns:a="http://schemas.openxmlformats.org/drawingml/2006/main">
               <a:ext uri="{FF2B5EF4-FFF2-40B4-BE49-F238E27FC236}">
-                <a16:creationId xmlns:a16="http://schemas.microsoft.com/office/drawing/2014/main" id="{65DE3044-654C-4A12-81CC-459652CC5D98}"/>
+                <a16:creationId xmlns:a16="http://schemas.microsoft.com/office/drawing/2014/main" id="{F559CD31-8A18-4D25-A9D3-C9A217A9D6B3}"/>
               </a:ext>
             </a:extLst>
           </p:cNvPr>
@@ -13038,7 +14570,7 @@
           <p:cNvPr id="18" name="">
             <a:extLst xmlns:a="http://schemas.openxmlformats.org/drawingml/2006/main">
               <a:ext uri="{FF2B5EF4-FFF2-40B4-BE49-F238E27FC236}">
-                <a16:creationId xmlns:a16="http://schemas.microsoft.com/office/drawing/2014/main" id="{63F8AB2D-826F-4BB7-86EF-0C02A90A93CA}"/>
+                <a16:creationId xmlns:a16="http://schemas.microsoft.com/office/drawing/2014/main" id="{5B4DE429-0F47-4205-9B2F-09360E4F58C7}"/>
               </a:ext>
             </a:extLst>
           </p:cNvPr>
@@ -13073,7 +14605,7 @@
           <p:cNvPr id="19" name="">
             <a:extLst xmlns:a="http://schemas.openxmlformats.org/drawingml/2006/main">
               <a:ext uri="{FF2B5EF4-FFF2-40B4-BE49-F238E27FC236}">
-                <a16:creationId xmlns:a16="http://schemas.microsoft.com/office/drawing/2014/main" id="{5BCBD2DD-1094-454C-BD71-84B581084D7E}"/>
+                <a16:creationId xmlns:a16="http://schemas.microsoft.com/office/drawing/2014/main" id="{45F31C71-2EA3-4134-A994-5EFAA508053C}"/>
               </a:ext>
             </a:extLst>
           </p:cNvPr>
@@ -13123,7 +14655,7 @@
           <p:cNvPr id="20" name="">
             <a:extLst xmlns:a="http://schemas.openxmlformats.org/drawingml/2006/main">
               <a:ext uri="{FF2B5EF4-FFF2-40B4-BE49-F238E27FC236}">
-                <a16:creationId xmlns:a16="http://schemas.microsoft.com/office/drawing/2014/main" id="{6C96F89A-BD41-4E46-BEED-56E59BAF3D71}"/>
+                <a16:creationId xmlns:a16="http://schemas.microsoft.com/office/drawing/2014/main" id="{DBE1CFB6-5D3A-42A6-862E-ADE6EAA26393}"/>
               </a:ext>
             </a:extLst>
           </p:cNvPr>
@@ -13173,7 +14705,7 @@
           <p:cNvPr id="21" name="">
             <a:extLst xmlns:a="http://schemas.openxmlformats.org/drawingml/2006/main">
               <a:ext uri="{FF2B5EF4-FFF2-40B4-BE49-F238E27FC236}">
-                <a16:creationId xmlns:a16="http://schemas.microsoft.com/office/drawing/2014/main" id="{8B177575-7950-4C17-AA14-8C3C7632E7DA}"/>
+                <a16:creationId xmlns:a16="http://schemas.microsoft.com/office/drawing/2014/main" id="{9CED9B61-1C04-4A34-BA0B-D3403D55A38D}"/>
               </a:ext>
             </a:extLst>
           </p:cNvPr>
@@ -13208,7 +14740,7 @@
           <p:cNvPr id="22" name="">
             <a:extLst xmlns:a="http://schemas.openxmlformats.org/drawingml/2006/main">
               <a:ext uri="{FF2B5EF4-FFF2-40B4-BE49-F238E27FC236}">
-                <a16:creationId xmlns:a16="http://schemas.microsoft.com/office/drawing/2014/main" id="{6D8B74E5-86DF-4A27-9162-A9C625CC2C37}"/>
+                <a16:creationId xmlns:a16="http://schemas.microsoft.com/office/drawing/2014/main" id="{35F9EB90-7A4B-463F-8BF2-3A2D1474D2E4}"/>
               </a:ext>
             </a:extLst>
           </p:cNvPr>
@@ -13258,7 +14790,7 @@
           <p:cNvPr id="23" name="">
             <a:extLst xmlns:a="http://schemas.openxmlformats.org/drawingml/2006/main">
               <a:ext uri="{FF2B5EF4-FFF2-40B4-BE49-F238E27FC236}">
-                <a16:creationId xmlns:a16="http://schemas.microsoft.com/office/drawing/2014/main" id="{5180C012-C08E-46CC-A4BF-E3166BC4BA89}"/>
+                <a16:creationId xmlns:a16="http://schemas.microsoft.com/office/drawing/2014/main" id="{03B9BDB1-16A6-4B47-9DBA-CB129D5E561F}"/>
               </a:ext>
             </a:extLst>
           </p:cNvPr>
@@ -13308,7 +14840,7 @@
           <p:cNvPr id="24" name="">
             <a:extLst xmlns:a="http://schemas.openxmlformats.org/drawingml/2006/main">
               <a:ext uri="{FF2B5EF4-FFF2-40B4-BE49-F238E27FC236}">
-                <a16:creationId xmlns:a16="http://schemas.microsoft.com/office/drawing/2014/main" id="{651F9B9D-3F8D-4083-B76A-E754371A8984}"/>
+                <a16:creationId xmlns:a16="http://schemas.microsoft.com/office/drawing/2014/main" id="{FA230E9D-0EB1-4E67-B70D-23FA50791652}"/>
               </a:ext>
             </a:extLst>
           </p:cNvPr>
@@ -13343,7 +14875,7 @@
           <p:cNvPr id="25" name="">
             <a:extLst xmlns:a="http://schemas.openxmlformats.org/drawingml/2006/main">
               <a:ext uri="{FF2B5EF4-FFF2-40B4-BE49-F238E27FC236}">
-                <a16:creationId xmlns:a16="http://schemas.microsoft.com/office/drawing/2014/main" id="{AFE97CA1-DCA4-4B26-9EE5-4C959B26F071}"/>
+                <a16:creationId xmlns:a16="http://schemas.microsoft.com/office/drawing/2014/main" id="{B0DDB051-DE84-4C82-8302-2BF4A98060BE}"/>
               </a:ext>
             </a:extLst>
           </p:cNvPr>
@@ -13393,7 +14925,7 @@
           <p:cNvPr id="26" name="">
             <a:extLst xmlns:a="http://schemas.openxmlformats.org/drawingml/2006/main">
               <a:ext uri="{FF2B5EF4-FFF2-40B4-BE49-F238E27FC236}">
-                <a16:creationId xmlns:a16="http://schemas.microsoft.com/office/drawing/2014/main" id="{133F6931-23A3-4536-A6E1-8A1D03D6F819}"/>
+                <a16:creationId xmlns:a16="http://schemas.microsoft.com/office/drawing/2014/main" id="{394CADB8-1A1F-4A1E-9BB5-28D0AD3E202E}"/>
               </a:ext>
             </a:extLst>
           </p:cNvPr>
@@ -13443,7 +14975,7 @@
           <p:cNvPr id="27" name="">
             <a:extLst xmlns:a="http://schemas.openxmlformats.org/drawingml/2006/main">
               <a:ext uri="{FF2B5EF4-FFF2-40B4-BE49-F238E27FC236}">
-                <a16:creationId xmlns:a16="http://schemas.microsoft.com/office/drawing/2014/main" id="{4B915435-AA0E-4AD9-9D4E-FF7E8AB199D4}"/>
+                <a16:creationId xmlns:a16="http://schemas.microsoft.com/office/drawing/2014/main" id="{048102E2-9785-4ED2-B4B9-E0E4AA86AE7B}"/>
               </a:ext>
             </a:extLst>
           </p:cNvPr>
@@ -13493,7 +15025,7 @@
           <p:cNvPr id="28" name="">
             <a:extLst xmlns:a="http://schemas.openxmlformats.org/drawingml/2006/main">
               <a:ext uri="{FF2B5EF4-FFF2-40B4-BE49-F238E27FC236}">
-                <a16:creationId xmlns:a16="http://schemas.microsoft.com/office/drawing/2014/main" id="{518469BB-1879-4D21-8685-FE8F37A99556}"/>
+                <a16:creationId xmlns:a16="http://schemas.microsoft.com/office/drawing/2014/main" id="{ECF68B05-ED71-4B8B-8D34-5D250EB0BE0A}"/>
               </a:ext>
             </a:extLst>
           </p:cNvPr>
@@ -13543,7 +15075,7 @@
           <p:cNvPr id="29" name="">
             <a:extLst xmlns:a="http://schemas.openxmlformats.org/drawingml/2006/main">
               <a:ext uri="{FF2B5EF4-FFF2-40B4-BE49-F238E27FC236}">
-                <a16:creationId xmlns:a16="http://schemas.microsoft.com/office/drawing/2014/main" id="{A4E625E4-227D-4D72-B750-FA72527EBEF4}"/>
+                <a16:creationId xmlns:a16="http://schemas.microsoft.com/office/drawing/2014/main" id="{A0C1E424-A900-4E0A-A9F1-C0389407C58B}"/>
               </a:ext>
             </a:extLst>
           </p:cNvPr>
@@ -13591,7 +15123,7 @@
     </p:spTree>
     <p:extLst>
       <p:ext uri="{BB962C8B-B14F-4D97-AF65-F5344CB8AC3E}">
-        <p14:creationId xmlns:p14="http://schemas.microsoft.com/office/powerpoint/2010/main" val="359672192"/>
+        <p14:creationId xmlns:p14="http://schemas.microsoft.com/office/powerpoint/2010/main" val="893905189"/>
       </p:ext>
     </p:extLst>
   </p:cSld>
@@ -13622,7 +15154,7 @@
           <p:cNvPr id="24" name="">
             <a:extLst xmlns:a="http://schemas.openxmlformats.org/drawingml/2006/main">
               <a:ext uri="{FF2B5EF4-FFF2-40B4-BE49-F238E27FC236}">
-                <a16:creationId xmlns:a16="http://schemas.microsoft.com/office/drawing/2014/main" id="{02A2DDBD-74C3-4F1E-B3EF-8C95361F965E}"/>
+                <a16:creationId xmlns:a16="http://schemas.microsoft.com/office/drawing/2014/main" id="{D45FB7FC-6358-4496-A757-05A3393D47C0}"/>
               </a:ext>
             </a:extLst>
           </p:cNvPr>
@@ -13672,7 +15204,7 @@
           <p:cNvPr id="2" name="">
             <a:extLst xmlns:a="http://schemas.openxmlformats.org/drawingml/2006/main">
               <a:ext uri="{FF2B5EF4-FFF2-40B4-BE49-F238E27FC236}">
-                <a16:creationId xmlns:a16="http://schemas.microsoft.com/office/drawing/2014/main" id="{738CFFC5-572B-471C-A315-6A4937102151}"/>
+                <a16:creationId xmlns:a16="http://schemas.microsoft.com/office/drawing/2014/main" id="{2510104F-B99E-4A46-AE6B-480182EE8D82}"/>
               </a:ext>
             </a:extLst>
           </p:cNvPr>
@@ -13722,7 +15254,7 @@
           <p:cNvPr id="3" name="">
             <a:extLst xmlns:a="http://schemas.openxmlformats.org/drawingml/2006/main">
               <a:ext uri="{FF2B5EF4-FFF2-40B4-BE49-F238E27FC236}">
-                <a16:creationId xmlns:a16="http://schemas.microsoft.com/office/drawing/2014/main" id="{5694B2F6-4609-4571-AA77-1352AAC8DA2B}"/>
+                <a16:creationId xmlns:a16="http://schemas.microsoft.com/office/drawing/2014/main" id="{9A122042-1C29-49EA-9F4E-C6A7B9BC7779}"/>
               </a:ext>
             </a:extLst>
           </p:cNvPr>
@@ -13757,7 +15289,7 @@
           <p:cNvPr id="4" name="">
             <a:extLst xmlns:a="http://schemas.openxmlformats.org/drawingml/2006/main">
               <a:ext uri="{FF2B5EF4-FFF2-40B4-BE49-F238E27FC236}">
-                <a16:creationId xmlns:a16="http://schemas.microsoft.com/office/drawing/2014/main" id="{049FD1A0-D12A-48D0-87C3-CBEB7B5E6CF5}"/>
+                <a16:creationId xmlns:a16="http://schemas.microsoft.com/office/drawing/2014/main" id="{2A3BD217-0FE7-41EC-9442-DE0E0A425560}"/>
               </a:ext>
             </a:extLst>
           </p:cNvPr>
@@ -13807,7 +15339,7 @@
           <p:cNvPr id="5" name="">
             <a:extLst xmlns:a="http://schemas.openxmlformats.org/drawingml/2006/main">
               <a:ext uri="{FF2B5EF4-FFF2-40B4-BE49-F238E27FC236}">
-                <a16:creationId xmlns:a16="http://schemas.microsoft.com/office/drawing/2014/main" id="{5F4C7A26-EC2F-4D37-B5C5-A2B7709EE085}"/>
+                <a16:creationId xmlns:a16="http://schemas.microsoft.com/office/drawing/2014/main" id="{91261904-99B6-4EAE-B169-7BE05890C158}"/>
               </a:ext>
             </a:extLst>
           </p:cNvPr>
@@ -13857,7 +15389,7 @@
           <p:cNvPr id="6" name="">
             <a:extLst xmlns:a="http://schemas.openxmlformats.org/drawingml/2006/main">
               <a:ext uri="{FF2B5EF4-FFF2-40B4-BE49-F238E27FC236}">
-                <a16:creationId xmlns:a16="http://schemas.microsoft.com/office/drawing/2014/main" id="{64938693-F727-46FD-AD3C-D651F10D0E47}"/>
+                <a16:creationId xmlns:a16="http://schemas.microsoft.com/office/drawing/2014/main" id="{96A58C54-69B9-4DA0-A64F-F64BC87CD82A}"/>
               </a:ext>
             </a:extLst>
           </p:cNvPr>
@@ -13892,7 +15424,7 @@
           <p:cNvPr id="7" name="">
             <a:extLst xmlns:a="http://schemas.openxmlformats.org/drawingml/2006/main">
               <a:ext uri="{FF2B5EF4-FFF2-40B4-BE49-F238E27FC236}">
-                <a16:creationId xmlns:a16="http://schemas.microsoft.com/office/drawing/2014/main" id="{998FCFD8-556D-4E08-8D86-35BA934E6289}"/>
+                <a16:creationId xmlns:a16="http://schemas.microsoft.com/office/drawing/2014/main" id="{97852FF0-011A-44FB-8072-8DD3BFB1A5A4}"/>
               </a:ext>
             </a:extLst>
           </p:cNvPr>
@@ -13942,7 +15474,7 @@
           <p:cNvPr id="8" name="">
             <a:extLst xmlns:a="http://schemas.openxmlformats.org/drawingml/2006/main">
               <a:ext uri="{FF2B5EF4-FFF2-40B4-BE49-F238E27FC236}">
-                <a16:creationId xmlns:a16="http://schemas.microsoft.com/office/drawing/2014/main" id="{DD5BB5EA-9535-4207-B970-A3E934272F49}"/>
+                <a16:creationId xmlns:a16="http://schemas.microsoft.com/office/drawing/2014/main" id="{DFFB6F39-E789-4FD2-8883-DF4758F66C90}"/>
               </a:ext>
             </a:extLst>
           </p:cNvPr>
@@ -13992,7 +15524,7 @@
           <p:cNvPr id="9" name="">
             <a:extLst xmlns:a="http://schemas.openxmlformats.org/drawingml/2006/main">
               <a:ext uri="{FF2B5EF4-FFF2-40B4-BE49-F238E27FC236}">
-                <a16:creationId xmlns:a16="http://schemas.microsoft.com/office/drawing/2014/main" id="{D00790E2-6490-4E7A-99A1-1DBF25136989}"/>
+                <a16:creationId xmlns:a16="http://schemas.microsoft.com/office/drawing/2014/main" id="{A5AD24B3-AAAA-4E3B-9C05-1BA17103D759}"/>
               </a:ext>
             </a:extLst>
           </p:cNvPr>
@@ -14027,7 +15559,7 @@
           <p:cNvPr id="10" name="">
             <a:extLst xmlns:a="http://schemas.openxmlformats.org/drawingml/2006/main">
               <a:ext uri="{FF2B5EF4-FFF2-40B4-BE49-F238E27FC236}">
-                <a16:creationId xmlns:a16="http://schemas.microsoft.com/office/drawing/2014/main" id="{4B669DB2-754F-4FCA-AAF8-339ABDA04AE4}"/>
+                <a16:creationId xmlns:a16="http://schemas.microsoft.com/office/drawing/2014/main" id="{95C5BD94-A774-42C4-BE5D-93AC05D8C92F}"/>
               </a:ext>
             </a:extLst>
           </p:cNvPr>
@@ -14077,7 +15609,7 @@
           <p:cNvPr id="11" name="">
             <a:extLst xmlns:a="http://schemas.openxmlformats.org/drawingml/2006/main">
               <a:ext uri="{FF2B5EF4-FFF2-40B4-BE49-F238E27FC236}">
-                <a16:creationId xmlns:a16="http://schemas.microsoft.com/office/drawing/2014/main" id="{E957C999-83DE-44A5-AEFD-F5874B600FC2}"/>
+                <a16:creationId xmlns:a16="http://schemas.microsoft.com/office/drawing/2014/main" id="{E38530BF-11A5-4B65-A9E6-0B1CD07276E0}"/>
               </a:ext>
             </a:extLst>
           </p:cNvPr>
@@ -14127,7 +15659,7 @@
           <p:cNvPr id="12" name="">
             <a:extLst xmlns:a="http://schemas.openxmlformats.org/drawingml/2006/main">
               <a:ext uri="{FF2B5EF4-FFF2-40B4-BE49-F238E27FC236}">
-                <a16:creationId xmlns:a16="http://schemas.microsoft.com/office/drawing/2014/main" id="{DFD09A04-A4B2-47B0-AF8E-996FB2E342D4}"/>
+                <a16:creationId xmlns:a16="http://schemas.microsoft.com/office/drawing/2014/main" id="{9D46090C-D13C-4453-8C52-2A9563BD93A9}"/>
               </a:ext>
             </a:extLst>
           </p:cNvPr>
@@ -14162,7 +15694,7 @@
           <p:cNvPr id="13" name="">
             <a:extLst xmlns:a="http://schemas.openxmlformats.org/drawingml/2006/main">
               <a:ext uri="{FF2B5EF4-FFF2-40B4-BE49-F238E27FC236}">
-                <a16:creationId xmlns:a16="http://schemas.microsoft.com/office/drawing/2014/main" id="{DBB0A91F-DB1A-496A-AFFC-F5B4DB7C10E6}"/>
+                <a16:creationId xmlns:a16="http://schemas.microsoft.com/office/drawing/2014/main" id="{D10C000B-96B0-48D0-9663-CDC12DC5914E}"/>
               </a:ext>
             </a:extLst>
           </p:cNvPr>
@@ -14212,7 +15744,7 @@
           <p:cNvPr id="14" name="">
             <a:extLst xmlns:a="http://schemas.openxmlformats.org/drawingml/2006/main">
               <a:ext uri="{FF2B5EF4-FFF2-40B4-BE49-F238E27FC236}">
-                <a16:creationId xmlns:a16="http://schemas.microsoft.com/office/drawing/2014/main" id="{20C2810D-83E1-41FE-B59C-BDC5E9D5533B}"/>
+                <a16:creationId xmlns:a16="http://schemas.microsoft.com/office/drawing/2014/main" id="{0FDC1118-2A1D-466A-B329-19FA364C3B58}"/>
               </a:ext>
             </a:extLst>
           </p:cNvPr>
@@ -14262,7 +15794,7 @@
           <p:cNvPr id="15" name="">
             <a:extLst xmlns:a="http://schemas.openxmlformats.org/drawingml/2006/main">
               <a:ext uri="{FF2B5EF4-FFF2-40B4-BE49-F238E27FC236}">
-                <a16:creationId xmlns:a16="http://schemas.microsoft.com/office/drawing/2014/main" id="{BE8DFBF6-DA84-4846-A88C-8D9E4FEB2178}"/>
+                <a16:creationId xmlns:a16="http://schemas.microsoft.com/office/drawing/2014/main" id="{8D5AAE64-9391-438C-A966-B9275652EC63}"/>
               </a:ext>
             </a:extLst>
           </p:cNvPr>
@@ -14297,7 +15829,7 @@
           <p:cNvPr id="16" name="">
             <a:extLst xmlns:a="http://schemas.openxmlformats.org/drawingml/2006/main">
               <a:ext uri="{FF2B5EF4-FFF2-40B4-BE49-F238E27FC236}">
-                <a16:creationId xmlns:a16="http://schemas.microsoft.com/office/drawing/2014/main" id="{E2661FAF-6EDA-462E-9E9D-2E4C80040292}"/>
+                <a16:creationId xmlns:a16="http://schemas.microsoft.com/office/drawing/2014/main" id="{47A1A4CF-A2AB-4A13-AEAE-BC4F2A5B36D2}"/>
               </a:ext>
             </a:extLst>
           </p:cNvPr>
@@ -14347,7 +15879,7 @@
           <p:cNvPr id="17" name="">
             <a:extLst xmlns:a="http://schemas.openxmlformats.org/drawingml/2006/main">
               <a:ext uri="{FF2B5EF4-FFF2-40B4-BE49-F238E27FC236}">
-                <a16:creationId xmlns:a16="http://schemas.microsoft.com/office/drawing/2014/main" id="{C31CB68E-5586-418F-A3AD-A35EFF4BE6AD}"/>
+                <a16:creationId xmlns:a16="http://schemas.microsoft.com/office/drawing/2014/main" id="{96DFF89B-39DE-46A0-AC39-CD4EE50F85D0}"/>
               </a:ext>
             </a:extLst>
           </p:cNvPr>
@@ -14397,7 +15929,7 @@
           <p:cNvPr id="18" name="">
             <a:extLst xmlns:a="http://schemas.openxmlformats.org/drawingml/2006/main">
               <a:ext uri="{FF2B5EF4-FFF2-40B4-BE49-F238E27FC236}">
-                <a16:creationId xmlns:a16="http://schemas.microsoft.com/office/drawing/2014/main" id="{75A4C633-9662-431B-9A03-509D49FF6589}"/>
+                <a16:creationId xmlns:a16="http://schemas.microsoft.com/office/drawing/2014/main" id="{5971B82E-28E7-40C3-BDA4-BC71D27017ED}"/>
               </a:ext>
             </a:extLst>
           </p:cNvPr>
@@ -14432,7 +15964,7 @@
           <p:cNvPr id="19" name="">
             <a:extLst xmlns:a="http://schemas.openxmlformats.org/drawingml/2006/main">
               <a:ext uri="{FF2B5EF4-FFF2-40B4-BE49-F238E27FC236}">
-                <a16:creationId xmlns:a16="http://schemas.microsoft.com/office/drawing/2014/main" id="{BFA9D90B-1FAA-4A7F-A1B9-FE19A825CF3F}"/>
+                <a16:creationId xmlns:a16="http://schemas.microsoft.com/office/drawing/2014/main" id="{7D9FC5DA-2CAD-4040-A324-411EFFBE90AF}"/>
               </a:ext>
             </a:extLst>
           </p:cNvPr>
@@ -14482,7 +16014,7 @@
           <p:cNvPr id="20" name="">
             <a:extLst xmlns:a="http://schemas.openxmlformats.org/drawingml/2006/main">
               <a:ext uri="{FF2B5EF4-FFF2-40B4-BE49-F238E27FC236}">
-                <a16:creationId xmlns:a16="http://schemas.microsoft.com/office/drawing/2014/main" id="{9A108297-C0FB-441A-98D1-E5D5FF19D394}"/>
+                <a16:creationId xmlns:a16="http://schemas.microsoft.com/office/drawing/2014/main" id="{93F95277-290E-45D1-8C61-B448A573A594}"/>
               </a:ext>
             </a:extLst>
           </p:cNvPr>
@@ -14532,7 +16064,7 @@
           <p:cNvPr id="21" name="">
             <a:extLst xmlns:a="http://schemas.openxmlformats.org/drawingml/2006/main">
               <a:ext uri="{FF2B5EF4-FFF2-40B4-BE49-F238E27FC236}">
-                <a16:creationId xmlns:a16="http://schemas.microsoft.com/office/drawing/2014/main" id="{B760E3CF-589E-4885-A57E-D871175FF2D3}"/>
+                <a16:creationId xmlns:a16="http://schemas.microsoft.com/office/drawing/2014/main" id="{91295E50-9E9C-4F9E-9F9F-71A5BD01FA89}"/>
               </a:ext>
             </a:extLst>
           </p:cNvPr>
@@ -14582,7 +16114,7 @@
           <p:cNvPr id="22" name="">
             <a:extLst xmlns:a="http://schemas.openxmlformats.org/drawingml/2006/main">
               <a:ext uri="{FF2B5EF4-FFF2-40B4-BE49-F238E27FC236}">
-                <a16:creationId xmlns:a16="http://schemas.microsoft.com/office/drawing/2014/main" id="{82BD3788-AD2A-4B52-AE8E-5D5A24FF264B}"/>
+                <a16:creationId xmlns:a16="http://schemas.microsoft.com/office/drawing/2014/main" id="{7FA41B43-BCB7-456C-B72C-9660D7CBEF50}"/>
               </a:ext>
             </a:extLst>
           </p:cNvPr>
@@ -14632,7 +16164,7 @@
           <p:cNvPr id="23" name="">
             <a:extLst xmlns:a="http://schemas.openxmlformats.org/drawingml/2006/main">
               <a:ext uri="{FF2B5EF4-FFF2-40B4-BE49-F238E27FC236}">
-                <a16:creationId xmlns:a16="http://schemas.microsoft.com/office/drawing/2014/main" id="{B70B991D-CA9F-4DA2-B4B1-CAB27FD4F200}"/>
+                <a16:creationId xmlns:a16="http://schemas.microsoft.com/office/drawing/2014/main" id="{895CA436-A866-47FF-8D88-D086719305A8}"/>
               </a:ext>
             </a:extLst>
           </p:cNvPr>
@@ -14680,7 +16212,7 @@
     </p:spTree>
     <p:extLst>
       <p:ext uri="{BB962C8B-B14F-4D97-AF65-F5344CB8AC3E}">
-        <p14:creationId xmlns:p14="http://schemas.microsoft.com/office/powerpoint/2010/main" val="560004862"/>
+        <p14:creationId xmlns:p14="http://schemas.microsoft.com/office/powerpoint/2010/main" val="324174371"/>
       </p:ext>
     </p:extLst>
   </p:cSld>
@@ -14711,7 +16243,7 @@
           <p:cNvPr id="18" name="">
             <a:extLst xmlns:a="http://schemas.openxmlformats.org/drawingml/2006/main">
               <a:ext uri="{FF2B5EF4-FFF2-40B4-BE49-F238E27FC236}">
-                <a16:creationId xmlns:a16="http://schemas.microsoft.com/office/drawing/2014/main" id="{72605F57-25BC-4EB7-9BEB-AB60F781B328}"/>
+                <a16:creationId xmlns:a16="http://schemas.microsoft.com/office/drawing/2014/main" id="{5BAB2820-52EB-405B-BAD4-20E9646269AB}"/>
               </a:ext>
             </a:extLst>
           </p:cNvPr>
@@ -14761,7 +16293,7 @@
           <p:cNvPr id="2" name="">
             <a:extLst xmlns:a="http://schemas.openxmlformats.org/drawingml/2006/main">
               <a:ext uri="{FF2B5EF4-FFF2-40B4-BE49-F238E27FC236}">
-                <a16:creationId xmlns:a16="http://schemas.microsoft.com/office/drawing/2014/main" id="{4B04384F-DAA6-4E25-8633-17515F5B6356}"/>
+                <a16:creationId xmlns:a16="http://schemas.microsoft.com/office/drawing/2014/main" id="{FBEC0B05-7158-49DE-837B-CA3630F7D83B}"/>
               </a:ext>
             </a:extLst>
           </p:cNvPr>
@@ -14811,7 +16343,7 @@
           <p:cNvPr id="3" name="">
             <a:extLst xmlns:a="http://schemas.openxmlformats.org/drawingml/2006/main">
               <a:ext uri="{FF2B5EF4-FFF2-40B4-BE49-F238E27FC236}">
-                <a16:creationId xmlns:a16="http://schemas.microsoft.com/office/drawing/2014/main" id="{29919EE3-A817-4454-9A0D-8CB07E5FBB29}"/>
+                <a16:creationId xmlns:a16="http://schemas.microsoft.com/office/drawing/2014/main" id="{9C0B766D-052B-44AF-9EFF-23D12CF3920C}"/>
               </a:ext>
             </a:extLst>
           </p:cNvPr>
@@ -14846,7 +16378,7 @@
           <p:cNvPr id="4" name="">
             <a:extLst xmlns:a="http://schemas.openxmlformats.org/drawingml/2006/main">
               <a:ext uri="{FF2B5EF4-FFF2-40B4-BE49-F238E27FC236}">
-                <a16:creationId xmlns:a16="http://schemas.microsoft.com/office/drawing/2014/main" id="{992B0177-E9FC-4FD5-A490-B48AA51F6EF1}"/>
+                <a16:creationId xmlns:a16="http://schemas.microsoft.com/office/drawing/2014/main" id="{506C210D-2B73-4B7B-8B23-F1AF528EF40B}"/>
               </a:ext>
             </a:extLst>
           </p:cNvPr>
@@ -14896,7 +16428,7 @@
           <p:cNvPr id="5" name="">
             <a:extLst xmlns:a="http://schemas.openxmlformats.org/drawingml/2006/main">
               <a:ext uri="{FF2B5EF4-FFF2-40B4-BE49-F238E27FC236}">
-                <a16:creationId xmlns:a16="http://schemas.microsoft.com/office/drawing/2014/main" id="{74F52E04-BB61-46D3-8731-4C16360D8764}"/>
+                <a16:creationId xmlns:a16="http://schemas.microsoft.com/office/drawing/2014/main" id="{B6F84FCB-2770-4762-B6A1-AF23A078FA6F}"/>
               </a:ext>
             </a:extLst>
           </p:cNvPr>
@@ -14963,7 +16495,7 @@
           <p:cNvPr id="6" name="">
             <a:extLst xmlns:a="http://schemas.openxmlformats.org/drawingml/2006/main">
               <a:ext uri="{FF2B5EF4-FFF2-40B4-BE49-F238E27FC236}">
-                <a16:creationId xmlns:a16="http://schemas.microsoft.com/office/drawing/2014/main" id="{81E89EFB-B8A0-4871-B13E-416942FC4CCF}"/>
+                <a16:creationId xmlns:a16="http://schemas.microsoft.com/office/drawing/2014/main" id="{B0892DC3-6DD9-42FE-8282-AB5AB193D845}"/>
               </a:ext>
             </a:extLst>
           </p:cNvPr>
@@ -14998,7 +16530,7 @@
           <p:cNvPr id="7" name="">
             <a:extLst xmlns:a="http://schemas.openxmlformats.org/drawingml/2006/main">
               <a:ext uri="{FF2B5EF4-FFF2-40B4-BE49-F238E27FC236}">
-                <a16:creationId xmlns:a16="http://schemas.microsoft.com/office/drawing/2014/main" id="{31FF4364-1F49-423B-95D9-CD85B29FDE49}"/>
+                <a16:creationId xmlns:a16="http://schemas.microsoft.com/office/drawing/2014/main" id="{79EB066D-6416-499F-85C8-7A8A2A477202}"/>
               </a:ext>
             </a:extLst>
           </p:cNvPr>
@@ -15048,7 +16580,7 @@
           <p:cNvPr id="8" name="">
             <a:extLst xmlns:a="http://schemas.openxmlformats.org/drawingml/2006/main">
               <a:ext uri="{FF2B5EF4-FFF2-40B4-BE49-F238E27FC236}">
-                <a16:creationId xmlns:a16="http://schemas.microsoft.com/office/drawing/2014/main" id="{262266CD-1C9A-4535-8764-ED0183A1412E}"/>
+                <a16:creationId xmlns:a16="http://schemas.microsoft.com/office/drawing/2014/main" id="{4C42C1A2-8CF6-47A6-B67A-30F2EFEC143C}"/>
               </a:ext>
             </a:extLst>
           </p:cNvPr>
@@ -15115,7 +16647,7 @@
           <p:cNvPr id="9" name="">
             <a:extLst xmlns:a="http://schemas.openxmlformats.org/drawingml/2006/main">
               <a:ext uri="{FF2B5EF4-FFF2-40B4-BE49-F238E27FC236}">
-                <a16:creationId xmlns:a16="http://schemas.microsoft.com/office/drawing/2014/main" id="{1CA9FA73-128E-4BA9-883F-6C100220C709}"/>
+                <a16:creationId xmlns:a16="http://schemas.microsoft.com/office/drawing/2014/main" id="{A24BD300-4EE9-4C13-95B2-3E387EC286BB}"/>
               </a:ext>
             </a:extLst>
           </p:cNvPr>
@@ -15150,7 +16682,7 @@
           <p:cNvPr id="10" name="">
             <a:extLst xmlns:a="http://schemas.openxmlformats.org/drawingml/2006/main">
               <a:ext uri="{FF2B5EF4-FFF2-40B4-BE49-F238E27FC236}">
-                <a16:creationId xmlns:a16="http://schemas.microsoft.com/office/drawing/2014/main" id="{2972DCAB-BDD6-4DD8-B4DD-C3478B690149}"/>
+                <a16:creationId xmlns:a16="http://schemas.microsoft.com/office/drawing/2014/main" id="{2D033FC1-46A2-4DF4-963D-76041B24231F}"/>
               </a:ext>
             </a:extLst>
           </p:cNvPr>
@@ -15200,7 +16732,7 @@
           <p:cNvPr id="11" name="">
             <a:extLst xmlns:a="http://schemas.openxmlformats.org/drawingml/2006/main">
               <a:ext uri="{FF2B5EF4-FFF2-40B4-BE49-F238E27FC236}">
-                <a16:creationId xmlns:a16="http://schemas.microsoft.com/office/drawing/2014/main" id="{36F5396F-8DC5-4982-BC31-4A9F98171256}"/>
+                <a16:creationId xmlns:a16="http://schemas.microsoft.com/office/drawing/2014/main" id="{A089A989-4FA1-411C-B096-5894D7479416}"/>
               </a:ext>
             </a:extLst>
           </p:cNvPr>
@@ -15267,7 +16799,7 @@
           <p:cNvPr id="12" name="">
             <a:extLst xmlns:a="http://schemas.openxmlformats.org/drawingml/2006/main">
               <a:ext uri="{FF2B5EF4-FFF2-40B4-BE49-F238E27FC236}">
-                <a16:creationId xmlns:a16="http://schemas.microsoft.com/office/drawing/2014/main" id="{2ABCA047-860C-4941-8A4A-C7380D9E6BA5}"/>
+                <a16:creationId xmlns:a16="http://schemas.microsoft.com/office/drawing/2014/main" id="{F09FC118-7F66-44B2-9DBE-3B2CF8D1DE8C}"/>
               </a:ext>
             </a:extLst>
           </p:cNvPr>
@@ -15300,7 +16832,7 @@
           <p:cNvPr id="13" name="">
             <a:extLst xmlns:a="http://schemas.openxmlformats.org/drawingml/2006/main">
               <a:ext uri="{FF2B5EF4-FFF2-40B4-BE49-F238E27FC236}">
-                <a16:creationId xmlns:a16="http://schemas.microsoft.com/office/drawing/2014/main" id="{17B93735-E1F6-43EF-8EEC-61D6F35CFECE}"/>
+                <a16:creationId xmlns:a16="http://schemas.microsoft.com/office/drawing/2014/main" id="{334FFEA2-2205-40E1-AFB7-76AC1E442AC8}"/>
               </a:ext>
             </a:extLst>
           </p:cNvPr>
@@ -15350,7 +16882,7 @@
           <p:cNvPr id="14" name="">
             <a:extLst xmlns:a="http://schemas.openxmlformats.org/drawingml/2006/main">
               <a:ext uri="{FF2B5EF4-FFF2-40B4-BE49-F238E27FC236}">
-                <a16:creationId xmlns:a16="http://schemas.microsoft.com/office/drawing/2014/main" id="{D3AB3228-F335-4864-9706-D4F352316267}"/>
+                <a16:creationId xmlns:a16="http://schemas.microsoft.com/office/drawing/2014/main" id="{C356D505-E783-41F6-96DE-9BF7C296B904}"/>
               </a:ext>
             </a:extLst>
           </p:cNvPr>
@@ -15383,7 +16915,7 @@
           <p:cNvPr id="15" name="">
             <a:extLst xmlns:a="http://schemas.openxmlformats.org/drawingml/2006/main">
               <a:ext uri="{FF2B5EF4-FFF2-40B4-BE49-F238E27FC236}">
-                <a16:creationId xmlns:a16="http://schemas.microsoft.com/office/drawing/2014/main" id="{352E499D-4050-4E92-B1CF-A509D75CADC8}"/>
+                <a16:creationId xmlns:a16="http://schemas.microsoft.com/office/drawing/2014/main" id="{22AA574D-1248-4F01-82E0-47B73FBF9B8F}"/>
               </a:ext>
             </a:extLst>
           </p:cNvPr>
@@ -15433,7 +16965,7 @@
           <p:cNvPr id="16" name="">
             <a:extLst xmlns:a="http://schemas.openxmlformats.org/drawingml/2006/main">
               <a:ext uri="{FF2B5EF4-FFF2-40B4-BE49-F238E27FC236}">
-                <a16:creationId xmlns:a16="http://schemas.microsoft.com/office/drawing/2014/main" id="{CD9DB776-D1E4-4D51-811F-39BCB3858C7A}"/>
+                <a16:creationId xmlns:a16="http://schemas.microsoft.com/office/drawing/2014/main" id="{8C9594F7-39AE-425D-BA42-60EF09378E30}"/>
               </a:ext>
             </a:extLst>
           </p:cNvPr>
@@ -15483,7 +17015,7 @@
           <p:cNvPr id="17" name="">
             <a:extLst xmlns:a="http://schemas.openxmlformats.org/drawingml/2006/main">
               <a:ext uri="{FF2B5EF4-FFF2-40B4-BE49-F238E27FC236}">
-                <a16:creationId xmlns:a16="http://schemas.microsoft.com/office/drawing/2014/main" id="{FF0C7DF1-CBAC-4E95-A63F-4C9D566FC0B9}"/>
+                <a16:creationId xmlns:a16="http://schemas.microsoft.com/office/drawing/2014/main" id="{7F6D96A0-A93D-47AB-BCE4-0B7200EB5A6C}"/>
               </a:ext>
             </a:extLst>
           </p:cNvPr>
@@ -15531,7 +17063,7 @@
     </p:spTree>
     <p:extLst>
       <p:ext uri="{BB962C8B-B14F-4D97-AF65-F5344CB8AC3E}">
-        <p14:creationId xmlns:p14="http://schemas.microsoft.com/office/powerpoint/2010/main" val="25900139"/>
+        <p14:creationId xmlns:p14="http://schemas.microsoft.com/office/powerpoint/2010/main" val="1242043863"/>
       </p:ext>
     </p:extLst>
   </p:cSld>
@@ -15562,7 +17094,7 @@
           <p:cNvPr id="30" name="">
             <a:extLst xmlns:a="http://schemas.openxmlformats.org/drawingml/2006/main">
               <a:ext uri="{FF2B5EF4-FFF2-40B4-BE49-F238E27FC236}">
-                <a16:creationId xmlns:a16="http://schemas.microsoft.com/office/drawing/2014/main" id="{34542D25-B90A-44D7-8FA9-5E9AF7F6BCA1}"/>
+                <a16:creationId xmlns:a16="http://schemas.microsoft.com/office/drawing/2014/main" id="{C120A1D1-1E77-4DF5-968C-78AF320A2F11}"/>
               </a:ext>
             </a:extLst>
           </p:cNvPr>
@@ -15612,7 +17144,7 @@
           <p:cNvPr id="2" name="">
             <a:extLst xmlns:a="http://schemas.openxmlformats.org/drawingml/2006/main">
               <a:ext uri="{FF2B5EF4-FFF2-40B4-BE49-F238E27FC236}">
-                <a16:creationId xmlns:a16="http://schemas.microsoft.com/office/drawing/2014/main" id="{C3B11FD7-680D-46D6-B828-C673254734F6}"/>
+                <a16:creationId xmlns:a16="http://schemas.microsoft.com/office/drawing/2014/main" id="{EC8067A5-CC47-4A5A-92D3-167B5970576A}"/>
               </a:ext>
             </a:extLst>
           </p:cNvPr>
@@ -15662,7 +17194,7 @@
           <p:cNvPr id="3" name="">
             <a:extLst xmlns:a="http://schemas.openxmlformats.org/drawingml/2006/main">
               <a:ext uri="{FF2B5EF4-FFF2-40B4-BE49-F238E27FC236}">
-                <a16:creationId xmlns:a16="http://schemas.microsoft.com/office/drawing/2014/main" id="{8DDD079E-9A74-4637-967A-92CD1EFBE43E}"/>
+                <a16:creationId xmlns:a16="http://schemas.microsoft.com/office/drawing/2014/main" id="{59A06972-6732-4575-8AF0-8212AD4D42EC}"/>
               </a:ext>
             </a:extLst>
           </p:cNvPr>
@@ -15695,7 +17227,7 @@
           <p:cNvPr id="4" name="">
             <a:extLst xmlns:a="http://schemas.openxmlformats.org/drawingml/2006/main">
               <a:ext uri="{FF2B5EF4-FFF2-40B4-BE49-F238E27FC236}">
-                <a16:creationId xmlns:a16="http://schemas.microsoft.com/office/drawing/2014/main" id="{D8D0A968-860C-4DF1-989C-91E3DD6A856B}"/>
+                <a16:creationId xmlns:a16="http://schemas.microsoft.com/office/drawing/2014/main" id="{9265127B-627C-43DF-AF79-3A533C75526C}"/>
               </a:ext>
             </a:extLst>
           </p:cNvPr>
@@ -15745,7 +17277,7 @@
           <p:cNvPr id="5" name="">
             <a:extLst xmlns:a="http://schemas.openxmlformats.org/drawingml/2006/main">
               <a:ext uri="{FF2B5EF4-FFF2-40B4-BE49-F238E27FC236}">
-                <a16:creationId xmlns:a16="http://schemas.microsoft.com/office/drawing/2014/main" id="{510AB8CF-D052-48E5-8A04-BB6E61032BA6}"/>
+                <a16:creationId xmlns:a16="http://schemas.microsoft.com/office/drawing/2014/main" id="{2A5C2F6C-4151-4CEE-AB12-BAC63B44A070}"/>
               </a:ext>
             </a:extLst>
           </p:cNvPr>
@@ -15776,7 +17308,7 @@
           <p:cNvPr id="6" name="">
             <a:extLst xmlns:a="http://schemas.openxmlformats.org/drawingml/2006/main">
               <a:ext uri="{FF2B5EF4-FFF2-40B4-BE49-F238E27FC236}">
-                <a16:creationId xmlns:a16="http://schemas.microsoft.com/office/drawing/2014/main" id="{C9766567-64AB-446B-B0A9-D7B87FA9BDE3}"/>
+                <a16:creationId xmlns:a16="http://schemas.microsoft.com/office/drawing/2014/main" id="{8B851C68-923F-4FCD-AF18-622DEB0C1A4E}"/>
               </a:ext>
             </a:extLst>
           </p:cNvPr>
@@ -15826,7 +17358,7 @@
           <p:cNvPr id="7" name="">
             <a:extLst xmlns:a="http://schemas.openxmlformats.org/drawingml/2006/main">
               <a:ext uri="{FF2B5EF4-FFF2-40B4-BE49-F238E27FC236}">
-                <a16:creationId xmlns:a16="http://schemas.microsoft.com/office/drawing/2014/main" id="{F31E8C6C-3A6E-40E9-BAF3-C4F0AEC6C9A9}"/>
+                <a16:creationId xmlns:a16="http://schemas.microsoft.com/office/drawing/2014/main" id="{B251C25F-DA18-4913-9C8F-2E1BA8082748}"/>
               </a:ext>
             </a:extLst>
           </p:cNvPr>
@@ -15876,7 +17408,7 @@
           <p:cNvPr id="8" name="">
             <a:extLst xmlns:a="http://schemas.openxmlformats.org/drawingml/2006/main">
               <a:ext uri="{FF2B5EF4-FFF2-40B4-BE49-F238E27FC236}">
-                <a16:creationId xmlns:a16="http://schemas.microsoft.com/office/drawing/2014/main" id="{1C2C5C16-6E7F-4AC8-89A3-7BB280F0D011}"/>
+                <a16:creationId xmlns:a16="http://schemas.microsoft.com/office/drawing/2014/main" id="{FA0C3F06-6D48-438F-91FA-038DDEF93D31}"/>
               </a:ext>
             </a:extLst>
           </p:cNvPr>
@@ -15909,7 +17441,7 @@
           <p:cNvPr id="9" name="">
             <a:extLst xmlns:a="http://schemas.openxmlformats.org/drawingml/2006/main">
               <a:ext uri="{FF2B5EF4-FFF2-40B4-BE49-F238E27FC236}">
-                <a16:creationId xmlns:a16="http://schemas.microsoft.com/office/drawing/2014/main" id="{FD4B0851-E487-47C5-B22B-DE3FE5E93E67}"/>
+                <a16:creationId xmlns:a16="http://schemas.microsoft.com/office/drawing/2014/main" id="{9C3EAE7B-A62B-4F2C-87D4-473091E77EBE}"/>
               </a:ext>
             </a:extLst>
           </p:cNvPr>
@@ -15959,7 +17491,7 @@
           <p:cNvPr id="10" name="">
             <a:extLst xmlns:a="http://schemas.openxmlformats.org/drawingml/2006/main">
               <a:ext uri="{FF2B5EF4-FFF2-40B4-BE49-F238E27FC236}">
-                <a16:creationId xmlns:a16="http://schemas.microsoft.com/office/drawing/2014/main" id="{56252885-D21F-4648-B66C-19BA28ED5824}"/>
+                <a16:creationId xmlns:a16="http://schemas.microsoft.com/office/drawing/2014/main" id="{A7DC222B-13FD-4995-A995-01A8630865C1}"/>
               </a:ext>
             </a:extLst>
           </p:cNvPr>
@@ -15990,7 +17522,7 @@
           <p:cNvPr id="11" name="">
             <a:extLst xmlns:a="http://schemas.openxmlformats.org/drawingml/2006/main">
               <a:ext uri="{FF2B5EF4-FFF2-40B4-BE49-F238E27FC236}">
-                <a16:creationId xmlns:a16="http://schemas.microsoft.com/office/drawing/2014/main" id="{4718B8BD-F200-45C6-9116-AD39FC40FE2F}"/>
+                <a16:creationId xmlns:a16="http://schemas.microsoft.com/office/drawing/2014/main" id="{346B1B9A-5609-4593-823B-EB1FC122E071}"/>
               </a:ext>
             </a:extLst>
           </p:cNvPr>
@@ -16040,7 +17572,7 @@
           <p:cNvPr id="12" name="">
             <a:extLst xmlns:a="http://schemas.openxmlformats.org/drawingml/2006/main">
               <a:ext uri="{FF2B5EF4-FFF2-40B4-BE49-F238E27FC236}">
-                <a16:creationId xmlns:a16="http://schemas.microsoft.com/office/drawing/2014/main" id="{27FC7B39-BB0A-41E3-99A5-21F07711165D}"/>
+                <a16:creationId xmlns:a16="http://schemas.microsoft.com/office/drawing/2014/main" id="{3C834CCE-6317-4955-AE81-99AFCF48BCF0}"/>
               </a:ext>
             </a:extLst>
           </p:cNvPr>
@@ -16090,7 +17622,7 @@
           <p:cNvPr id="13" name="">
             <a:extLst xmlns:a="http://schemas.openxmlformats.org/drawingml/2006/main">
               <a:ext uri="{FF2B5EF4-FFF2-40B4-BE49-F238E27FC236}">
-                <a16:creationId xmlns:a16="http://schemas.microsoft.com/office/drawing/2014/main" id="{D57C9059-0802-4700-B43E-DE0F0A4DF1A6}"/>
+                <a16:creationId xmlns:a16="http://schemas.microsoft.com/office/drawing/2014/main" id="{338C2D48-4ADD-46B3-9616-C2B26934458A}"/>
               </a:ext>
             </a:extLst>
           </p:cNvPr>
@@ -16123,7 +17655,7 @@
           <p:cNvPr id="14" name="">
             <a:extLst xmlns:a="http://schemas.openxmlformats.org/drawingml/2006/main">
               <a:ext uri="{FF2B5EF4-FFF2-40B4-BE49-F238E27FC236}">
-                <a16:creationId xmlns:a16="http://schemas.microsoft.com/office/drawing/2014/main" id="{1E8368F1-D167-42AA-B18C-32B419DC84B5}"/>
+                <a16:creationId xmlns:a16="http://schemas.microsoft.com/office/drawing/2014/main" id="{C276677D-437C-4834-B699-B7233A8FEEDA}"/>
               </a:ext>
             </a:extLst>
           </p:cNvPr>
@@ -16173,7 +17705,7 @@
           <p:cNvPr id="15" name="">
             <a:extLst xmlns:a="http://schemas.openxmlformats.org/drawingml/2006/main">
               <a:ext uri="{FF2B5EF4-FFF2-40B4-BE49-F238E27FC236}">
-                <a16:creationId xmlns:a16="http://schemas.microsoft.com/office/drawing/2014/main" id="{05DC7170-7A57-4BA6-AF43-099BE355CCE1}"/>
+                <a16:creationId xmlns:a16="http://schemas.microsoft.com/office/drawing/2014/main" id="{7583F664-271C-4CB6-9701-7E58E31DBF3C}"/>
               </a:ext>
             </a:extLst>
           </p:cNvPr>
@@ -16204,7 +17736,7 @@
           <p:cNvPr id="16" name="">
             <a:extLst xmlns:a="http://schemas.openxmlformats.org/drawingml/2006/main">
               <a:ext uri="{FF2B5EF4-FFF2-40B4-BE49-F238E27FC236}">
-                <a16:creationId xmlns:a16="http://schemas.microsoft.com/office/drawing/2014/main" id="{C9855F55-D96C-4BD0-A49E-C6B0860420A6}"/>
+                <a16:creationId xmlns:a16="http://schemas.microsoft.com/office/drawing/2014/main" id="{433A72B9-0D8D-4E4D-8141-EA93DB4B1194}"/>
               </a:ext>
             </a:extLst>
           </p:cNvPr>
@@ -16254,7 +17786,7 @@
           <p:cNvPr id="17" name="">
             <a:extLst xmlns:a="http://schemas.openxmlformats.org/drawingml/2006/main">
               <a:ext uri="{FF2B5EF4-FFF2-40B4-BE49-F238E27FC236}">
-                <a16:creationId xmlns:a16="http://schemas.microsoft.com/office/drawing/2014/main" id="{69B956AB-0272-43CE-8958-482CC296A39A}"/>
+                <a16:creationId xmlns:a16="http://schemas.microsoft.com/office/drawing/2014/main" id="{4A6903F3-D3FD-4E60-A08F-3F05E3C6AEBA}"/>
               </a:ext>
             </a:extLst>
           </p:cNvPr>
@@ -16304,7 +17836,7 @@
           <p:cNvPr id="18" name="">
             <a:extLst xmlns:a="http://schemas.openxmlformats.org/drawingml/2006/main">
               <a:ext uri="{FF2B5EF4-FFF2-40B4-BE49-F238E27FC236}">
-                <a16:creationId xmlns:a16="http://schemas.microsoft.com/office/drawing/2014/main" id="{80EA99B7-6BD9-4F8B-89A9-E0F89B6BF16D}"/>
+                <a16:creationId xmlns:a16="http://schemas.microsoft.com/office/drawing/2014/main" id="{478E2149-0805-49E9-955C-1C1B3B611C8C}"/>
               </a:ext>
             </a:extLst>
           </p:cNvPr>
@@ -16337,7 +17869,7 @@
           <p:cNvPr id="19" name="">
             <a:extLst xmlns:a="http://schemas.openxmlformats.org/drawingml/2006/main">
               <a:ext uri="{FF2B5EF4-FFF2-40B4-BE49-F238E27FC236}">
-                <a16:creationId xmlns:a16="http://schemas.microsoft.com/office/drawing/2014/main" id="{9DA5930D-45C0-4B9D-92BA-C8C1BB0AD522}"/>
+                <a16:creationId xmlns:a16="http://schemas.microsoft.com/office/drawing/2014/main" id="{DBE8A257-055B-4D87-8A11-15D7E65BF11A}"/>
               </a:ext>
             </a:extLst>
           </p:cNvPr>
@@ -16387,7 +17919,7 @@
           <p:cNvPr id="20" name="">
             <a:extLst xmlns:a="http://schemas.openxmlformats.org/drawingml/2006/main">
               <a:ext uri="{FF2B5EF4-FFF2-40B4-BE49-F238E27FC236}">
-                <a16:creationId xmlns:a16="http://schemas.microsoft.com/office/drawing/2014/main" id="{1D8CFBB8-F83F-4DEC-B26E-B772E335C190}"/>
+                <a16:creationId xmlns:a16="http://schemas.microsoft.com/office/drawing/2014/main" id="{D8098081-07DC-4C12-8FEF-5EC4EDA9EFC2}"/>
               </a:ext>
             </a:extLst>
           </p:cNvPr>
@@ -16418,7 +17950,7 @@
           <p:cNvPr id="21" name="">
             <a:extLst xmlns:a="http://schemas.openxmlformats.org/drawingml/2006/main">
               <a:ext uri="{FF2B5EF4-FFF2-40B4-BE49-F238E27FC236}">
-                <a16:creationId xmlns:a16="http://schemas.microsoft.com/office/drawing/2014/main" id="{F9271641-2C6B-49F1-8675-2B14DCB428E2}"/>
+                <a16:creationId xmlns:a16="http://schemas.microsoft.com/office/drawing/2014/main" id="{91D31E1B-1D26-4E84-B457-61E2EE05F15F}"/>
               </a:ext>
             </a:extLst>
           </p:cNvPr>
@@ -16468,7 +18000,7 @@
           <p:cNvPr id="22" name="">
             <a:extLst xmlns:a="http://schemas.openxmlformats.org/drawingml/2006/main">
               <a:ext uri="{FF2B5EF4-FFF2-40B4-BE49-F238E27FC236}">
-                <a16:creationId xmlns:a16="http://schemas.microsoft.com/office/drawing/2014/main" id="{9AD8A3F1-CD2B-44DC-B57C-41B964A7D8D6}"/>
+                <a16:creationId xmlns:a16="http://schemas.microsoft.com/office/drawing/2014/main" id="{9BAB8C7E-98B8-4ED1-8C5A-3D1A79FE4791}"/>
               </a:ext>
             </a:extLst>
           </p:cNvPr>
@@ -16518,7 +18050,7 @@
           <p:cNvPr id="23" name="">
             <a:extLst xmlns:a="http://schemas.openxmlformats.org/drawingml/2006/main">
               <a:ext uri="{FF2B5EF4-FFF2-40B4-BE49-F238E27FC236}">
-                <a16:creationId xmlns:a16="http://schemas.microsoft.com/office/drawing/2014/main" id="{1C2227C1-0E69-4F9E-8FDE-B3B99CEF3506}"/>
+                <a16:creationId xmlns:a16="http://schemas.microsoft.com/office/drawing/2014/main" id="{14E176A0-5A02-4CEF-968B-61F93F9F52DB}"/>
               </a:ext>
             </a:extLst>
           </p:cNvPr>
@@ -16551,7 +18083,7 @@
           <p:cNvPr id="24" name="">
             <a:extLst xmlns:a="http://schemas.openxmlformats.org/drawingml/2006/main">
               <a:ext uri="{FF2B5EF4-FFF2-40B4-BE49-F238E27FC236}">
-                <a16:creationId xmlns:a16="http://schemas.microsoft.com/office/drawing/2014/main" id="{9D5BF691-619B-4AA5-B0D5-CC8F5C4555E4}"/>
+                <a16:creationId xmlns:a16="http://schemas.microsoft.com/office/drawing/2014/main" id="{0C4B4D32-E7AD-4F90-91A1-A2FF05A0A7D8}"/>
               </a:ext>
             </a:extLst>
           </p:cNvPr>
@@ -16601,7 +18133,7 @@
           <p:cNvPr id="25" name="">
             <a:extLst xmlns:a="http://schemas.openxmlformats.org/drawingml/2006/main">
               <a:ext uri="{FF2B5EF4-FFF2-40B4-BE49-F238E27FC236}">
-                <a16:creationId xmlns:a16="http://schemas.microsoft.com/office/drawing/2014/main" id="{6627162A-1375-4FA9-B150-6F86617E3F4E}"/>
+                <a16:creationId xmlns:a16="http://schemas.microsoft.com/office/drawing/2014/main" id="{F9F5F07F-5D59-4361-8172-84FBB89D716C}"/>
               </a:ext>
             </a:extLst>
           </p:cNvPr>
@@ -16651,7 +18183,7 @@
           <p:cNvPr id="26" name="">
             <a:extLst xmlns:a="http://schemas.openxmlformats.org/drawingml/2006/main">
               <a:ext uri="{FF2B5EF4-FFF2-40B4-BE49-F238E27FC236}">
-                <a16:creationId xmlns:a16="http://schemas.microsoft.com/office/drawing/2014/main" id="{168B78A4-8423-4F50-A1B9-7C2C21675896}"/>
+                <a16:creationId xmlns:a16="http://schemas.microsoft.com/office/drawing/2014/main" id="{B38332FF-0578-4EC3-8AA2-55B7C72BFF27}"/>
               </a:ext>
             </a:extLst>
           </p:cNvPr>
@@ -16701,7 +18233,7 @@
           <p:cNvPr id="27" name="">
             <a:extLst xmlns:a="http://schemas.openxmlformats.org/drawingml/2006/main">
               <a:ext uri="{FF2B5EF4-FFF2-40B4-BE49-F238E27FC236}">
-                <a16:creationId xmlns:a16="http://schemas.microsoft.com/office/drawing/2014/main" id="{D5B3CD68-0DF1-4383-9EF9-8B65C861C2C6}"/>
+                <a16:creationId xmlns:a16="http://schemas.microsoft.com/office/drawing/2014/main" id="{F5FC8C20-0E98-43B9-AEF2-FBD5767FBE7C}"/>
               </a:ext>
             </a:extLst>
           </p:cNvPr>
@@ -16751,7 +18283,7 @@
           <p:cNvPr id="28" name="">
             <a:extLst xmlns:a="http://schemas.openxmlformats.org/drawingml/2006/main">
               <a:ext uri="{FF2B5EF4-FFF2-40B4-BE49-F238E27FC236}">
-                <a16:creationId xmlns:a16="http://schemas.microsoft.com/office/drawing/2014/main" id="{9B78F02A-E1F1-4705-B711-3DD96DB94993}"/>
+                <a16:creationId xmlns:a16="http://schemas.microsoft.com/office/drawing/2014/main" id="{5AF60478-3640-4868-B815-A8DA2E23605A}"/>
               </a:ext>
             </a:extLst>
           </p:cNvPr>
@@ -16801,7 +18333,7 @@
           <p:cNvPr id="29" name="">
             <a:extLst xmlns:a="http://schemas.openxmlformats.org/drawingml/2006/main">
               <a:ext uri="{FF2B5EF4-FFF2-40B4-BE49-F238E27FC236}">
-                <a16:creationId xmlns:a16="http://schemas.microsoft.com/office/drawing/2014/main" id="{E3FF8DB9-75B8-4047-B955-57A21AF19FE9}"/>
+                <a16:creationId xmlns:a16="http://schemas.microsoft.com/office/drawing/2014/main" id="{6019D0AF-30A7-483B-BF01-41950FE700CB}"/>
               </a:ext>
             </a:extLst>
           </p:cNvPr>
@@ -16849,7 +18381,7 @@
     </p:spTree>
     <p:extLst>
       <p:ext uri="{BB962C8B-B14F-4D97-AF65-F5344CB8AC3E}">
-        <p14:creationId xmlns:p14="http://schemas.microsoft.com/office/powerpoint/2010/main" val="175737173"/>
+        <p14:creationId xmlns:p14="http://schemas.microsoft.com/office/powerpoint/2010/main" val="935505116"/>
       </p:ext>
     </p:extLst>
   </p:cSld>

</xml_diff>